<commit_message>
Clarify why a bare Pod doesn't self-heal after apply
kubectl apply performs a one-time diff-and-patch, then exits — it does
not keep watching the YAML file or the object it created. Continuous
self-healing only happens when a controller (e.g. a ReplicaSet, via a
Deployment) is attached to watch the desired count. A bare Pod has no
such controller, which is why kubectl delete pod + kubectl get pods
shows it gone for good. Previous wording implied apply itself "keeps
the cluster matching," which contradicted the very next section.

Co-Authored-By: Claude Sonnet 5 <noreply@anthropic.com>
</commit_message>
<xml_diff>
--- a/docs/presentations/KubernetesFundamentals/KubernetesFundamentals.pptx
+++ b/docs/presentations/KubernetesFundamentals/KubernetesFundamentals.pptx
@@ -4,9 +4,6 @@
   <p:sldMasterIdLst>
     <p:sldMasterId id="2147483648" r:id="rId1"/>
   </p:sldMasterIdLst>
-  <p:notesMasterIdLst>
-    <p:notesMasterId r:id="rId24"/>
-  </p:notesMasterIdLst>
   <p:sldIdLst>
     <p:sldId id="256" r:id="rId2"/>
     <p:sldId id="257" r:id="rId3"/>
@@ -31,6 +28,9 @@
     <p:sldId id="276" r:id="rId22"/>
     <p:sldId id="277" r:id="rId23"/>
   </p:sldIdLst>
+  <p:notesMasterIdLst>
+    <p:notesMasterId r:id="rId24"/>
+  </p:notesMasterIdLst>
   <p:sldSz cx="12192000" cy="6858000"/>
   <p:notesSz cx="6858000" cy="12192000"/>
   <p:defaultTextStyle>
@@ -125,11 +125,6 @@
       </a:defRPr>
     </a:lvl9pPr>
   </p:defaultTextStyle>
-  <p:extLst>
-    <p:ext uri="{EFAFB233-063F-42B5-8137-9DF3F51BA10A}">
-      <p15:sldGuideLst xmlns:p15="http://schemas.microsoft.com/office/powerpoint/2012/main"/>
-    </p:ext>
-  </p:extLst>
 </p:presentation>
 </file>
 
@@ -155,10 +150,234 @@
           <a:chExt cx="0" cy="0"/>
         </a:xfrm>
       </p:grpSpPr>
+      <p:sp>
+        <p:nvSpPr>
+          <p:cNvPr id="2" name="Header Placeholder 1"/>
+          <p:cNvSpPr>
+            <a:spLocks noGrp="1"/>
+          </p:cNvSpPr>
+          <p:nvPr>
+            <p:ph type="hdr" sz="quarter"/>
+          </p:nvPr>
+        </p:nvSpPr>
+        <p:spPr>
+          <a:xfrm>
+            <a:off x="0" y="0"/>
+            <a:ext cx="2971800" cy="458788"/>
+          </a:xfrm>
+          <a:prstGeom prst="rect">
+            <a:avLst/>
+          </a:prstGeom>
+        </p:spPr>
+        <p:txBody>
+          <a:bodyPr vert="horz" lIns="91440" tIns="45720" rIns="91440" bIns="45720" rtlCol="0"/>
+          <a:lstStyle>
+            <a:lvl1pPr algn="l">
+              <a:defRPr sz="1200"/>
+            </a:lvl1pPr>
+          </a:lstStyle>
+          <a:p>
+            <a:endParaRPr lang="en-US"/>
+          </a:p>
+        </p:txBody>
+      </p:sp>
+      <p:sp>
+        <p:nvSpPr>
+          <p:cNvPr id="3" name="Date Placeholder 2"/>
+          <p:cNvSpPr>
+            <a:spLocks noGrp="1"/>
+          </p:cNvSpPr>
+          <p:nvPr>
+            <p:ph type="dt" idx="1"/>
+          </p:nvPr>
+        </p:nvSpPr>
+        <p:spPr>
+          <a:xfrm>
+            <a:off x="3884613" y="0"/>
+            <a:ext cx="2971800" cy="458788"/>
+          </a:xfrm>
+          <a:prstGeom prst="rect">
+            <a:avLst/>
+          </a:prstGeom>
+        </p:spPr>
+        <p:txBody>
+          <a:bodyPr vert="horz" lIns="91440" tIns="45720" rIns="91440" bIns="45720" rtlCol="0"/>
+          <a:lstStyle>
+            <a:lvl1pPr algn="r">
+              <a:defRPr sz="1200"/>
+            </a:lvl1pPr>
+          </a:lstStyle>
+          <a:p>
+            <a:fld id="{5282F153-3F37-0F45-9E97-73ACFA13230C}" type="datetimeFigureOut">
+              <a:rPr lang="en-US"/>
+              <a:t>7/23/19</a:t>
+            </a:fld>
+            <a:endParaRPr lang="en-US"/>
+          </a:p>
+        </p:txBody>
+      </p:sp>
+      <p:sp>
+        <p:nvSpPr>
+          <p:cNvPr id="4" name="Slide Image Placeholder 3"/>
+          <p:cNvSpPr>
+            <a:spLocks noGrp="1" noRot="1" noChangeAspect="1"/>
+          </p:cNvSpPr>
+          <p:nvPr>
+            <p:ph type="sldImg" idx="2"/>
+          </p:nvPr>
+        </p:nvSpPr>
+        <p:spPr>
+          <a:xfrm>
+            <a:off x="685800" y="1143000"/>
+            <a:ext cx="5486400" cy="3086100"/>
+          </a:xfrm>
+          <a:prstGeom prst="rect">
+            <a:avLst/>
+          </a:prstGeom>
+          <a:noFill/>
+          <a:ln w="12700">
+            <a:solidFill>
+              <a:prstClr val="black"/>
+            </a:solidFill>
+          </a:ln>
+        </p:spPr>
+        <p:txBody>
+          <a:bodyPr vert="horz" lIns="91440" tIns="45720" rIns="91440" bIns="45720" rtlCol="0" anchor="ctr"/>
+          <a:lstStyle/>
+          <a:p>
+            <a:endParaRPr lang="en-US"/>
+          </a:p>
+        </p:txBody>
+      </p:sp>
+      <p:sp>
+        <p:nvSpPr>
+          <p:cNvPr id="5" name="Notes Placeholder 4"/>
+          <p:cNvSpPr>
+            <a:spLocks noGrp="1"/>
+          </p:cNvSpPr>
+          <p:nvPr>
+            <p:ph type="body" sz="quarter" idx="3"/>
+          </p:nvPr>
+        </p:nvSpPr>
+        <p:spPr>
+          <a:xfrm>
+            <a:off x="685800" y="4400550"/>
+            <a:ext cx="5486400" cy="3600450"/>
+          </a:xfrm>
+          <a:prstGeom prst="rect">
+            <a:avLst/>
+          </a:prstGeom>
+        </p:spPr>
+        <p:txBody>
+          <a:bodyPr vert="horz" lIns="91440" tIns="45720" rIns="91440" bIns="45720" rtlCol="0"/>
+          <a:lstStyle/>
+          <a:p>
+            <a:pPr lvl="0"/>
+            <a:r>
+              <a:rPr lang="en-US"/>
+              <a:t>Click to edit Master text styles</a:t>
+            </a:r>
+          </a:p>
+          <a:p>
+            <a:pPr lvl="1"/>
+            <a:r>
+              <a:rPr lang="en-US"/>
+              <a:t>Second level</a:t>
+            </a:r>
+          </a:p>
+          <a:p>
+            <a:pPr lvl="2"/>
+            <a:r>
+              <a:rPr lang="en-US"/>
+              <a:t>Third level</a:t>
+            </a:r>
+          </a:p>
+          <a:p>
+            <a:pPr lvl="3"/>
+            <a:r>
+              <a:rPr lang="en-US"/>
+              <a:t>Fourth level</a:t>
+            </a:r>
+          </a:p>
+          <a:p>
+            <a:pPr lvl="4"/>
+            <a:r>
+              <a:rPr lang="en-US"/>
+              <a:t>Fifth level</a:t>
+            </a:r>
+          </a:p>
+        </p:txBody>
+      </p:sp>
+      <p:sp>
+        <p:nvSpPr>
+          <p:cNvPr id="6" name="Footer Placeholder 5"/>
+          <p:cNvSpPr>
+            <a:spLocks noGrp="1"/>
+          </p:cNvSpPr>
+          <p:nvPr>
+            <p:ph type="ftr" sz="quarter" idx="4"/>
+          </p:nvPr>
+        </p:nvSpPr>
+        <p:spPr>
+          <a:xfrm>
+            <a:off x="0" y="8685213"/>
+            <a:ext cx="2971800" cy="458787"/>
+          </a:xfrm>
+          <a:prstGeom prst="rect">
+            <a:avLst/>
+          </a:prstGeom>
+        </p:spPr>
+        <p:txBody>
+          <a:bodyPr vert="horz" lIns="91440" tIns="45720" rIns="91440" bIns="45720" rtlCol="0" anchor="b"/>
+          <a:lstStyle>
+            <a:lvl1pPr algn="l">
+              <a:defRPr sz="1200"/>
+            </a:lvl1pPr>
+          </a:lstStyle>
+          <a:p>
+            <a:endParaRPr lang="en-US"/>
+          </a:p>
+        </p:txBody>
+      </p:sp>
+      <p:sp>
+        <p:nvSpPr>
+          <p:cNvPr id="7" name="Slide Number Placeholder 6"/>
+          <p:cNvSpPr>
+            <a:spLocks noGrp="1"/>
+          </p:cNvSpPr>
+          <p:nvPr>
+            <p:ph type="sldNum" sz="quarter" idx="5"/>
+          </p:nvPr>
+        </p:nvSpPr>
+        <p:spPr>
+          <a:xfrm>
+            <a:off x="3884613" y="8685213"/>
+            <a:ext cx="2971800" cy="458787"/>
+          </a:xfrm>
+          <a:prstGeom prst="rect">
+            <a:avLst/>
+          </a:prstGeom>
+        </p:spPr>
+        <p:txBody>
+          <a:bodyPr vert="horz" lIns="91440" tIns="45720" rIns="91440" bIns="45720" rtlCol="0" anchor="b"/>
+          <a:lstStyle>
+            <a:lvl1pPr algn="r">
+              <a:defRPr sz="1200"/>
+            </a:lvl1pPr>
+          </a:lstStyle>
+          <a:p>
+            <a:fld id="{CE5E9CC1-C706-0F49-92D6-E571CC5EEA8F}" type="slidenum">
+              <a:rPr lang="en-US"/>
+              <a:t>‹#›</a:t>
+            </a:fld>
+            <a:endParaRPr lang="en-US"/>
+          </a:p>
+        </p:txBody>
+      </p:sp>
     </p:spTree>
     <p:extLst>
       <p:ext uri="{BB962C8B-B14F-4D97-AF65-F5344CB8AC3E}">
-        <p14:creationId xmlns:p14="http://schemas.microsoft.com/office/powerpoint/2010/main" val="470938966"/>
+        <p14:creationId xmlns:p14="http://schemas.microsoft.com/office/powerpoint/2010/main" val="1024086991"/>
       </p:ext>
     </p:extLst>
   </p:cSld>
@@ -306,6 +525,7 @@
               <a:rPr lang="en-US" dirty="0"/>
               <a:t>Set the frame immediately: this is the concept deck to watch/read before opening TUTORIAL.md in this same repo, not a standalone reference. Ten to fifteen minutes to build the mental model before the first kubectl command. Companion to this repo's TUTORIAL.md — read/watch this first, then go hands-on. No prior Kubernetes knowledge assumed.</a:t>
             </a:r>
+            <a:endParaRPr lang="en-US" dirty="0"/>
           </a:p>
         </p:txBody>
       </p:sp>
@@ -393,6 +613,7 @@
               <a:rPr lang="en-US" dirty="0"/>
               <a:t>Walk each component's single job in order — API server first since everything else is described relative to it. Land on kubelet since it's the bridge to the worker-node side.</a:t>
             </a:r>
+            <a:endParaRPr lang="en-US" dirty="0"/>
           </a:p>
         </p:txBody>
       </p:sp>
@@ -480,6 +701,7 @@
               <a:rPr lang="en-US" dirty="0"/>
               <a:t>Trace one concrete request end to end so the component table on the previous slide stops being abstract. Call out the pod-before-container ordering explicitly — it's a detail worth remembering.</a:t>
             </a:r>
+            <a:endParaRPr lang="en-US" dirty="0"/>
           </a:p>
         </p:txBody>
       </p:sp>
@@ -567,6 +789,7 @@
               <a:rPr lang="en-US" dirty="0"/>
               <a:t>Third focus area — move from control-plane theory into the actual objects readers will type in Module 1 and Module 2.</a:t>
             </a:r>
+            <a:endParaRPr lang="en-US" dirty="0"/>
           </a:p>
         </p:txBody>
       </p:sp>
@@ -654,6 +877,7 @@
               <a:rPr lang="en-US" dirty="0"/>
               <a:t>This is the "aha" moment of the deck for a first-time reader: run the delete experiment and watch the Pod not come back. Frame it as a problem statement, not a dead end — Slide 14 is the fix.</a:t>
             </a:r>
+            <a:endParaRPr lang="en-US" dirty="0"/>
           </a:p>
         </p:txBody>
       </p:sp>
@@ -741,6 +965,7 @@
               <a:rPr lang="en-US" dirty="0"/>
               <a:t>Repeat the exact delete experiment from Slide 13, but this time on a Deployment-managed Pod — the contrast is the whole point. Tie the self-healing behavior explicitly back to Slide 8's reconciliation loop.</a:t>
             </a:r>
+            <a:endParaRPr lang="en-US" dirty="0"/>
           </a:p>
         </p:txBody>
       </p:sp>
@@ -828,6 +1053,7 @@
               <a:rPr lang="en-US" dirty="0"/>
               <a:t>Fourth and final focus area — the last two object types, then the capstone that wires everything together.</a:t>
             </a:r>
+            <a:endParaRPr lang="en-US" dirty="0"/>
           </a:p>
         </p:txBody>
       </p:sp>
@@ -915,6 +1141,7 @@
               <a:rPr lang="en-US" dirty="0"/>
               <a:t>Anchor this in the fact that the reader just watched a Pod's IP change in the previous section — a Service is the direct answer to that instability.</a:t>
             </a:r>
+            <a:endParaRPr lang="en-US" dirty="0"/>
           </a:p>
         </p:txBody>
       </p:sp>
@@ -1002,6 +1229,7 @@
               <a:rPr lang="en-US" dirty="0"/>
               <a:t>Keep this conceptual per the high-level depth — one short illustrative snippet, not a manifest walkthrough. The base64-is-not-encryption point is the one thing to land hard.</a:t>
             </a:r>
+            <a:endParaRPr lang="en-US" dirty="0"/>
           </a:p>
         </p:txBody>
       </p:sp>
@@ -1089,6 +1317,7 @@
               <a:rPr lang="en-US" dirty="0"/>
               <a:t>This is where all four focus areas visibly compose into TUTORIAL.md's Module 5. The DNS-name-per-Service detail and the deploy-order gotcha are the two things worth remembering here.</a:t>
             </a:r>
+            <a:endParaRPr lang="en-US" dirty="0"/>
           </a:p>
         </p:txBody>
       </p:sp>
@@ -1176,6 +1405,7 @@
               <a:rPr lang="en-US" dirty="0"/>
               <a:t>Frame this as "things that were harder than expected" for an onboarding audience — real failure modes pulled straight from the tutorial's own troubleshooting notes, not hypotheticals.</a:t>
             </a:r>
+            <a:endParaRPr lang="en-US" dirty="0"/>
           </a:p>
         </p:txBody>
       </p:sp>
@@ -1263,6 +1493,7 @@
               <a:rPr lang="en-US" dirty="0"/>
               <a:t>Open with the pain, not the architecture. This is the itch that motivated Kubernetes existing at all — no jargon yet, just "here's what breaks."</a:t>
             </a:r>
+            <a:endParaRPr lang="en-US" dirty="0"/>
           </a:p>
         </p:txBody>
       </p:sp>
@@ -1350,6 +1581,7 @@
               <a:rPr lang="en-US" dirty="0"/>
               <a:t>Land the single unifying idea before handing off to TUTORIAL.md — everything walked through today is one mechanism wearing different hats.</a:t>
             </a:r>
+            <a:endParaRPr lang="en-US" dirty="0"/>
           </a:p>
         </p:txBody>
       </p:sp>
@@ -1437,6 +1669,7 @@
               <a:rPr lang="en-US" dirty="0"/>
               <a:t>Explicit handoff — this is the deck's actual job, to end with the reader opening a terminal and starting Module 0 with the mental model already in place.</a:t>
             </a:r>
+            <a:endParaRPr lang="en-US" dirty="0"/>
           </a:p>
         </p:txBody>
       </p:sp>
@@ -1524,6 +1757,7 @@
               <a:rPr lang="en-US" dirty="0"/>
               <a:t>Three takeaways, no more — the last line is the one thing worth remembering walking into Module 1.</a:t>
             </a:r>
+            <a:endParaRPr lang="en-US" dirty="0"/>
           </a:p>
         </p:txBody>
       </p:sp>
@@ -1611,6 +1845,7 @@
               <a:rPr lang="en-US" dirty="0"/>
               <a:t>Transition from "why" to "how" — zoom out to the two kinds of machines before drilling into any one component.</a:t>
             </a:r>
+            <a:endParaRPr lang="en-US" dirty="0"/>
           </a:p>
         </p:txBody>
       </p:sp>
@@ -1698,6 +1933,7 @@
               <a:rPr lang="en-US" dirty="0"/>
               <a:t>Establish the two-tier model before naming any single component in depth. Emphasize that you never talk to a worker node directly — everything routes through the API server.</a:t>
             </a:r>
+            <a:endParaRPr lang="en-US" dirty="0"/>
           </a:p>
         </p:txBody>
       </p:sp>
@@ -1785,6 +2021,7 @@
               <a:rPr lang="en-US" dirty="0"/>
               <a:t>Orient the reader to exactly what they're about to install in TUTORIAL.md Module 0, and flag the one gotcha (containerd runtime flag) before they hit it themselves.</a:t>
             </a:r>
+            <a:endParaRPr lang="en-US" dirty="0"/>
           </a:p>
         </p:txBody>
       </p:sp>
@@ -1872,6 +2109,7 @@
               <a:rPr lang="en-US" dirty="0"/>
               <a:t>First of the four focus areas — go one level deeper on the motivation now that the architecture is in view.</a:t>
             </a:r>
+            <a:endParaRPr lang="en-US" dirty="0"/>
           </a:p>
         </p:txBody>
       </p:sp>
@@ -1959,6 +2197,7 @@
               <a:rPr lang="en-US" dirty="0"/>
               <a:t>Make each failure mode concrete with what Kubernetes actually does about it, not just the abstract label.</a:t>
             </a:r>
+            <a:endParaRPr lang="en-US" dirty="0"/>
           </a:p>
         </p:txBody>
       </p:sp>
@@ -2046,6 +2285,7 @@
               <a:rPr lang="en-US" dirty="0"/>
               <a:t>This is the single most important concept in the deck — everything downstream (self-healing, scaling) is this same idea running continuously. Spell out declarative vs. imperative explicitly for onboarding.</a:t>
             </a:r>
+            <a:endParaRPr lang="en-US" dirty="0"/>
           </a:p>
         </p:txBody>
       </p:sp>
@@ -2133,6 +2373,7 @@
               <a:rPr lang="en-US" dirty="0"/>
               <a:t>Second focus area — now open the door from Slide 4 and name every piece behind it.</a:t>
             </a:r>
+            <a:endParaRPr lang="en-US" dirty="0"/>
           </a:p>
         </p:txBody>
       </p:sp>
@@ -2205,11 +2446,6 @@
 <file path=ppt/slideMasters/slideMaster1.xml><?xml version="1.0" encoding="utf-8"?>
 <p:sldMaster xmlns:a="http://schemas.openxmlformats.org/drawingml/2006/main" xmlns:r="http://schemas.openxmlformats.org/officeDocument/2006/relationships" xmlns:p="http://schemas.openxmlformats.org/presentationml/2006/main">
   <p:cSld>
-    <p:bg>
-      <p:bgRef idx="1001">
-        <a:schemeClr val="bg1"/>
-      </p:bgRef>
-    </p:bg>
     <p:spTree>
       <p:nvGrpSpPr>
         <p:cNvPr id="1" name=""/>
@@ -2492,7 +2728,6 @@
         <a:solidFill>
           <a:srgbClr val="EAFCFF"/>
         </a:solidFill>
-        <a:effectLst/>
       </p:bgPr>
     </p:bg>
     <p:spTree>
@@ -2530,11 +2765,11 @@
           <a:bodyPr wrap="square" rtlCol="0" anchor="ctr"/>
           <a:lstStyle/>
           <a:p>
-            <a:pPr marL="0" indent="0" algn="ctr">
-              <a:buNone/>
-            </a:pPr>
-            <a:r>
-              <a:rPr lang="en-US" sz="6400" b="1" kern="0" spc="50" dirty="0">
+            <a:pPr algn="ctr" indent="0" marL="0">
+              <a:buNone/>
+            </a:pPr>
+            <a:r>
+              <a:rPr lang="en-US" sz="6400" b="1" spc="50" kern="0" dirty="0">
                 <a:solidFill>
                   <a:srgbClr val="0A1A1C"/>
                 </a:solidFill>
@@ -2569,7 +2804,7 @@
           <a:bodyPr wrap="square" rtlCol="0" anchor="ctr"/>
           <a:lstStyle/>
           <a:p>
-            <a:pPr marL="0" indent="0" algn="ctr">
+            <a:pPr algn="ctr" indent="0" marL="0">
               <a:buNone/>
             </a:pPr>
             <a:r>
@@ -2611,13 +2846,6 @@
             <a:prstDash val="solid"/>
           </a:ln>
         </p:spPr>
-        <p:txBody>
-          <a:bodyPr/>
-          <a:lstStyle/>
-          <a:p>
-            <a:endParaRPr lang="en-US"/>
-          </a:p>
-        </p:txBody>
       </p:sp>
       <p:sp>
         <p:nvSpPr>
@@ -2640,7 +2868,7 @@
           <a:bodyPr wrap="square" rtlCol="0" anchor="ctr"/>
           <a:lstStyle/>
           <a:p>
-            <a:pPr marL="0" indent="0" algn="ctr">
+            <a:pPr algn="ctr" indent="0" marL="0">
               <a:buNone/>
             </a:pPr>
             <a:r>
@@ -2679,11 +2907,11 @@
           <a:bodyPr wrap="square" rtlCol="0" anchor="ctr"/>
           <a:lstStyle/>
           <a:p>
-            <a:pPr marL="0" indent="0" algn="ctr">
-              <a:buNone/>
-            </a:pPr>
-            <a:r>
-              <a:rPr lang="en-US" sz="1400" kern="0" spc="50" dirty="0">
+            <a:pPr algn="ctr" indent="0" marL="0">
+              <a:buNone/>
+            </a:pPr>
+            <a:r>
+              <a:rPr lang="en-US" sz="1400" spc="50" kern="0" dirty="0">
                 <a:solidFill>
                   <a:srgbClr val="306878"/>
                 </a:solidFill>
@@ -2713,7 +2941,6 @@
         <a:solidFill>
           <a:srgbClr val="EAFCFF"/>
         </a:solidFill>
-        <a:effectLst/>
       </p:bgPr>
     </p:bg>
     <p:spTree>
@@ -2754,13 +2981,6 @@
             <a:prstDash val="solid"/>
           </a:ln>
         </p:spPr>
-        <p:txBody>
-          <a:bodyPr/>
-          <a:lstStyle/>
-          <a:p>
-            <a:endParaRPr lang="en-US"/>
-          </a:p>
-        </p:txBody>
       </p:sp>
       <p:sp>
         <p:nvSpPr>
@@ -2783,11 +3003,11 @@
           <a:bodyPr wrap="square" rtlCol="0" anchor="ctr"/>
           <a:lstStyle/>
           <a:p>
-            <a:pPr marL="0" indent="0" algn="ctr">
-              <a:buNone/>
-            </a:pPr>
-            <a:r>
-              <a:rPr lang="en-US" sz="1200" b="1" kern="0" spc="50" dirty="0">
+            <a:pPr algn="ctr" indent="0" marL="0">
+              <a:buNone/>
+            </a:pPr>
+            <a:r>
+              <a:rPr lang="en-US" sz="1200" b="1" spc="50" kern="0" dirty="0">
                 <a:solidFill>
                   <a:srgbClr val="FFFFFF"/>
                 </a:solidFill>
@@ -2822,11 +3042,11 @@
           <a:bodyPr wrap="square" rtlCol="0" anchor="ctr"/>
           <a:lstStyle/>
           <a:p>
-            <a:pPr marL="0" indent="0">
-              <a:buNone/>
-            </a:pPr>
-            <a:r>
-              <a:rPr lang="en-US" sz="3000" b="1" kern="0" spc="50" dirty="0">
+            <a:pPr indent="0" marL="0">
+              <a:buNone/>
+            </a:pPr>
+            <a:r>
+              <a:rPr lang="en-US" sz="3000" b="1" spc="50" kern="0" dirty="0">
                 <a:solidFill>
                   <a:srgbClr val="0A1A1C"/>
                 </a:solidFill>
@@ -2864,13 +3084,6 @@
             <a:prstDash val="solid"/>
           </a:ln>
         </p:spPr>
-        <p:txBody>
-          <a:bodyPr/>
-          <a:lstStyle/>
-          <a:p>
-            <a:endParaRPr lang="en-US"/>
-          </a:p>
-        </p:txBody>
       </p:sp>
       <p:sp>
         <p:nvSpPr>
@@ -2908,6 +3121,9 @@
               </a:rPr>
               <a:t>API server — </a:t>
             </a:r>
+            <a:pPr indent="0" marL="0">
+              <a:buNone/>
+            </a:pPr>
             <a:r>
               <a:rPr lang="en-US" sz="2000" dirty="0">
                 <a:solidFill>
@@ -2959,6 +3175,9 @@
               </a:rPr>
               <a:t>etcd — </a:t>
             </a:r>
+            <a:pPr indent="0" marL="0">
+              <a:buNone/>
+            </a:pPr>
             <a:r>
               <a:rPr lang="en-US" sz="2000" dirty="0">
                 <a:solidFill>
@@ -3010,6 +3229,9 @@
               </a:rPr>
               <a:t>Scheduler — </a:t>
             </a:r>
+            <a:pPr indent="0" marL="0">
+              <a:buNone/>
+            </a:pPr>
             <a:r>
               <a:rPr lang="en-US" sz="2000" dirty="0">
                 <a:solidFill>
@@ -3061,6 +3283,9 @@
               </a:rPr>
               <a:t>Controller manager — </a:t>
             </a:r>
+            <a:pPr indent="0" marL="0">
+              <a:buNone/>
+            </a:pPr>
             <a:r>
               <a:rPr lang="en-US" sz="2000" dirty="0">
                 <a:solidFill>
@@ -3112,6 +3337,9 @@
               </a:rPr>
               <a:t>kubelet — </a:t>
             </a:r>
+            <a:pPr indent="0" marL="0">
+              <a:buNone/>
+            </a:pPr>
             <a:r>
               <a:rPr lang="en-US" sz="2000" dirty="0">
                 <a:solidFill>
@@ -3143,7 +3371,6 @@
         <a:solidFill>
           <a:srgbClr val="EAFCFF"/>
         </a:solidFill>
-        <a:effectLst/>
       </p:bgPr>
     </p:bg>
     <p:spTree>
@@ -3184,13 +3411,6 @@
             <a:prstDash val="solid"/>
           </a:ln>
         </p:spPr>
-        <p:txBody>
-          <a:bodyPr/>
-          <a:lstStyle/>
-          <a:p>
-            <a:endParaRPr lang="en-US"/>
-          </a:p>
-        </p:txBody>
       </p:sp>
       <p:sp>
         <p:nvSpPr>
@@ -3213,11 +3433,11 @@
           <a:bodyPr wrap="square" rtlCol="0" anchor="ctr"/>
           <a:lstStyle/>
           <a:p>
-            <a:pPr marL="0" indent="0" algn="ctr">
-              <a:buNone/>
-            </a:pPr>
-            <a:r>
-              <a:rPr lang="en-US" sz="1200" b="1" kern="0" spc="50" dirty="0">
+            <a:pPr algn="ctr" indent="0" marL="0">
+              <a:buNone/>
+            </a:pPr>
+            <a:r>
+              <a:rPr lang="en-US" sz="1200" b="1" spc="50" kern="0" dirty="0">
                 <a:solidFill>
                   <a:srgbClr val="FFFFFF"/>
                 </a:solidFill>
@@ -3252,11 +3472,11 @@
           <a:bodyPr wrap="square" rtlCol="0" anchor="ctr"/>
           <a:lstStyle/>
           <a:p>
-            <a:pPr marL="0" indent="0">
-              <a:buNone/>
-            </a:pPr>
-            <a:r>
-              <a:rPr lang="en-US" sz="3000" b="1" kern="0" spc="50" dirty="0">
+            <a:pPr indent="0" marL="0">
+              <a:buNone/>
+            </a:pPr>
+            <a:r>
+              <a:rPr lang="en-US" sz="3000" b="1" spc="50" kern="0" dirty="0">
                 <a:solidFill>
                   <a:srgbClr val="0A1A1C"/>
                 </a:solidFill>
@@ -3294,13 +3514,6 @@
             <a:prstDash val="solid"/>
           </a:ln>
         </p:spPr>
-        <p:txBody>
-          <a:bodyPr/>
-          <a:lstStyle/>
-          <a:p>
-            <a:endParaRPr lang="en-US"/>
-          </a:p>
-        </p:txBody>
       </p:sp>
       <p:sp>
         <p:nvSpPr>
@@ -3328,13 +3541,6 @@
             <a:prstDash val="solid"/>
           </a:ln>
         </p:spPr>
-        <p:txBody>
-          <a:bodyPr/>
-          <a:lstStyle/>
-          <a:p>
-            <a:endParaRPr lang="en-US"/>
-          </a:p>
-        </p:txBody>
       </p:sp>
       <p:sp>
         <p:nvSpPr>
@@ -3357,7 +3563,7 @@
           <a:bodyPr wrap="square" rtlCol="0" anchor="ctr"/>
           <a:lstStyle/>
           <a:p>
-            <a:pPr marL="0" indent="0" algn="ctr">
+            <a:pPr algn="ctr" indent="0" marL="0">
               <a:buNone/>
             </a:pPr>
             <a:r>
@@ -3396,7 +3602,7 @@
           <a:bodyPr wrap="square" rtlCol="0" anchor="ctr"/>
           <a:lstStyle/>
           <a:p>
-            <a:pPr marL="0" indent="0" algn="ctr">
+            <a:pPr algn="ctr" indent="0" marL="0">
               <a:buNone/>
             </a:pPr>
             <a:r>
@@ -3440,13 +3646,6 @@
             <a:prstDash val="solid"/>
           </a:ln>
         </p:spPr>
-        <p:txBody>
-          <a:bodyPr/>
-          <a:lstStyle/>
-          <a:p>
-            <a:endParaRPr lang="en-US"/>
-          </a:p>
-        </p:txBody>
       </p:sp>
       <p:sp>
         <p:nvSpPr>
@@ -3469,7 +3668,7 @@
           <a:bodyPr wrap="square" rtlCol="0" anchor="ctr"/>
           <a:lstStyle/>
           <a:p>
-            <a:pPr marL="0" indent="0" algn="ctr">
+            <a:pPr algn="ctr" indent="0" marL="0">
               <a:buNone/>
             </a:pPr>
             <a:r>
@@ -3486,7 +3685,7 @@
             <a:endParaRPr lang="en-US" sz="1100" dirty="0"/>
           </a:p>
           <a:p>
-            <a:pPr marL="0" indent="0" algn="ctr">
+            <a:pPr algn="ctr" indent="0" marL="0">
               <a:buNone/>
             </a:pPr>
             <a:r>
@@ -3525,7 +3724,7 @@
           <a:bodyPr wrap="square" rtlCol="0" anchor="ctr"/>
           <a:lstStyle/>
           <a:p>
-            <a:pPr marL="0" indent="0" algn="ctr">
+            <a:pPr algn="ctr" indent="0" marL="0">
               <a:buNone/>
             </a:pPr>
             <a:r>
@@ -3569,13 +3768,6 @@
             <a:prstDash val="solid"/>
           </a:ln>
         </p:spPr>
-        <p:txBody>
-          <a:bodyPr/>
-          <a:lstStyle/>
-          <a:p>
-            <a:endParaRPr lang="en-US"/>
-          </a:p>
-        </p:txBody>
       </p:sp>
       <p:sp>
         <p:nvSpPr>
@@ -3598,7 +3790,7 @@
           <a:bodyPr wrap="square" rtlCol="0" anchor="ctr"/>
           <a:lstStyle/>
           <a:p>
-            <a:pPr marL="0" indent="0" algn="ctr">
+            <a:pPr algn="ctr" indent="0" marL="0">
               <a:buNone/>
             </a:pPr>
             <a:r>
@@ -3637,7 +3829,7 @@
           <a:bodyPr wrap="square" rtlCol="0" anchor="ctr"/>
           <a:lstStyle/>
           <a:p>
-            <a:pPr marL="0" indent="0" algn="ctr">
+            <a:pPr algn="ctr" indent="0" marL="0">
               <a:buNone/>
             </a:pPr>
             <a:r>
@@ -3681,13 +3873,6 @@
             <a:prstDash val="solid"/>
           </a:ln>
         </p:spPr>
-        <p:txBody>
-          <a:bodyPr/>
-          <a:lstStyle/>
-          <a:p>
-            <a:endParaRPr lang="en-US"/>
-          </a:p>
-        </p:txBody>
       </p:sp>
       <p:sp>
         <p:nvSpPr>
@@ -3710,7 +3895,7 @@
           <a:bodyPr wrap="square" rtlCol="0" anchor="ctr"/>
           <a:lstStyle/>
           <a:p>
-            <a:pPr marL="0" indent="0" algn="ctr">
+            <a:pPr algn="ctr" indent="0" marL="0">
               <a:buNone/>
             </a:pPr>
             <a:r>
@@ -3749,7 +3934,7 @@
           <a:bodyPr wrap="square" rtlCol="0" anchor="ctr"/>
           <a:lstStyle/>
           <a:p>
-            <a:pPr marL="0" indent="0" algn="ctr">
+            <a:pPr algn="ctr" indent="0" marL="0">
               <a:buNone/>
             </a:pPr>
             <a:r>
@@ -3793,13 +3978,6 @@
             <a:prstDash val="solid"/>
           </a:ln>
         </p:spPr>
-        <p:txBody>
-          <a:bodyPr/>
-          <a:lstStyle/>
-          <a:p>
-            <a:endParaRPr lang="en-US"/>
-          </a:p>
-        </p:txBody>
       </p:sp>
       <p:sp>
         <p:nvSpPr>
@@ -3822,7 +4000,7 @@
           <a:bodyPr wrap="square" rtlCol="0" anchor="ctr"/>
           <a:lstStyle/>
           <a:p>
-            <a:pPr marL="0" indent="0" algn="ctr">
+            <a:pPr algn="ctr" indent="0" marL="0">
               <a:buNone/>
             </a:pPr>
             <a:r>
@@ -3861,7 +4039,7 @@
           <a:bodyPr wrap="square" rtlCol="0" anchor="ctr"/>
           <a:lstStyle/>
           <a:p>
-            <a:pPr marL="0" indent="0" algn="ctr">
+            <a:pPr algn="ctr" indent="0" marL="0">
               <a:buNone/>
             </a:pPr>
             <a:r>
@@ -3905,13 +4083,6 @@
             <a:prstDash val="solid"/>
           </a:ln>
         </p:spPr>
-        <p:txBody>
-          <a:bodyPr/>
-          <a:lstStyle/>
-          <a:p>
-            <a:endParaRPr lang="en-US"/>
-          </a:p>
-        </p:txBody>
       </p:sp>
       <p:sp>
         <p:nvSpPr>
@@ -3934,7 +4105,7 @@
           <a:bodyPr wrap="square" rtlCol="0" anchor="ctr"/>
           <a:lstStyle/>
           <a:p>
-            <a:pPr marL="0" indent="0" algn="ctr">
+            <a:pPr algn="ctr" indent="0" marL="0">
               <a:buNone/>
             </a:pPr>
             <a:r>
@@ -3951,7 +4122,7 @@
             <a:endParaRPr lang="en-US" sz="1100" dirty="0"/>
           </a:p>
           <a:p>
-            <a:pPr marL="0" indent="0" algn="ctr">
+            <a:pPr algn="ctr" indent="0" marL="0">
               <a:buNone/>
             </a:pPr>
             <a:r>
@@ -4265,7 +4436,6 @@
         <a:solidFill>
           <a:srgbClr val="007A90"/>
         </a:solidFill>
-        <a:effectLst/>
       </p:bgPr>
     </p:bg>
     <p:spTree>
@@ -4306,13 +4476,6 @@
             <a:prstDash val="solid"/>
           </a:ln>
         </p:spPr>
-        <p:txBody>
-          <a:bodyPr/>
-          <a:lstStyle/>
-          <a:p>
-            <a:endParaRPr lang="en-US"/>
-          </a:p>
-        </p:txBody>
       </p:sp>
       <p:sp>
         <p:nvSpPr>
@@ -4335,11 +4498,11 @@
           <a:bodyPr wrap="square" rtlCol="0" anchor="ctr"/>
           <a:lstStyle/>
           <a:p>
-            <a:pPr marL="0" indent="0" algn="ctr">
-              <a:buNone/>
-            </a:pPr>
-            <a:r>
-              <a:rPr lang="en-US" sz="4800" b="1" kern="0" spc="50" dirty="0">
+            <a:pPr algn="ctr" indent="0" marL="0">
+              <a:buNone/>
+            </a:pPr>
+            <a:r>
+              <a:rPr lang="en-US" sz="4800" b="1" spc="50" kern="0" dirty="0">
                 <a:solidFill>
                   <a:srgbClr val="FFFFFF"/>
                 </a:solidFill>
@@ -4374,7 +4537,7 @@
           <a:bodyPr wrap="square" rtlCol="0" anchor="ctr"/>
           <a:lstStyle/>
           <a:p>
-            <a:pPr marL="0" indent="0" algn="ctr">
+            <a:pPr algn="ctr" indent="0" marL="0">
               <a:buNone/>
             </a:pPr>
             <a:r>
@@ -4410,7 +4573,6 @@
         <a:solidFill>
           <a:srgbClr val="EAFCFF"/>
         </a:solidFill>
-        <a:effectLst/>
       </p:bgPr>
     </p:bg>
     <p:spTree>
@@ -4451,13 +4613,6 @@
             <a:prstDash val="solid"/>
           </a:ln>
         </p:spPr>
-        <p:txBody>
-          <a:bodyPr/>
-          <a:lstStyle/>
-          <a:p>
-            <a:endParaRPr lang="en-US"/>
-          </a:p>
-        </p:txBody>
       </p:sp>
       <p:sp>
         <p:nvSpPr>
@@ -4480,11 +4635,11 @@
           <a:bodyPr wrap="square" rtlCol="0" anchor="ctr"/>
           <a:lstStyle/>
           <a:p>
-            <a:pPr marL="0" indent="0" algn="ctr">
-              <a:buNone/>
-            </a:pPr>
-            <a:r>
-              <a:rPr lang="en-US" sz="1200" b="1" kern="0" spc="50" dirty="0">
+            <a:pPr algn="ctr" indent="0" marL="0">
+              <a:buNone/>
+            </a:pPr>
+            <a:r>
+              <a:rPr lang="en-US" sz="1200" b="1" spc="50" kern="0" dirty="0">
                 <a:solidFill>
                   <a:srgbClr val="FFFFFF"/>
                 </a:solidFill>
@@ -4519,11 +4674,11 @@
           <a:bodyPr wrap="square" rtlCol="0" anchor="ctr"/>
           <a:lstStyle/>
           <a:p>
-            <a:pPr marL="0" indent="0">
-              <a:buNone/>
-            </a:pPr>
-            <a:r>
-              <a:rPr lang="en-US" sz="3000" b="1" kern="0" spc="50" dirty="0">
+            <a:pPr indent="0" marL="0">
+              <a:buNone/>
+            </a:pPr>
+            <a:r>
+              <a:rPr lang="en-US" sz="3000" b="1" spc="50" kern="0" dirty="0">
                 <a:solidFill>
                   <a:srgbClr val="0A1A1C"/>
                 </a:solidFill>
@@ -4561,13 +4716,6 @@
             <a:prstDash val="solid"/>
           </a:ln>
         </p:spPr>
-        <p:txBody>
-          <a:bodyPr/>
-          <a:lstStyle/>
-          <a:p>
-            <a:endParaRPr lang="en-US"/>
-          </a:p>
-        </p:txBody>
       </p:sp>
       <p:sp>
         <p:nvSpPr>
@@ -4577,8 +4725,8 @@
         </p:nvSpPr>
         <p:spPr>
           <a:xfrm>
-            <a:off x="686614" y="2814223"/>
-            <a:ext cx="5204564" cy="2626457"/>
+            <a:off x="457200" y="1572768"/>
+            <a:ext cx="5477256" cy="5010912"/>
           </a:xfrm>
           <a:prstGeom prst="rect">
             <a:avLst/>
@@ -4593,13 +4741,6 @@
             <a:prstDash val="solid"/>
           </a:ln>
         </p:spPr>
-        <p:txBody>
-          <a:bodyPr/>
-          <a:lstStyle/>
-          <a:p>
-            <a:endParaRPr lang="en-US"/>
-          </a:p>
-        </p:txBody>
       </p:sp>
       <p:sp>
         <p:nvSpPr>
@@ -4609,7 +4750,7 @@
         </p:nvSpPr>
         <p:spPr>
           <a:xfrm>
-            <a:off x="914807" y="3007899"/>
+            <a:off x="640080" y="1709928"/>
             <a:ext cx="5111496" cy="4736592"/>
           </a:xfrm>
           <a:prstGeom prst="rect">
@@ -4622,7 +4763,7 @@
           <a:bodyPr wrap="none" rtlCol="0" anchor="t"/>
           <a:lstStyle/>
           <a:p>
-            <a:pPr marL="0" indent="0">
+            <a:pPr indent="0" marL="0">
               <a:buNone/>
             </a:pPr>
             <a:r>
@@ -4639,7 +4780,7 @@
             <a:endParaRPr lang="en-US" sz="1400" dirty="0"/>
           </a:p>
           <a:p>
-            <a:pPr marL="0" indent="0">
+            <a:pPr indent="0" marL="0">
               <a:buNone/>
             </a:pPr>
             <a:r>
@@ -4656,7 +4797,7 @@
             <a:endParaRPr lang="en-US" sz="1400" dirty="0"/>
           </a:p>
           <a:p>
-            <a:pPr marL="0" indent="0">
+            <a:pPr indent="0" marL="0">
               <a:buNone/>
             </a:pPr>
             <a:r>
@@ -4673,7 +4814,7 @@
             <a:endParaRPr lang="en-US" sz="1400" dirty="0"/>
           </a:p>
           <a:p>
-            <a:pPr marL="0" indent="0">
+            <a:pPr indent="0" marL="0">
               <a:buNone/>
             </a:pPr>
             <a:r>
@@ -4690,7 +4831,7 @@
             <a:endParaRPr lang="en-US" sz="1400" dirty="0"/>
           </a:p>
           <a:p>
-            <a:pPr marL="0" indent="0">
+            <a:pPr indent="0" marL="0">
               <a:buNone/>
             </a:pPr>
             <a:r>
@@ -4707,7 +4848,7 @@
             <a:endParaRPr lang="en-US" sz="1400" dirty="0"/>
           </a:p>
           <a:p>
-            <a:pPr marL="0" indent="0">
+            <a:pPr indent="0" marL="0">
               <a:buNone/>
             </a:pPr>
             <a:r>
@@ -4724,7 +4865,7 @@
             <a:endParaRPr lang="en-US" sz="1400" dirty="0"/>
           </a:p>
           <a:p>
-            <a:pPr marL="0" indent="0">
+            <a:pPr indent="0" marL="0">
               <a:buNone/>
             </a:pPr>
             <a:r>
@@ -4741,7 +4882,7 @@
             <a:endParaRPr lang="en-US" sz="1400" dirty="0"/>
           </a:p>
           <a:p>
-            <a:pPr marL="0" indent="0">
+            <a:pPr indent="0" marL="0">
               <a:buNone/>
             </a:pPr>
             <a:r>
@@ -4758,7 +4899,7 @@
             <a:endParaRPr lang="en-US" sz="1400" dirty="0"/>
           </a:p>
           <a:p>
-            <a:pPr marL="0" indent="0">
+            <a:pPr indent="0" marL="0">
               <a:buNone/>
             </a:pPr>
             <a:r>
@@ -4775,7 +4916,7 @@
             <a:endParaRPr lang="en-US" sz="1400" dirty="0"/>
           </a:p>
           <a:p>
-            <a:pPr marL="0" indent="0">
+            <a:pPr indent="0" marL="0">
               <a:buNone/>
             </a:pPr>
             <a:r>
@@ -4987,7 +5128,7 @@
                 <a:ea typeface="Trebuchet MS" pitchFamily="34" charset="-122"/>
                 <a:cs typeface="Trebuchet MS" pitchFamily="34" charset="-120"/>
               </a:rPr>
-              <a:t>It does not come back — a bare Pod has no supervisor</a:t>
+              <a:t>It does not come back — apply already exited; the YAML file is now inert, no controller is watching this Pod</a:t>
             </a:r>
             <a:endParaRPr lang="en-US" sz="1600" dirty="0"/>
           </a:p>
@@ -5009,7 +5150,6 @@
         <a:solidFill>
           <a:srgbClr val="EAFCFF"/>
         </a:solidFill>
-        <a:effectLst/>
       </p:bgPr>
     </p:bg>
     <p:spTree>
@@ -5050,13 +5190,6 @@
             <a:prstDash val="solid"/>
           </a:ln>
         </p:spPr>
-        <p:txBody>
-          <a:bodyPr/>
-          <a:lstStyle/>
-          <a:p>
-            <a:endParaRPr lang="en-US"/>
-          </a:p>
-        </p:txBody>
       </p:sp>
       <p:sp>
         <p:nvSpPr>
@@ -5079,11 +5212,11 @@
           <a:bodyPr wrap="square" rtlCol="0" anchor="ctr"/>
           <a:lstStyle/>
           <a:p>
-            <a:pPr marL="0" indent="0" algn="ctr">
-              <a:buNone/>
-            </a:pPr>
-            <a:r>
-              <a:rPr lang="en-US" sz="1200" b="1" kern="0" spc="50" dirty="0">
+            <a:pPr algn="ctr" indent="0" marL="0">
+              <a:buNone/>
+            </a:pPr>
+            <a:r>
+              <a:rPr lang="en-US" sz="1200" b="1" spc="50" kern="0" dirty="0">
                 <a:solidFill>
                   <a:srgbClr val="FFFFFF"/>
                 </a:solidFill>
@@ -5118,11 +5251,11 @@
           <a:bodyPr wrap="square" rtlCol="0" anchor="ctr"/>
           <a:lstStyle/>
           <a:p>
-            <a:pPr marL="0" indent="0">
-              <a:buNone/>
-            </a:pPr>
-            <a:r>
-              <a:rPr lang="en-US" sz="3000" b="1" kern="0" spc="50" dirty="0">
+            <a:pPr indent="0" marL="0">
+              <a:buNone/>
+            </a:pPr>
+            <a:r>
+              <a:rPr lang="en-US" sz="3000" b="1" spc="50" kern="0" dirty="0">
                 <a:solidFill>
                   <a:srgbClr val="0A1A1C"/>
                 </a:solidFill>
@@ -5160,13 +5293,6 @@
             <a:prstDash val="solid"/>
           </a:ln>
         </p:spPr>
-        <p:txBody>
-          <a:bodyPr/>
-          <a:lstStyle/>
-          <a:p>
-            <a:endParaRPr lang="en-US"/>
-          </a:p>
-        </p:txBody>
       </p:sp>
       <p:sp>
         <p:nvSpPr>
@@ -5194,13 +5320,6 @@
             <a:prstDash val="solid"/>
           </a:ln>
         </p:spPr>
-        <p:txBody>
-          <a:bodyPr/>
-          <a:lstStyle/>
-          <a:p>
-            <a:endParaRPr lang="en-US"/>
-          </a:p>
-        </p:txBody>
       </p:sp>
       <p:sp>
         <p:nvSpPr>
@@ -5223,7 +5342,7 @@
           <a:bodyPr wrap="square" rtlCol="0" anchor="ctr"/>
           <a:lstStyle/>
           <a:p>
-            <a:pPr marL="0" indent="0" algn="ctr">
+            <a:pPr algn="ctr" indent="0" marL="0">
               <a:buNone/>
             </a:pPr>
             <a:r>
@@ -5262,7 +5381,7 @@
           <a:bodyPr wrap="square" rtlCol="0" anchor="ctr"/>
           <a:lstStyle/>
           <a:p>
-            <a:pPr marL="0" indent="0" algn="ctr">
+            <a:pPr algn="ctr" indent="0" marL="0">
               <a:buNone/>
             </a:pPr>
             <a:r>
@@ -5306,13 +5425,6 @@
             <a:prstDash val="solid"/>
           </a:ln>
         </p:spPr>
-        <p:txBody>
-          <a:bodyPr/>
-          <a:lstStyle/>
-          <a:p>
-            <a:endParaRPr lang="en-US"/>
-          </a:p>
-        </p:txBody>
       </p:sp>
       <p:sp>
         <p:nvSpPr>
@@ -5335,7 +5447,7 @@
           <a:bodyPr wrap="square" rtlCol="0" anchor="ctr"/>
           <a:lstStyle/>
           <a:p>
-            <a:pPr marL="0" indent="0" algn="ctr">
+            <a:pPr algn="ctr" indent="0" marL="0">
               <a:buNone/>
             </a:pPr>
             <a:r>
@@ -5374,7 +5486,7 @@
           <a:bodyPr wrap="square" rtlCol="0" anchor="ctr"/>
           <a:lstStyle/>
           <a:p>
-            <a:pPr marL="0" indent="0" algn="ctr">
+            <a:pPr algn="ctr" indent="0" marL="0">
               <a:buNone/>
             </a:pPr>
             <a:r>
@@ -5418,13 +5530,6 @@
             <a:prstDash val="solid"/>
           </a:ln>
         </p:spPr>
-        <p:txBody>
-          <a:bodyPr/>
-          <a:lstStyle/>
-          <a:p>
-            <a:endParaRPr lang="en-US"/>
-          </a:p>
-        </p:txBody>
       </p:sp>
       <p:sp>
         <p:nvSpPr>
@@ -5447,7 +5552,7 @@
           <a:bodyPr wrap="square" rtlCol="0" anchor="ctr"/>
           <a:lstStyle/>
           <a:p>
-            <a:pPr marL="0" indent="0" algn="ctr">
+            <a:pPr algn="ctr" indent="0" marL="0">
               <a:buNone/>
             </a:pPr>
             <a:r>
@@ -5489,13 +5594,6 @@
             <a:prstDash val="solid"/>
           </a:ln>
         </p:spPr>
-        <p:txBody>
-          <a:bodyPr/>
-          <a:lstStyle/>
-          <a:p>
-            <a:endParaRPr lang="en-US"/>
-          </a:p>
-        </p:txBody>
       </p:sp>
       <p:sp>
         <p:nvSpPr>
@@ -5518,7 +5616,7 @@
           <a:bodyPr wrap="none" rtlCol="0" anchor="t"/>
           <a:lstStyle/>
           <a:p>
-            <a:pPr marL="0" indent="0">
+            <a:pPr indent="0" marL="0">
               <a:buNone/>
             </a:pPr>
             <a:r>
@@ -5535,7 +5633,7 @@
             <a:endParaRPr lang="en-US" sz="1300" dirty="0"/>
           </a:p>
           <a:p>
-            <a:pPr marL="0" indent="0">
+            <a:pPr indent="0" marL="0">
               <a:buNone/>
             </a:pPr>
             <a:r>
@@ -5552,7 +5650,7 @@
             <a:endParaRPr lang="en-US" sz="1300" dirty="0"/>
           </a:p>
           <a:p>
-            <a:pPr marL="0" indent="0">
+            <a:pPr indent="0" marL="0">
               <a:buNone/>
             </a:pPr>
             <a:r>
@@ -5569,7 +5667,7 @@
             <a:endParaRPr lang="en-US" sz="1300" dirty="0"/>
           </a:p>
           <a:p>
-            <a:pPr marL="0" indent="0">
+            <a:pPr indent="0" marL="0">
               <a:buNone/>
             </a:pPr>
             <a:r>
@@ -5586,7 +5684,7 @@
             <a:endParaRPr lang="en-US" sz="1300" dirty="0"/>
           </a:p>
           <a:p>
-            <a:pPr marL="0" indent="0">
+            <a:pPr indent="0" marL="0">
               <a:buNone/>
             </a:pPr>
             <a:r>
@@ -5603,7 +5701,7 @@
             <a:endParaRPr lang="en-US" sz="1300" dirty="0"/>
           </a:p>
           <a:p>
-            <a:pPr marL="0" indent="0">
+            <a:pPr indent="0" marL="0">
               <a:buNone/>
             </a:pPr>
             <a:r>
@@ -5620,7 +5718,7 @@
             <a:endParaRPr lang="en-US" sz="1300" dirty="0"/>
           </a:p>
           <a:p>
-            <a:pPr marL="0" indent="0">
+            <a:pPr indent="0" marL="0">
               <a:buNone/>
             </a:pPr>
             <a:r>
@@ -5637,7 +5735,7 @@
             <a:endParaRPr lang="en-US" sz="1300" dirty="0"/>
           </a:p>
           <a:p>
-            <a:pPr marL="0" indent="0">
+            <a:pPr indent="0" marL="0">
               <a:buNone/>
             </a:pPr>
             <a:r>
@@ -5654,7 +5752,7 @@
             <a:endParaRPr lang="en-US" sz="1300" dirty="0"/>
           </a:p>
           <a:p>
-            <a:pPr marL="0" indent="0">
+            <a:pPr indent="0" marL="0">
               <a:buNone/>
             </a:pPr>
             <a:r>
@@ -5706,7 +5804,7 @@
                 <a:ea typeface="Trebuchet MS" pitchFamily="34" charset="-122"/>
                 <a:cs typeface="Trebuchet MS" pitchFamily="34" charset="-120"/>
               </a:rPr>
-              <a:t>Deployment doesn't run containers directly — it manages a ReplicaSet, which maintains a fixed Pod count</a:t>
+              <a:t>Deployment doesn't run containers directly — it manages a ReplicaSet, and the ReplicaSet IS a controller: a background process maintaining a fixed Pod count</a:t>
             </a:r>
             <a:endParaRPr lang="en-US" sz="1500" dirty="0"/>
           </a:p>
@@ -5746,7 +5844,7 @@
                 <a:ea typeface="Trebuchet MS" pitchFamily="34" charset="-122"/>
                 <a:cs typeface="Trebuchet MS" pitchFamily="34" charset="-120"/>
               </a:rPr>
-              <a:t>Delete one managed Pod: it disappears, a brand-new one (new random suffix) appears almost immediately, count never drops below desired</a:t>
+              <a:t>Delete one managed Pod: it disappears, a brand-new one (new random suffix) appears almost immediately — with no re-apply</a:t>
             </a:r>
             <a:endParaRPr lang="en-US" sz="1500" dirty="0"/>
           </a:p>
@@ -5786,7 +5884,7 @@
                 <a:ea typeface="Trebuchet MS" pitchFamily="34" charset="-122"/>
                 <a:cs typeface="Trebuchet MS" pitchFamily="34" charset="-120"/>
               </a:rPr>
-              <a:t>Same declarative reconciliation loop as Slide 8 — just running continuously instead of once</a:t>
+              <a:t>This is the controller piece from Slide 8 made concrete — a bare Pod (Slide 13) has no such process watching it</a:t>
             </a:r>
             <a:endParaRPr lang="en-US" sz="1500" dirty="0"/>
           </a:p>
@@ -5826,7 +5924,7 @@
                 <a:ea typeface="Trebuchet MS" pitchFamily="34" charset="-122"/>
                 <a:cs typeface="Trebuchet MS" pitchFamily="34" charset="-120"/>
               </a:rPr>
-              <a:t>kubectl scale --replicas=5 just changes what "desired" means; the same loop does the rest</a:t>
+              <a:t>kubectl scale --replicas=5 just changes what "desired" means; the same controller loop does the rest</a:t>
             </a:r>
             <a:endParaRPr lang="en-US" sz="1500" dirty="0"/>
           </a:p>
@@ -5848,7 +5946,6 @@
         <a:solidFill>
           <a:srgbClr val="007A90"/>
         </a:solidFill>
-        <a:effectLst/>
       </p:bgPr>
     </p:bg>
     <p:spTree>
@@ -5889,13 +5986,6 @@
             <a:prstDash val="solid"/>
           </a:ln>
         </p:spPr>
-        <p:txBody>
-          <a:bodyPr/>
-          <a:lstStyle/>
-          <a:p>
-            <a:endParaRPr lang="en-US"/>
-          </a:p>
-        </p:txBody>
       </p:sp>
       <p:sp>
         <p:nvSpPr>
@@ -5918,11 +6008,11 @@
           <a:bodyPr wrap="square" rtlCol="0" anchor="ctr"/>
           <a:lstStyle/>
           <a:p>
-            <a:pPr marL="0" indent="0" algn="ctr">
-              <a:buNone/>
-            </a:pPr>
-            <a:r>
-              <a:rPr lang="en-US" sz="4800" b="1" kern="0" spc="50" dirty="0">
+            <a:pPr algn="ctr" indent="0" marL="0">
+              <a:buNone/>
+            </a:pPr>
+            <a:r>
+              <a:rPr lang="en-US" sz="4800" b="1" spc="50" kern="0" dirty="0">
                 <a:solidFill>
                   <a:srgbClr val="FFFFFF"/>
                 </a:solidFill>
@@ -5957,7 +6047,7 @@
           <a:bodyPr wrap="square" rtlCol="0" anchor="ctr"/>
           <a:lstStyle/>
           <a:p>
-            <a:pPr marL="0" indent="0" algn="ctr">
+            <a:pPr algn="ctr" indent="0" marL="0">
               <a:buNone/>
             </a:pPr>
             <a:r>
@@ -5993,7 +6083,6 @@
         <a:solidFill>
           <a:srgbClr val="EAFCFF"/>
         </a:solidFill>
-        <a:effectLst/>
       </p:bgPr>
     </p:bg>
     <p:spTree>
@@ -6034,13 +6123,6 @@
             <a:prstDash val="solid"/>
           </a:ln>
         </p:spPr>
-        <p:txBody>
-          <a:bodyPr/>
-          <a:lstStyle/>
-          <a:p>
-            <a:endParaRPr lang="en-US"/>
-          </a:p>
-        </p:txBody>
       </p:sp>
       <p:sp>
         <p:nvSpPr>
@@ -6063,11 +6145,11 @@
           <a:bodyPr wrap="square" rtlCol="0" anchor="ctr"/>
           <a:lstStyle/>
           <a:p>
-            <a:pPr marL="0" indent="0" algn="ctr">
-              <a:buNone/>
-            </a:pPr>
-            <a:r>
-              <a:rPr lang="en-US" sz="1200" b="1" kern="0" spc="50" dirty="0">
+            <a:pPr algn="ctr" indent="0" marL="0">
+              <a:buNone/>
+            </a:pPr>
+            <a:r>
+              <a:rPr lang="en-US" sz="1200" b="1" spc="50" kern="0" dirty="0">
                 <a:solidFill>
                   <a:srgbClr val="FFFFFF"/>
                 </a:solidFill>
@@ -6102,11 +6184,11 @@
           <a:bodyPr wrap="square" rtlCol="0" anchor="ctr"/>
           <a:lstStyle/>
           <a:p>
-            <a:pPr marL="0" indent="0">
-              <a:buNone/>
-            </a:pPr>
-            <a:r>
-              <a:rPr lang="en-US" sz="3000" b="1" kern="0" spc="50" dirty="0">
+            <a:pPr indent="0" marL="0">
+              <a:buNone/>
+            </a:pPr>
+            <a:r>
+              <a:rPr lang="en-US" sz="3000" b="1" spc="50" kern="0" dirty="0">
                 <a:solidFill>
                   <a:srgbClr val="0A1A1C"/>
                 </a:solidFill>
@@ -6144,13 +6226,6 @@
             <a:prstDash val="solid"/>
           </a:ln>
         </p:spPr>
-        <p:txBody>
-          <a:bodyPr/>
-          <a:lstStyle/>
-          <a:p>
-            <a:endParaRPr lang="en-US"/>
-          </a:p>
-        </p:txBody>
       </p:sp>
       <p:sp>
         <p:nvSpPr>
@@ -6160,8 +6235,8 @@
         </p:nvSpPr>
         <p:spPr>
           <a:xfrm>
-            <a:off x="455676" y="3581880"/>
-            <a:ext cx="5638800" cy="992688"/>
+            <a:off x="457200" y="1572768"/>
+            <a:ext cx="5477256" cy="5010912"/>
           </a:xfrm>
           <a:prstGeom prst="rect">
             <a:avLst/>
@@ -6176,13 +6251,6 @@
             <a:prstDash val="solid"/>
           </a:ln>
         </p:spPr>
-        <p:txBody>
-          <a:bodyPr/>
-          <a:lstStyle/>
-          <a:p>
-            <a:endParaRPr lang="en-US"/>
-          </a:p>
-        </p:txBody>
       </p:sp>
       <p:sp>
         <p:nvSpPr>
@@ -6192,8 +6260,8 @@
         </p:nvSpPr>
         <p:spPr>
           <a:xfrm>
-            <a:off x="577448" y="3682464"/>
-            <a:ext cx="5936085" cy="4713168"/>
+            <a:off x="640080" y="1709928"/>
+            <a:ext cx="5111496" cy="4736592"/>
           </a:xfrm>
           <a:prstGeom prst="rect">
             <a:avLst/>
@@ -6205,11 +6273,11 @@
           <a:bodyPr wrap="none" rtlCol="0" anchor="t"/>
           <a:lstStyle/>
           <a:p>
-            <a:pPr marL="0" indent="0">
-              <a:buNone/>
-            </a:pPr>
-            <a:r>
-              <a:rPr lang="en-US" sz="1200" dirty="0">
+            <a:pPr indent="0" marL="0">
+              <a:buNone/>
+            </a:pPr>
+            <a:r>
+              <a:rPr lang="en-US" sz="1300" dirty="0">
                 <a:solidFill>
                   <a:srgbClr val="003848"/>
                 </a:solidFill>
@@ -6219,14 +6287,14 @@
               </a:rPr>
               <a:t>kubectl expose deployment hello-deploy \</a:t>
             </a:r>
-            <a:endParaRPr lang="en-US" sz="1200" dirty="0"/>
-          </a:p>
-          <a:p>
-            <a:pPr marL="0" indent="0">
-              <a:buNone/>
-            </a:pPr>
-            <a:r>
-              <a:rPr lang="en-US" sz="1200" dirty="0">
+            <a:endParaRPr lang="en-US" sz="1300" dirty="0"/>
+          </a:p>
+          <a:p>
+            <a:pPr indent="0" marL="0">
+              <a:buNone/>
+            </a:pPr>
+            <a:r>
+              <a:rPr lang="en-US" sz="1300" dirty="0">
                 <a:solidFill>
                   <a:srgbClr val="003848"/>
                 </a:solidFill>
@@ -6236,14 +6304,14 @@
               </a:rPr>
               <a:t>  --port=80 --target-port=80 --name=hello-service</a:t>
             </a:r>
-            <a:endParaRPr lang="en-US" sz="1200" dirty="0"/>
-          </a:p>
-          <a:p>
-            <a:pPr marL="0" indent="0">
-              <a:buNone/>
-            </a:pPr>
-            <a:r>
-              <a:rPr lang="en-US" sz="1200" dirty="0">
+            <a:endParaRPr lang="en-US" sz="1300" dirty="0"/>
+          </a:p>
+          <a:p>
+            <a:pPr indent="0" marL="0">
+              <a:buNone/>
+            </a:pPr>
+            <a:r>
+              <a:rPr lang="en-US" sz="1300" dirty="0">
                 <a:solidFill>
                   <a:srgbClr val="003848"/>
                 </a:solidFill>
@@ -6253,7 +6321,7 @@
               </a:rPr>
               <a:t># → TYPE: ClusterIP   CLUSTER-IP: 10.x.x.x (stays fixed)</a:t>
             </a:r>
-            <a:endParaRPr lang="en-US" sz="1200" dirty="0"/>
+            <a:endParaRPr lang="en-US" sz="1300" dirty="0"/>
           </a:p>
         </p:txBody>
       </p:sp>
@@ -6433,7 +6501,6 @@
         <a:solidFill>
           <a:srgbClr val="EAFCFF"/>
         </a:solidFill>
-        <a:effectLst/>
       </p:bgPr>
     </p:bg>
     <p:spTree>
@@ -6474,13 +6541,6 @@
             <a:prstDash val="solid"/>
           </a:ln>
         </p:spPr>
-        <p:txBody>
-          <a:bodyPr/>
-          <a:lstStyle/>
-          <a:p>
-            <a:endParaRPr lang="en-US"/>
-          </a:p>
-        </p:txBody>
       </p:sp>
       <p:sp>
         <p:nvSpPr>
@@ -6503,11 +6563,11 @@
           <a:bodyPr wrap="square" rtlCol="0" anchor="ctr"/>
           <a:lstStyle/>
           <a:p>
-            <a:pPr marL="0" indent="0" algn="ctr">
-              <a:buNone/>
-            </a:pPr>
-            <a:r>
-              <a:rPr lang="en-US" sz="1200" b="1" kern="0" spc="50" dirty="0">
+            <a:pPr algn="ctr" indent="0" marL="0">
+              <a:buNone/>
+            </a:pPr>
+            <a:r>
+              <a:rPr lang="en-US" sz="1200" b="1" spc="50" kern="0" dirty="0">
                 <a:solidFill>
                   <a:srgbClr val="FFFFFF"/>
                 </a:solidFill>
@@ -6542,11 +6602,11 @@
           <a:bodyPr wrap="square" rtlCol="0" anchor="ctr"/>
           <a:lstStyle/>
           <a:p>
-            <a:pPr marL="0" indent="0">
-              <a:buNone/>
-            </a:pPr>
-            <a:r>
-              <a:rPr lang="en-US" sz="3000" b="1" kern="0" spc="50" dirty="0">
+            <a:pPr indent="0" marL="0">
+              <a:buNone/>
+            </a:pPr>
+            <a:r>
+              <a:rPr lang="en-US" sz="3000" b="1" spc="50" kern="0" dirty="0">
                 <a:solidFill>
                   <a:srgbClr val="0A1A1C"/>
                 </a:solidFill>
@@ -6584,13 +6644,6 @@
             <a:prstDash val="solid"/>
           </a:ln>
         </p:spPr>
-        <p:txBody>
-          <a:bodyPr/>
-          <a:lstStyle/>
-          <a:p>
-            <a:endParaRPr lang="en-US"/>
-          </a:p>
-        </p:txBody>
       </p:sp>
       <p:sp>
         <p:nvSpPr>
@@ -6768,7 +6821,6 @@
         <a:solidFill>
           <a:srgbClr val="EAFCFF"/>
         </a:solidFill>
-        <a:effectLst/>
       </p:bgPr>
     </p:bg>
     <p:spTree>
@@ -6809,13 +6861,6 @@
             <a:prstDash val="solid"/>
           </a:ln>
         </p:spPr>
-        <p:txBody>
-          <a:bodyPr/>
-          <a:lstStyle/>
-          <a:p>
-            <a:endParaRPr lang="en-US"/>
-          </a:p>
-        </p:txBody>
       </p:sp>
       <p:sp>
         <p:nvSpPr>
@@ -6838,11 +6883,11 @@
           <a:bodyPr wrap="square" rtlCol="0" anchor="ctr"/>
           <a:lstStyle/>
           <a:p>
-            <a:pPr marL="0" indent="0" algn="ctr">
-              <a:buNone/>
-            </a:pPr>
-            <a:r>
-              <a:rPr lang="en-US" sz="1200" b="1" kern="0" spc="50" dirty="0">
+            <a:pPr algn="ctr" indent="0" marL="0">
+              <a:buNone/>
+            </a:pPr>
+            <a:r>
+              <a:rPr lang="en-US" sz="1200" b="1" spc="50" kern="0" dirty="0">
                 <a:solidFill>
                   <a:srgbClr val="FFFFFF"/>
                 </a:solidFill>
@@ -6877,11 +6922,11 @@
           <a:bodyPr wrap="square" rtlCol="0" anchor="ctr"/>
           <a:lstStyle/>
           <a:p>
-            <a:pPr marL="0" indent="0">
-              <a:buNone/>
-            </a:pPr>
-            <a:r>
-              <a:rPr lang="en-US" sz="3000" b="1" kern="0" spc="50" dirty="0">
+            <a:pPr indent="0" marL="0">
+              <a:buNone/>
+            </a:pPr>
+            <a:r>
+              <a:rPr lang="en-US" sz="3000" b="1" spc="50" kern="0" dirty="0">
                 <a:solidFill>
                   <a:srgbClr val="0A1A1C"/>
                 </a:solidFill>
@@ -6919,13 +6964,6 @@
             <a:prstDash val="solid"/>
           </a:ln>
         </p:spPr>
-        <p:txBody>
-          <a:bodyPr/>
-          <a:lstStyle/>
-          <a:p>
-            <a:endParaRPr lang="en-US"/>
-          </a:p>
-        </p:txBody>
       </p:sp>
       <p:sp>
         <p:nvSpPr>
@@ -6953,13 +6991,6 @@
             <a:prstDash val="solid"/>
           </a:ln>
         </p:spPr>
-        <p:txBody>
-          <a:bodyPr/>
-          <a:lstStyle/>
-          <a:p>
-            <a:endParaRPr lang="en-US"/>
-          </a:p>
-        </p:txBody>
       </p:sp>
       <p:sp>
         <p:nvSpPr>
@@ -6982,7 +7013,7 @@
           <a:bodyPr wrap="square" rtlCol="0" anchor="ctr"/>
           <a:lstStyle/>
           <a:p>
-            <a:pPr marL="0" indent="0" algn="ctr">
+            <a:pPr algn="ctr" indent="0" marL="0">
               <a:buNone/>
             </a:pPr>
             <a:r>
@@ -6999,7 +7030,7 @@
             <a:endParaRPr lang="en-US" sz="1100" dirty="0"/>
           </a:p>
           <a:p>
-            <a:pPr marL="0" indent="0" algn="ctr">
+            <a:pPr algn="ctr" indent="0" marL="0">
               <a:buNone/>
             </a:pPr>
             <a:r>
@@ -7038,7 +7069,7 @@
           <a:bodyPr wrap="square" rtlCol="0" anchor="ctr"/>
           <a:lstStyle/>
           <a:p>
-            <a:pPr marL="0" indent="0" algn="ctr">
+            <a:pPr algn="ctr" indent="0" marL="0">
               <a:buNone/>
             </a:pPr>
             <a:r>
@@ -7082,13 +7113,6 @@
             <a:prstDash val="solid"/>
           </a:ln>
         </p:spPr>
-        <p:txBody>
-          <a:bodyPr/>
-          <a:lstStyle/>
-          <a:p>
-            <a:endParaRPr lang="en-US"/>
-          </a:p>
-        </p:txBody>
       </p:sp>
       <p:sp>
         <p:nvSpPr>
@@ -7111,7 +7135,7 @@
           <a:bodyPr wrap="square" rtlCol="0" anchor="ctr"/>
           <a:lstStyle/>
           <a:p>
-            <a:pPr marL="0" indent="0" algn="ctr">
+            <a:pPr algn="ctr" indent="0" marL="0">
               <a:buNone/>
             </a:pPr>
             <a:r>
@@ -7128,7 +7152,7 @@
             <a:endParaRPr lang="en-US" sz="1100" dirty="0"/>
           </a:p>
           <a:p>
-            <a:pPr marL="0" indent="0" algn="ctr">
+            <a:pPr algn="ctr" indent="0" marL="0">
               <a:buNone/>
             </a:pPr>
             <a:r>
@@ -7167,7 +7191,7 @@
           <a:bodyPr wrap="square" rtlCol="0" anchor="ctr"/>
           <a:lstStyle/>
           <a:p>
-            <a:pPr marL="0" indent="0" algn="ctr">
+            <a:pPr algn="ctr" indent="0" marL="0">
               <a:buNone/>
             </a:pPr>
             <a:r>
@@ -7211,13 +7235,6 @@
             <a:prstDash val="solid"/>
           </a:ln>
         </p:spPr>
-        <p:txBody>
-          <a:bodyPr/>
-          <a:lstStyle/>
-          <a:p>
-            <a:endParaRPr lang="en-US"/>
-          </a:p>
-        </p:txBody>
       </p:sp>
       <p:sp>
         <p:nvSpPr>
@@ -7240,7 +7257,7 @@
           <a:bodyPr wrap="square" rtlCol="0" anchor="ctr"/>
           <a:lstStyle/>
           <a:p>
-            <a:pPr marL="0" indent="0" algn="ctr">
+            <a:pPr algn="ctr" indent="0" marL="0">
               <a:buNone/>
             </a:pPr>
             <a:r>
@@ -7257,7 +7274,7 @@
             <a:endParaRPr lang="en-US" sz="1100" dirty="0"/>
           </a:p>
           <a:p>
-            <a:pPr marL="0" indent="0" algn="ctr">
+            <a:pPr algn="ctr" indent="0" marL="0">
               <a:buNone/>
             </a:pPr>
             <a:r>
@@ -7296,7 +7313,7 @@
           <a:bodyPr wrap="square" rtlCol="0" anchor="ctr"/>
           <a:lstStyle/>
           <a:p>
-            <a:pPr marL="0" indent="0" algn="ctr">
+            <a:pPr algn="ctr" indent="0" marL="0">
               <a:buNone/>
             </a:pPr>
             <a:r>
@@ -7340,13 +7357,6 @@
             <a:prstDash val="solid"/>
           </a:ln>
         </p:spPr>
-        <p:txBody>
-          <a:bodyPr/>
-          <a:lstStyle/>
-          <a:p>
-            <a:endParaRPr lang="en-US"/>
-          </a:p>
-        </p:txBody>
       </p:sp>
       <p:sp>
         <p:nvSpPr>
@@ -7369,7 +7379,7 @@
           <a:bodyPr wrap="square" rtlCol="0" anchor="ctr"/>
           <a:lstStyle/>
           <a:p>
-            <a:pPr marL="0" indent="0" algn="ctr">
+            <a:pPr algn="ctr" indent="0" marL="0">
               <a:buNone/>
             </a:pPr>
             <a:r>
@@ -7386,7 +7396,7 @@
             <a:endParaRPr lang="en-US" sz="1100" dirty="0"/>
           </a:p>
           <a:p>
-            <a:pPr marL="0" indent="0" algn="ctr">
+            <a:pPr algn="ctr" indent="0" marL="0">
               <a:buNone/>
             </a:pPr>
             <a:r>
@@ -7425,7 +7435,7 @@
           <a:bodyPr wrap="square" rtlCol="0" anchor="ctr"/>
           <a:lstStyle/>
           <a:p>
-            <a:pPr marL="0" indent="0" algn="ctr">
+            <a:pPr algn="ctr" indent="0" marL="0">
               <a:buNone/>
             </a:pPr>
             <a:r>
@@ -7469,13 +7479,6 @@
             <a:prstDash val="solid"/>
           </a:ln>
         </p:spPr>
-        <p:txBody>
-          <a:bodyPr/>
-          <a:lstStyle/>
-          <a:p>
-            <a:endParaRPr lang="en-US"/>
-          </a:p>
-        </p:txBody>
       </p:sp>
       <p:sp>
         <p:nvSpPr>
@@ -7498,7 +7501,7 @@
           <a:bodyPr wrap="square" rtlCol="0" anchor="ctr"/>
           <a:lstStyle/>
           <a:p>
-            <a:pPr marL="0" indent="0" algn="ctr">
+            <a:pPr algn="ctr" indent="0" marL="0">
               <a:buNone/>
             </a:pPr>
             <a:r>
@@ -7692,7 +7695,6 @@
         <a:solidFill>
           <a:srgbClr val="EAFCFF"/>
         </a:solidFill>
-        <a:effectLst/>
       </p:bgPr>
     </p:bg>
     <p:spTree>
@@ -7733,13 +7735,6 @@
             <a:prstDash val="solid"/>
           </a:ln>
         </p:spPr>
-        <p:txBody>
-          <a:bodyPr/>
-          <a:lstStyle/>
-          <a:p>
-            <a:endParaRPr lang="en-US"/>
-          </a:p>
-        </p:txBody>
       </p:sp>
       <p:sp>
         <p:nvSpPr>
@@ -7762,11 +7757,11 @@
           <a:bodyPr wrap="square" rtlCol="0" anchor="ctr"/>
           <a:lstStyle/>
           <a:p>
-            <a:pPr marL="0" indent="0" algn="ctr">
-              <a:buNone/>
-            </a:pPr>
-            <a:r>
-              <a:rPr lang="en-US" sz="1200" b="1" kern="0" spc="50" dirty="0">
+            <a:pPr algn="ctr" indent="0" marL="0">
+              <a:buNone/>
+            </a:pPr>
+            <a:r>
+              <a:rPr lang="en-US" sz="1200" b="1" spc="50" kern="0" dirty="0">
                 <a:solidFill>
                   <a:srgbClr val="FFFFFF"/>
                 </a:solidFill>
@@ -7801,11 +7796,11 @@
           <a:bodyPr wrap="square" rtlCol="0" anchor="ctr"/>
           <a:lstStyle/>
           <a:p>
-            <a:pPr marL="0" indent="0">
-              <a:buNone/>
-            </a:pPr>
-            <a:r>
-              <a:rPr lang="en-US" sz="3000" b="1" kern="0" spc="50" dirty="0">
+            <a:pPr indent="0" marL="0">
+              <a:buNone/>
+            </a:pPr>
+            <a:r>
+              <a:rPr lang="en-US" sz="3000" b="1" spc="50" kern="0" dirty="0">
                 <a:solidFill>
                   <a:srgbClr val="0A1A1C"/>
                 </a:solidFill>
@@ -7843,13 +7838,6 @@
             <a:prstDash val="solid"/>
           </a:ln>
         </p:spPr>
-        <p:txBody>
-          <a:bodyPr/>
-          <a:lstStyle/>
-          <a:p>
-            <a:endParaRPr lang="en-US"/>
-          </a:p>
-        </p:txBody>
       </p:sp>
       <p:sp>
         <p:nvSpPr>
@@ -8027,7 +8015,6 @@
         <a:solidFill>
           <a:srgbClr val="EAFCFF"/>
         </a:solidFill>
-        <a:effectLst/>
       </p:bgPr>
     </p:bg>
     <p:spTree>
@@ -8068,13 +8055,6 @@
             <a:prstDash val="solid"/>
           </a:ln>
         </p:spPr>
-        <p:txBody>
-          <a:bodyPr/>
-          <a:lstStyle/>
-          <a:p>
-            <a:endParaRPr lang="en-US"/>
-          </a:p>
-        </p:txBody>
       </p:sp>
       <p:sp>
         <p:nvSpPr>
@@ -8097,11 +8077,11 @@
           <a:bodyPr wrap="square" rtlCol="0" anchor="ctr"/>
           <a:lstStyle/>
           <a:p>
-            <a:pPr marL="0" indent="0" algn="ctr">
-              <a:buNone/>
-            </a:pPr>
-            <a:r>
-              <a:rPr lang="en-US" sz="1200" b="1" kern="0" spc="50" dirty="0">
+            <a:pPr algn="ctr" indent="0" marL="0">
+              <a:buNone/>
+            </a:pPr>
+            <a:r>
+              <a:rPr lang="en-US" sz="1200" b="1" spc="50" kern="0" dirty="0">
                 <a:solidFill>
                   <a:srgbClr val="FFFFFF"/>
                 </a:solidFill>
@@ -8136,11 +8116,11 @@
           <a:bodyPr wrap="square" rtlCol="0" anchor="ctr"/>
           <a:lstStyle/>
           <a:p>
-            <a:pPr marL="0" indent="0">
-              <a:buNone/>
-            </a:pPr>
-            <a:r>
-              <a:rPr lang="en-US" sz="3000" b="1" kern="0" spc="50" dirty="0">
+            <a:pPr indent="0" marL="0">
+              <a:buNone/>
+            </a:pPr>
+            <a:r>
+              <a:rPr lang="en-US" sz="3000" b="1" spc="50" kern="0" dirty="0">
                 <a:solidFill>
                   <a:srgbClr val="0A1A1C"/>
                 </a:solidFill>
@@ -8178,13 +8158,6 @@
             <a:prstDash val="solid"/>
           </a:ln>
         </p:spPr>
-        <p:txBody>
-          <a:bodyPr/>
-          <a:lstStyle/>
-          <a:p>
-            <a:endParaRPr lang="en-US"/>
-          </a:p>
-        </p:txBody>
       </p:sp>
       <p:sp>
         <p:nvSpPr>
@@ -8402,7 +8375,6 @@
         <a:solidFill>
           <a:srgbClr val="EAFCFF"/>
         </a:solidFill>
-        <a:effectLst/>
       </p:bgPr>
     </p:bg>
     <p:spTree>
@@ -8443,13 +8415,6 @@
             <a:prstDash val="solid"/>
           </a:ln>
         </p:spPr>
-        <p:txBody>
-          <a:bodyPr/>
-          <a:lstStyle/>
-          <a:p>
-            <a:endParaRPr lang="en-US"/>
-          </a:p>
-        </p:txBody>
       </p:sp>
       <p:sp>
         <p:nvSpPr>
@@ -8472,11 +8437,11 @@
           <a:bodyPr wrap="square" rtlCol="0" anchor="ctr"/>
           <a:lstStyle/>
           <a:p>
-            <a:pPr marL="0" indent="0" algn="ctr">
-              <a:buNone/>
-            </a:pPr>
-            <a:r>
-              <a:rPr lang="en-US" sz="1200" b="1" kern="0" spc="50" dirty="0">
+            <a:pPr algn="ctr" indent="0" marL="0">
+              <a:buNone/>
+            </a:pPr>
+            <a:r>
+              <a:rPr lang="en-US" sz="1200" b="1" spc="50" kern="0" dirty="0">
                 <a:solidFill>
                   <a:srgbClr val="FFFFFF"/>
                 </a:solidFill>
@@ -8511,11 +8476,11 @@
           <a:bodyPr wrap="square" rtlCol="0" anchor="ctr"/>
           <a:lstStyle/>
           <a:p>
-            <a:pPr marL="0" indent="0">
-              <a:buNone/>
-            </a:pPr>
-            <a:r>
-              <a:rPr lang="en-US" sz="3000" b="1" kern="0" spc="50" dirty="0">
+            <a:pPr indent="0" marL="0">
+              <a:buNone/>
+            </a:pPr>
+            <a:r>
+              <a:rPr lang="en-US" sz="3000" b="1" spc="50" kern="0" dirty="0">
                 <a:solidFill>
                   <a:srgbClr val="0A1A1C"/>
                 </a:solidFill>
@@ -8553,13 +8518,6 @@
             <a:prstDash val="solid"/>
           </a:ln>
         </p:spPr>
-        <p:txBody>
-          <a:bodyPr/>
-          <a:lstStyle/>
-          <a:p>
-            <a:endParaRPr lang="en-US"/>
-          </a:p>
-        </p:txBody>
       </p:sp>
       <p:sp>
         <p:nvSpPr>
@@ -8585,13 +8543,6 @@
             <a:prstDash val="solid"/>
           </a:ln>
         </p:spPr>
-        <p:txBody>
-          <a:bodyPr/>
-          <a:lstStyle/>
-          <a:p>
-            <a:endParaRPr lang="en-US"/>
-          </a:p>
-        </p:txBody>
       </p:sp>
       <p:sp>
         <p:nvSpPr>
@@ -8617,13 +8568,6 @@
             <a:prstDash val="solid"/>
           </a:ln>
         </p:spPr>
-        <p:txBody>
-          <a:bodyPr/>
-          <a:lstStyle/>
-          <a:p>
-            <a:endParaRPr lang="en-US"/>
-          </a:p>
-        </p:txBody>
       </p:sp>
       <p:sp>
         <p:nvSpPr>
@@ -8646,7 +8590,7 @@
           <a:bodyPr wrap="square" rtlCol="0" anchor="ctr"/>
           <a:lstStyle/>
           <a:p>
-            <a:pPr marL="0" indent="0">
+            <a:pPr indent="0" marL="0">
               <a:buNone/>
             </a:pPr>
             <a:r>
@@ -8680,7 +8624,6 @@
         <a:solidFill>
           <a:srgbClr val="EAFCFF"/>
         </a:solidFill>
-        <a:effectLst/>
       </p:bgPr>
     </p:bg>
     <p:spTree>
@@ -8721,13 +8664,6 @@
             <a:prstDash val="solid"/>
           </a:ln>
         </p:spPr>
-        <p:txBody>
-          <a:bodyPr/>
-          <a:lstStyle/>
-          <a:p>
-            <a:endParaRPr lang="en-US"/>
-          </a:p>
-        </p:txBody>
       </p:sp>
       <p:sp>
         <p:nvSpPr>
@@ -8750,11 +8686,11 @@
           <a:bodyPr wrap="square" rtlCol="0" anchor="ctr"/>
           <a:lstStyle/>
           <a:p>
-            <a:pPr marL="0" indent="0" algn="ctr">
-              <a:buNone/>
-            </a:pPr>
-            <a:r>
-              <a:rPr lang="en-US" sz="1200" b="1" kern="0" spc="50" dirty="0">
+            <a:pPr algn="ctr" indent="0" marL="0">
+              <a:buNone/>
+            </a:pPr>
+            <a:r>
+              <a:rPr lang="en-US" sz="1200" b="1" spc="50" kern="0" dirty="0">
                 <a:solidFill>
                   <a:srgbClr val="FFFFFF"/>
                 </a:solidFill>
@@ -8789,11 +8725,11 @@
           <a:bodyPr wrap="square" rtlCol="0" anchor="ctr"/>
           <a:lstStyle/>
           <a:p>
-            <a:pPr marL="0" indent="0">
-              <a:buNone/>
-            </a:pPr>
-            <a:r>
-              <a:rPr lang="en-US" sz="3000" b="1" kern="0" spc="50" dirty="0">
+            <a:pPr indent="0" marL="0">
+              <a:buNone/>
+            </a:pPr>
+            <a:r>
+              <a:rPr lang="en-US" sz="3000" b="1" spc="50" kern="0" dirty="0">
                 <a:solidFill>
                   <a:srgbClr val="0A1A1C"/>
                 </a:solidFill>
@@ -8831,13 +8767,6 @@
             <a:prstDash val="solid"/>
           </a:ln>
         </p:spPr>
-        <p:txBody>
-          <a:bodyPr/>
-          <a:lstStyle/>
-          <a:p>
-            <a:endParaRPr lang="en-US"/>
-          </a:p>
-        </p:txBody>
       </p:sp>
       <p:sp>
         <p:nvSpPr>
@@ -9015,7 +8944,6 @@
         <a:solidFill>
           <a:srgbClr val="EAFCFF"/>
         </a:solidFill>
-        <a:effectLst/>
       </p:bgPr>
     </p:bg>
     <p:spTree>
@@ -9056,13 +8984,6 @@
             <a:prstDash val="solid"/>
           </a:ln>
         </p:spPr>
-        <p:txBody>
-          <a:bodyPr/>
-          <a:lstStyle/>
-          <a:p>
-            <a:endParaRPr lang="en-US"/>
-          </a:p>
-        </p:txBody>
       </p:sp>
       <p:sp>
         <p:nvSpPr>
@@ -9085,11 +9006,11 @@
           <a:bodyPr wrap="square" rtlCol="0" anchor="ctr"/>
           <a:lstStyle/>
           <a:p>
-            <a:pPr marL="0" indent="0" algn="ctr">
-              <a:buNone/>
-            </a:pPr>
-            <a:r>
-              <a:rPr lang="en-US" sz="1200" b="1" kern="0" spc="50" dirty="0">
+            <a:pPr algn="ctr" indent="0" marL="0">
+              <a:buNone/>
+            </a:pPr>
+            <a:r>
+              <a:rPr lang="en-US" sz="1200" b="1" spc="50" kern="0" dirty="0">
                 <a:solidFill>
                   <a:srgbClr val="FFFFFF"/>
                 </a:solidFill>
@@ -9124,11 +9045,11 @@
           <a:bodyPr wrap="square" rtlCol="0" anchor="ctr"/>
           <a:lstStyle/>
           <a:p>
-            <a:pPr marL="0" indent="0">
-              <a:buNone/>
-            </a:pPr>
-            <a:r>
-              <a:rPr lang="en-US" sz="3000" b="1" kern="0" spc="50" dirty="0">
+            <a:pPr indent="0" marL="0">
+              <a:buNone/>
+            </a:pPr>
+            <a:r>
+              <a:rPr lang="en-US" sz="3000" b="1" spc="50" kern="0" dirty="0">
                 <a:solidFill>
                   <a:srgbClr val="0A1A1C"/>
                 </a:solidFill>
@@ -9166,13 +9087,6 @@
             <a:prstDash val="solid"/>
           </a:ln>
         </p:spPr>
-        <p:txBody>
-          <a:bodyPr/>
-          <a:lstStyle/>
-          <a:p>
-            <a:endParaRPr lang="en-US"/>
-          </a:p>
-        </p:txBody>
       </p:sp>
       <p:sp>
         <p:nvSpPr>
@@ -9198,13 +9112,6 @@
             <a:prstDash val="solid"/>
           </a:ln>
         </p:spPr>
-        <p:txBody>
-          <a:bodyPr/>
-          <a:lstStyle/>
-          <a:p>
-            <a:endParaRPr lang="en-US"/>
-          </a:p>
-        </p:txBody>
       </p:sp>
       <p:sp>
         <p:nvSpPr>
@@ -9230,13 +9137,6 @@
             <a:prstDash val="solid"/>
           </a:ln>
         </p:spPr>
-        <p:txBody>
-          <a:bodyPr/>
-          <a:lstStyle/>
-          <a:p>
-            <a:endParaRPr lang="en-US"/>
-          </a:p>
-        </p:txBody>
       </p:sp>
       <p:sp>
         <p:nvSpPr>
@@ -9259,7 +9159,7 @@
           <a:bodyPr wrap="square" rtlCol="0" anchor="ctr"/>
           <a:lstStyle/>
           <a:p>
-            <a:pPr marL="0" indent="0">
+            <a:pPr indent="0" marL="0">
               <a:buNone/>
             </a:pPr>
             <a:r>
@@ -9276,7 +9176,7 @@
             <a:endParaRPr lang="en-US" sz="2000" dirty="0"/>
           </a:p>
           <a:p>
-            <a:pPr marL="0" indent="0">
+            <a:pPr indent="0" marL="0">
               <a:buNone/>
             </a:pPr>
             <a:r>
@@ -9293,7 +9193,7 @@
             <a:endParaRPr lang="en-US" sz="2000" dirty="0"/>
           </a:p>
           <a:p>
-            <a:pPr marL="0" indent="0">
+            <a:pPr indent="0" marL="0">
               <a:buNone/>
             </a:pPr>
             <a:r>
@@ -9327,7 +9227,6 @@
         <a:solidFill>
           <a:srgbClr val="007A90"/>
         </a:solidFill>
-        <a:effectLst/>
       </p:bgPr>
     </p:bg>
     <p:spTree>
@@ -9368,13 +9267,6 @@
             <a:prstDash val="solid"/>
           </a:ln>
         </p:spPr>
-        <p:txBody>
-          <a:bodyPr/>
-          <a:lstStyle/>
-          <a:p>
-            <a:endParaRPr lang="en-US"/>
-          </a:p>
-        </p:txBody>
       </p:sp>
       <p:sp>
         <p:nvSpPr>
@@ -9397,11 +9289,11 @@
           <a:bodyPr wrap="square" rtlCol="0" anchor="ctr"/>
           <a:lstStyle/>
           <a:p>
-            <a:pPr marL="0" indent="0" algn="ctr">
-              <a:buNone/>
-            </a:pPr>
-            <a:r>
-              <a:rPr lang="en-US" sz="4800" b="1" kern="0" spc="50" dirty="0">
+            <a:pPr algn="ctr" indent="0" marL="0">
+              <a:buNone/>
+            </a:pPr>
+            <a:r>
+              <a:rPr lang="en-US" sz="4800" b="1" spc="50" kern="0" dirty="0">
                 <a:solidFill>
                   <a:srgbClr val="FFFFFF"/>
                 </a:solidFill>
@@ -9436,7 +9328,7 @@
           <a:bodyPr wrap="square" rtlCol="0" anchor="ctr"/>
           <a:lstStyle/>
           <a:p>
-            <a:pPr marL="0" indent="0" algn="ctr">
+            <a:pPr algn="ctr" indent="0" marL="0">
               <a:buNone/>
             </a:pPr>
             <a:r>
@@ -9472,7 +9364,6 @@
         <a:solidFill>
           <a:srgbClr val="EAFCFF"/>
         </a:solidFill>
-        <a:effectLst/>
       </p:bgPr>
     </p:bg>
     <p:spTree>
@@ -9513,13 +9404,6 @@
             <a:prstDash val="solid"/>
           </a:ln>
         </p:spPr>
-        <p:txBody>
-          <a:bodyPr/>
-          <a:lstStyle/>
-          <a:p>
-            <a:endParaRPr lang="en-US"/>
-          </a:p>
-        </p:txBody>
       </p:sp>
       <p:sp>
         <p:nvSpPr>
@@ -9542,11 +9426,11 @@
           <a:bodyPr wrap="square" rtlCol="0" anchor="ctr"/>
           <a:lstStyle/>
           <a:p>
-            <a:pPr marL="0" indent="0" algn="ctr">
-              <a:buNone/>
-            </a:pPr>
-            <a:r>
-              <a:rPr lang="en-US" sz="1200" b="1" kern="0" spc="50" dirty="0">
+            <a:pPr algn="ctr" indent="0" marL="0">
+              <a:buNone/>
+            </a:pPr>
+            <a:r>
+              <a:rPr lang="en-US" sz="1200" b="1" spc="50" kern="0" dirty="0">
                 <a:solidFill>
                   <a:srgbClr val="FFFFFF"/>
                 </a:solidFill>
@@ -9581,11 +9465,11 @@
           <a:bodyPr wrap="square" rtlCol="0" anchor="ctr"/>
           <a:lstStyle/>
           <a:p>
-            <a:pPr marL="0" indent="0">
-              <a:buNone/>
-            </a:pPr>
-            <a:r>
-              <a:rPr lang="en-US" sz="3000" b="1" kern="0" spc="50" dirty="0">
+            <a:pPr indent="0" marL="0">
+              <a:buNone/>
+            </a:pPr>
+            <a:r>
+              <a:rPr lang="en-US" sz="3000" b="1" spc="50" kern="0" dirty="0">
                 <a:solidFill>
                   <a:srgbClr val="0A1A1C"/>
                 </a:solidFill>
@@ -9623,13 +9507,6 @@
             <a:prstDash val="solid"/>
           </a:ln>
         </p:spPr>
-        <p:txBody>
-          <a:bodyPr/>
-          <a:lstStyle/>
-          <a:p>
-            <a:endParaRPr lang="en-US"/>
-          </a:p>
-        </p:txBody>
       </p:sp>
       <p:sp>
         <p:nvSpPr>
@@ -9657,13 +9534,6 @@
             <a:prstDash val="solid"/>
           </a:ln>
         </p:spPr>
-        <p:txBody>
-          <a:bodyPr/>
-          <a:lstStyle/>
-          <a:p>
-            <a:endParaRPr lang="en-US"/>
-          </a:p>
-        </p:txBody>
       </p:sp>
       <p:sp>
         <p:nvSpPr>
@@ -9686,7 +9556,7 @@
           <a:bodyPr wrap="square" rtlCol="0" anchor="ctr"/>
           <a:lstStyle/>
           <a:p>
-            <a:pPr marL="0" indent="0" algn="ctr">
+            <a:pPr algn="ctr" indent="0" marL="0">
               <a:buNone/>
             </a:pPr>
             <a:r>
@@ -9703,7 +9573,7 @@
             <a:endParaRPr lang="en-US" sz="1300" dirty="0"/>
           </a:p>
           <a:p>
-            <a:pPr marL="0" indent="0" algn="ctr">
+            <a:pPr algn="ctr" indent="0" marL="0">
               <a:buNone/>
             </a:pPr>
             <a:r>
@@ -9720,7 +9590,7 @@
             <a:endParaRPr lang="en-US" sz="1300" dirty="0"/>
           </a:p>
           <a:p>
-            <a:pPr marL="0" indent="0" algn="ctr">
+            <a:pPr algn="ctr" indent="0" marL="0">
               <a:buNone/>
             </a:pPr>
             <a:r>
@@ -9759,7 +9629,7 @@
           <a:bodyPr wrap="square" rtlCol="0" anchor="ctr"/>
           <a:lstStyle/>
           <a:p>
-            <a:pPr marL="0" indent="0" algn="ctr">
+            <a:pPr algn="ctr" indent="0" marL="0">
               <a:buNone/>
             </a:pPr>
             <a:r>
@@ -9803,13 +9673,6 @@
             <a:prstDash val="solid"/>
           </a:ln>
         </p:spPr>
-        <p:txBody>
-          <a:bodyPr/>
-          <a:lstStyle/>
-          <a:p>
-            <a:endParaRPr lang="en-US"/>
-          </a:p>
-        </p:txBody>
       </p:sp>
       <p:sp>
         <p:nvSpPr>
@@ -9832,7 +9695,7 @@
           <a:bodyPr wrap="square" rtlCol="0" anchor="ctr"/>
           <a:lstStyle/>
           <a:p>
-            <a:pPr marL="0" indent="0" algn="ctr">
+            <a:pPr algn="ctr" indent="0" marL="0">
               <a:buNone/>
             </a:pPr>
             <a:r>
@@ -9849,7 +9712,7 @@
             <a:endParaRPr lang="en-US" sz="1300" dirty="0"/>
           </a:p>
           <a:p>
-            <a:pPr marL="0" indent="0" algn="ctr">
+            <a:pPr algn="ctr" indent="0" marL="0">
               <a:buNone/>
             </a:pPr>
             <a:r>
@@ -9866,7 +9729,7 @@
             <a:endParaRPr lang="en-US" sz="1300" dirty="0"/>
           </a:p>
           <a:p>
-            <a:pPr marL="0" indent="0" algn="ctr">
+            <a:pPr algn="ctr" indent="0" marL="0">
               <a:buNone/>
             </a:pPr>
             <a:r>
@@ -10060,7 +9923,6 @@
         <a:solidFill>
           <a:srgbClr val="EAFCFF"/>
         </a:solidFill>
-        <a:effectLst/>
       </p:bgPr>
     </p:bg>
     <p:spTree>
@@ -10101,13 +9963,6 @@
             <a:prstDash val="solid"/>
           </a:ln>
         </p:spPr>
-        <p:txBody>
-          <a:bodyPr/>
-          <a:lstStyle/>
-          <a:p>
-            <a:endParaRPr lang="en-US"/>
-          </a:p>
-        </p:txBody>
       </p:sp>
       <p:sp>
         <p:nvSpPr>
@@ -10130,11 +9985,11 @@
           <a:bodyPr wrap="square" rtlCol="0" anchor="ctr"/>
           <a:lstStyle/>
           <a:p>
-            <a:pPr marL="0" indent="0" algn="ctr">
-              <a:buNone/>
-            </a:pPr>
-            <a:r>
-              <a:rPr lang="en-US" sz="1200" b="1" kern="0" spc="50" dirty="0">
+            <a:pPr algn="ctr" indent="0" marL="0">
+              <a:buNone/>
+            </a:pPr>
+            <a:r>
+              <a:rPr lang="en-US" sz="1200" b="1" spc="50" kern="0" dirty="0">
                 <a:solidFill>
                   <a:srgbClr val="FFFFFF"/>
                 </a:solidFill>
@@ -10169,11 +10024,11 @@
           <a:bodyPr wrap="square" rtlCol="0" anchor="ctr"/>
           <a:lstStyle/>
           <a:p>
-            <a:pPr marL="0" indent="0">
-              <a:buNone/>
-            </a:pPr>
-            <a:r>
-              <a:rPr lang="en-US" sz="3000" b="1" kern="0" spc="50" dirty="0">
+            <a:pPr indent="0" marL="0">
+              <a:buNone/>
+            </a:pPr>
+            <a:r>
+              <a:rPr lang="en-US" sz="3000" b="1" spc="50" kern="0" dirty="0">
                 <a:solidFill>
                   <a:srgbClr val="0A1A1C"/>
                 </a:solidFill>
@@ -10211,13 +10066,6 @@
             <a:prstDash val="solid"/>
           </a:ln>
         </p:spPr>
-        <p:txBody>
-          <a:bodyPr/>
-          <a:lstStyle/>
-          <a:p>
-            <a:endParaRPr lang="en-US"/>
-          </a:p>
-        </p:txBody>
       </p:sp>
       <p:sp>
         <p:nvSpPr>
@@ -10395,7 +10243,6 @@
         <a:solidFill>
           <a:srgbClr val="007A90"/>
         </a:solidFill>
-        <a:effectLst/>
       </p:bgPr>
     </p:bg>
     <p:spTree>
@@ -10436,13 +10283,6 @@
             <a:prstDash val="solid"/>
           </a:ln>
         </p:spPr>
-        <p:txBody>
-          <a:bodyPr/>
-          <a:lstStyle/>
-          <a:p>
-            <a:endParaRPr lang="en-US"/>
-          </a:p>
-        </p:txBody>
       </p:sp>
       <p:sp>
         <p:nvSpPr>
@@ -10465,11 +10305,11 @@
           <a:bodyPr wrap="square" rtlCol="0" anchor="ctr"/>
           <a:lstStyle/>
           <a:p>
-            <a:pPr marL="0" indent="0" algn="ctr">
-              <a:buNone/>
-            </a:pPr>
-            <a:r>
-              <a:rPr lang="en-US" sz="4800" b="1" kern="0" spc="50" dirty="0">
+            <a:pPr algn="ctr" indent="0" marL="0">
+              <a:buNone/>
+            </a:pPr>
+            <a:r>
+              <a:rPr lang="en-US" sz="4800" b="1" spc="50" kern="0" dirty="0">
                 <a:solidFill>
                   <a:srgbClr val="FFFFFF"/>
                 </a:solidFill>
@@ -10504,7 +10344,7 @@
           <a:bodyPr wrap="square" rtlCol="0" anchor="ctr"/>
           <a:lstStyle/>
           <a:p>
-            <a:pPr marL="0" indent="0" algn="ctr">
+            <a:pPr algn="ctr" indent="0" marL="0">
               <a:buNone/>
             </a:pPr>
             <a:r>
@@ -10540,7 +10380,6 @@
         <a:solidFill>
           <a:srgbClr val="EAFCFF"/>
         </a:solidFill>
-        <a:effectLst/>
       </p:bgPr>
     </p:bg>
     <p:spTree>
@@ -10581,13 +10420,6 @@
             <a:prstDash val="solid"/>
           </a:ln>
         </p:spPr>
-        <p:txBody>
-          <a:bodyPr/>
-          <a:lstStyle/>
-          <a:p>
-            <a:endParaRPr lang="en-US"/>
-          </a:p>
-        </p:txBody>
       </p:sp>
       <p:sp>
         <p:nvSpPr>
@@ -10610,11 +10442,11 @@
           <a:bodyPr wrap="square" rtlCol="0" anchor="ctr"/>
           <a:lstStyle/>
           <a:p>
-            <a:pPr marL="0" indent="0" algn="ctr">
-              <a:buNone/>
-            </a:pPr>
-            <a:r>
-              <a:rPr lang="en-US" sz="1200" b="1" kern="0" spc="50" dirty="0">
+            <a:pPr algn="ctr" indent="0" marL="0">
+              <a:buNone/>
+            </a:pPr>
+            <a:r>
+              <a:rPr lang="en-US" sz="1200" b="1" spc="50" kern="0" dirty="0">
                 <a:solidFill>
                   <a:srgbClr val="FFFFFF"/>
                 </a:solidFill>
@@ -10649,11 +10481,11 @@
           <a:bodyPr wrap="square" rtlCol="0" anchor="ctr"/>
           <a:lstStyle/>
           <a:p>
-            <a:pPr marL="0" indent="0">
-              <a:buNone/>
-            </a:pPr>
-            <a:r>
-              <a:rPr lang="en-US" sz="3000" b="1" kern="0" spc="50" dirty="0">
+            <a:pPr indent="0" marL="0">
+              <a:buNone/>
+            </a:pPr>
+            <a:r>
+              <a:rPr lang="en-US" sz="3000" b="1" spc="50" kern="0" dirty="0">
                 <a:solidFill>
                   <a:srgbClr val="0A1A1C"/>
                 </a:solidFill>
@@ -10691,13 +10523,6 @@
             <a:prstDash val="solid"/>
           </a:ln>
         </p:spPr>
-        <p:txBody>
-          <a:bodyPr/>
-          <a:lstStyle/>
-          <a:p>
-            <a:endParaRPr lang="en-US"/>
-          </a:p>
-        </p:txBody>
       </p:sp>
       <p:sp>
         <p:nvSpPr>
@@ -10725,13 +10550,6 @@
             <a:prstDash val="solid"/>
           </a:ln>
         </p:spPr>
-        <p:txBody>
-          <a:bodyPr/>
-          <a:lstStyle/>
-          <a:p>
-            <a:endParaRPr lang="en-US"/>
-          </a:p>
-        </p:txBody>
       </p:sp>
       <p:sp>
         <p:nvSpPr>
@@ -10754,7 +10572,7 @@
           <a:bodyPr wrap="square" rtlCol="0" anchor="b"/>
           <a:lstStyle/>
           <a:p>
-            <a:pPr marL="0" indent="0" algn="ctr">
+            <a:pPr algn="ctr" indent="0" marL="0">
               <a:buNone/>
             </a:pPr>
             <a:r>
@@ -10793,7 +10611,7 @@
           <a:bodyPr wrap="square" rtlCol="0" anchor="t"/>
           <a:lstStyle/>
           <a:p>
-            <a:pPr marL="0" indent="0" algn="ctr">
+            <a:pPr algn="ctr" indent="0" marL="0">
               <a:buNone/>
             </a:pPr>
             <a:r>
@@ -10837,13 +10655,6 @@
             <a:prstDash val="solid"/>
           </a:ln>
         </p:spPr>
-        <p:txBody>
-          <a:bodyPr/>
-          <a:lstStyle/>
-          <a:p>
-            <a:endParaRPr lang="en-US"/>
-          </a:p>
-        </p:txBody>
       </p:sp>
       <p:sp>
         <p:nvSpPr>
@@ -10866,7 +10677,7 @@
           <a:bodyPr wrap="square" rtlCol="0" anchor="b"/>
           <a:lstStyle/>
           <a:p>
-            <a:pPr marL="0" indent="0" algn="ctr">
+            <a:pPr algn="ctr" indent="0" marL="0">
               <a:buNone/>
             </a:pPr>
             <a:r>
@@ -10905,7 +10716,7 @@
           <a:bodyPr wrap="square" rtlCol="0" anchor="t"/>
           <a:lstStyle/>
           <a:p>
-            <a:pPr marL="0" indent="0" algn="ctr">
+            <a:pPr algn="ctr" indent="0" marL="0">
               <a:buNone/>
             </a:pPr>
             <a:r>
@@ -10949,13 +10760,6 @@
             <a:prstDash val="solid"/>
           </a:ln>
         </p:spPr>
-        <p:txBody>
-          <a:bodyPr/>
-          <a:lstStyle/>
-          <a:p>
-            <a:endParaRPr lang="en-US"/>
-          </a:p>
-        </p:txBody>
       </p:sp>
       <p:sp>
         <p:nvSpPr>
@@ -10978,7 +10782,7 @@
           <a:bodyPr wrap="square" rtlCol="0" anchor="b"/>
           <a:lstStyle/>
           <a:p>
-            <a:pPr marL="0" indent="0" algn="ctr">
+            <a:pPr algn="ctr" indent="0" marL="0">
               <a:buNone/>
             </a:pPr>
             <a:r>
@@ -11017,7 +10821,7 @@
           <a:bodyPr wrap="square" rtlCol="0" anchor="t"/>
           <a:lstStyle/>
           <a:p>
-            <a:pPr marL="0" indent="0" algn="ctr">
+            <a:pPr algn="ctr" indent="0" marL="0">
               <a:buNone/>
             </a:pPr>
             <a:r>
@@ -11211,7 +11015,6 @@
         <a:solidFill>
           <a:srgbClr val="EAFCFF"/>
         </a:solidFill>
-        <a:effectLst/>
       </p:bgPr>
     </p:bg>
     <p:spTree>
@@ -11252,13 +11055,6 @@
             <a:prstDash val="solid"/>
           </a:ln>
         </p:spPr>
-        <p:txBody>
-          <a:bodyPr/>
-          <a:lstStyle/>
-          <a:p>
-            <a:endParaRPr lang="en-US"/>
-          </a:p>
-        </p:txBody>
       </p:sp>
       <p:sp>
         <p:nvSpPr>
@@ -11281,11 +11077,11 @@
           <a:bodyPr wrap="square" rtlCol="0" anchor="ctr"/>
           <a:lstStyle/>
           <a:p>
-            <a:pPr marL="0" indent="0" algn="ctr">
-              <a:buNone/>
-            </a:pPr>
-            <a:r>
-              <a:rPr lang="en-US" sz="1200" b="1" kern="0" spc="50" dirty="0">
+            <a:pPr algn="ctr" indent="0" marL="0">
+              <a:buNone/>
+            </a:pPr>
+            <a:r>
+              <a:rPr lang="en-US" sz="1200" b="1" spc="50" kern="0" dirty="0">
                 <a:solidFill>
                   <a:srgbClr val="FFFFFF"/>
                 </a:solidFill>
@@ -11320,11 +11116,11 @@
           <a:bodyPr wrap="square" rtlCol="0" anchor="ctr"/>
           <a:lstStyle/>
           <a:p>
-            <a:pPr marL="0" indent="0">
-              <a:buNone/>
-            </a:pPr>
-            <a:r>
-              <a:rPr lang="en-US" sz="3000" b="1" kern="0" spc="50" dirty="0">
+            <a:pPr indent="0" marL="0">
+              <a:buNone/>
+            </a:pPr>
+            <a:r>
+              <a:rPr lang="en-US" sz="3000" b="1" spc="50" kern="0" dirty="0">
                 <a:solidFill>
                   <a:srgbClr val="0A1A1C"/>
                 </a:solidFill>
@@ -11362,13 +11158,6 @@
             <a:prstDash val="solid"/>
           </a:ln>
         </p:spPr>
-        <p:txBody>
-          <a:bodyPr/>
-          <a:lstStyle/>
-          <a:p>
-            <a:endParaRPr lang="en-US"/>
-          </a:p>
-        </p:txBody>
       </p:sp>
       <p:sp>
         <p:nvSpPr>
@@ -11378,8 +11167,8 @@
         </p:nvSpPr>
         <p:spPr>
           <a:xfrm>
-            <a:off x="457200" y="3451860"/>
-            <a:ext cx="5638800" cy="1273646"/>
+            <a:off x="457200" y="1572768"/>
+            <a:ext cx="5477256" cy="5010912"/>
           </a:xfrm>
           <a:prstGeom prst="rect">
             <a:avLst/>
@@ -11394,13 +11183,6 @@
             <a:prstDash val="solid"/>
           </a:ln>
         </p:spPr>
-        <p:txBody>
-          <a:bodyPr/>
-          <a:lstStyle/>
-          <a:p>
-            <a:endParaRPr lang="en-US"/>
-          </a:p>
-        </p:txBody>
       </p:sp>
       <p:sp>
         <p:nvSpPr>
@@ -11410,7 +11192,7 @@
         </p:nvSpPr>
         <p:spPr>
           <a:xfrm>
-            <a:off x="602502" y="3589020"/>
+            <a:off x="640080" y="1709928"/>
             <a:ext cx="5111496" cy="4736592"/>
           </a:xfrm>
           <a:prstGeom prst="rect">
@@ -11423,7 +11205,7 @@
           <a:bodyPr wrap="none" rtlCol="0" anchor="t"/>
           <a:lstStyle/>
           <a:p>
-            <a:pPr marL="0" indent="0">
+            <a:pPr indent="0" marL="0">
               <a:buNone/>
             </a:pPr>
             <a:r>
@@ -11440,7 +11222,7 @@
             <a:endParaRPr lang="en-US" sz="1400" dirty="0"/>
           </a:p>
           <a:p>
-            <a:pPr marL="0" indent="0">
+            <a:pPr indent="0" marL="0">
               <a:buNone/>
             </a:pPr>
             <a:r>
@@ -11457,7 +11239,7 @@
             <a:endParaRPr lang="en-US" sz="1400" dirty="0"/>
           </a:p>
           <a:p>
-            <a:pPr marL="0" indent="0">
+            <a:pPr indent="0" marL="0">
               <a:buNone/>
             </a:pPr>
             <a:r>
@@ -11474,7 +11256,7 @@
             <a:endParaRPr lang="en-US" sz="1400" dirty="0"/>
           </a:p>
           <a:p>
-            <a:pPr marL="0" indent="0">
+            <a:pPr indent="0" marL="0">
               <a:buNone/>
             </a:pPr>
             <a:r>
@@ -11566,7 +11348,7 @@
                 <a:ea typeface="Trebuchet MS" pitchFamily="34" charset="-122"/>
                 <a:cs typeface="Trebuchet MS" pitchFamily="34" charset="-120"/>
               </a:rPr>
-              <a:t>kubectl apply means "make the cluster match this file" — and keep it matching</a:t>
+              <a:t>kubectl apply means "make the cluster match this file" — once, then it exits</a:t>
             </a:r>
             <a:endParaRPr lang="en-US" sz="1700" dirty="0"/>
           </a:p>
@@ -11606,7 +11388,7 @@
                 <a:ea typeface="Trebuchet MS" pitchFamily="34" charset="-122"/>
                 <a:cs typeface="Trebuchet MS" pitchFamily="34" charset="-120"/>
               </a:rPr>
-              <a:t>Re-running apply with no changes reports unchanged because reality already matches</a:t>
+              <a:t>Re-running apply reports unchanged — a fresh one-time diff, not proof of an ongoing watch</a:t>
             </a:r>
             <a:endParaRPr lang="en-US" sz="1700" dirty="0"/>
           </a:p>
@@ -11646,7 +11428,7 @@
                 <a:ea typeface="Trebuchet MS" pitchFamily="34" charset="-122"/>
                 <a:cs typeface="Trebuchet MS" pitchFamily="34" charset="-120"/>
               </a:rPr>
-              <a:t>This loop, running continuously instead of once, is exactly what makes a Deployment self-heal a deleted Pod</a:t>
+              <a:t>Continuous enforcement comes from a controller, not from apply — a bare Pod has none, a Deployment does</a:t>
             </a:r>
             <a:endParaRPr lang="en-US" sz="1700" dirty="0"/>
           </a:p>
@@ -11668,7 +11450,6 @@
         <a:solidFill>
           <a:srgbClr val="007A90"/>
         </a:solidFill>
-        <a:effectLst/>
       </p:bgPr>
     </p:bg>
     <p:spTree>
@@ -11709,13 +11490,6 @@
             <a:prstDash val="solid"/>
           </a:ln>
         </p:spPr>
-        <p:txBody>
-          <a:bodyPr/>
-          <a:lstStyle/>
-          <a:p>
-            <a:endParaRPr lang="en-US"/>
-          </a:p>
-        </p:txBody>
       </p:sp>
       <p:sp>
         <p:nvSpPr>
@@ -11738,11 +11512,11 @@
           <a:bodyPr wrap="square" rtlCol="0" anchor="ctr"/>
           <a:lstStyle/>
           <a:p>
-            <a:pPr marL="0" indent="0" algn="ctr">
-              <a:buNone/>
-            </a:pPr>
-            <a:r>
-              <a:rPr lang="en-US" sz="4800" b="1" kern="0" spc="50" dirty="0">
+            <a:pPr algn="ctr" indent="0" marL="0">
+              <a:buNone/>
+            </a:pPr>
+            <a:r>
+              <a:rPr lang="en-US" sz="4800" b="1" spc="50" kern="0" dirty="0">
                 <a:solidFill>
                   <a:srgbClr val="FFFFFF"/>
                 </a:solidFill>
@@ -11777,7 +11551,7 @@
           <a:bodyPr wrap="square" rtlCol="0" anchor="ctr"/>
           <a:lstStyle/>
           <a:p>
-            <a:pPr marL="0" indent="0" algn="ctr">
+            <a:pPr algn="ctr" indent="0" marL="0">
               <a:buNone/>
             </a:pPr>
             <a:r>
@@ -12098,319 +11872,4 @@
     </a:ext>
   </a:extLst>
 </a:theme>
-</file>
-
-<file path=ppt/theme/theme2.xml><?xml version="1.0" encoding="utf-8"?>
-<a:theme xmlns:a="http://schemas.openxmlformats.org/drawingml/2006/main" name="Office Theme">
-  <a:themeElements>
-    <a:clrScheme name="Office">
-      <a:dk1>
-        <a:sysClr val="windowText" lastClr="000000"/>
-      </a:dk1>
-      <a:lt1>
-        <a:sysClr val="window" lastClr="FFFFFF"/>
-      </a:lt1>
-      <a:dk2>
-        <a:srgbClr val="0E2841"/>
-      </a:dk2>
-      <a:lt2>
-        <a:srgbClr val="E8E8E8"/>
-      </a:lt2>
-      <a:accent1>
-        <a:srgbClr val="156082"/>
-      </a:accent1>
-      <a:accent2>
-        <a:srgbClr val="E97132"/>
-      </a:accent2>
-      <a:accent3>
-        <a:srgbClr val="196B24"/>
-      </a:accent3>
-      <a:accent4>
-        <a:srgbClr val="0F9ED5"/>
-      </a:accent4>
-      <a:accent5>
-        <a:srgbClr val="A02B93"/>
-      </a:accent5>
-      <a:accent6>
-        <a:srgbClr val="4EA72E"/>
-      </a:accent6>
-      <a:hlink>
-        <a:srgbClr val="467886"/>
-      </a:hlink>
-      <a:folHlink>
-        <a:srgbClr val="96607D"/>
-      </a:folHlink>
-    </a:clrScheme>
-    <a:fontScheme name="Office">
-      <a:majorFont>
-        <a:latin typeface="Aptos Display" panose="02110004020202020204"/>
-        <a:ea typeface=""/>
-        <a:cs typeface=""/>
-        <a:font script="Jpan" typeface="游ゴシック Light"/>
-        <a:font script="Hang" typeface="맑은 고딕"/>
-        <a:font script="Hans" typeface="等线 Light"/>
-        <a:font script="Hant" typeface="新細明體"/>
-        <a:font script="Arab" typeface="Times New Roman"/>
-        <a:font script="Hebr" typeface="Times New Roman"/>
-        <a:font script="Thai" typeface="Angsana New"/>
-        <a:font script="Ethi" typeface="Nyala"/>
-        <a:font script="Beng" typeface="Vrinda"/>
-        <a:font script="Gujr" typeface="Shruti"/>
-        <a:font script="Khmr" typeface="MoolBoran"/>
-        <a:font script="Knda" typeface="Tunga"/>
-        <a:font script="Guru" typeface="Raavi"/>
-        <a:font script="Cans" typeface="Euphemia"/>
-        <a:font script="Cher" typeface="Plantagenet Cherokee"/>
-        <a:font script="Yiii" typeface="Microsoft Yi Baiti"/>
-        <a:font script="Tibt" typeface="Microsoft Himalaya"/>
-        <a:font script="Thaa" typeface="MV Boli"/>
-        <a:font script="Deva" typeface="Mangal"/>
-        <a:font script="Telu" typeface="Gautami"/>
-        <a:font script="Taml" typeface="Latha"/>
-        <a:font script="Syrc" typeface="Estrangelo Edessa"/>
-        <a:font script="Orya" typeface="Kalinga"/>
-        <a:font script="Mlym" typeface="Kartika"/>
-        <a:font script="Laoo" typeface="DokChampa"/>
-        <a:font script="Sinh" typeface="Iskoola Pota"/>
-        <a:font script="Mong" typeface="Mongolian Baiti"/>
-        <a:font script="Viet" typeface="Times New Roman"/>
-        <a:font script="Uigh" typeface="Microsoft Uighur"/>
-        <a:font script="Geor" typeface="Sylfaen"/>
-        <a:font script="Armn" typeface="Arial"/>
-        <a:font script="Bugi" typeface="Leelawadee UI"/>
-        <a:font script="Bopo" typeface="Microsoft JhengHei"/>
-        <a:font script="Java" typeface="Javanese Text"/>
-        <a:font script="Lisu" typeface="Segoe UI"/>
-        <a:font script="Mymr" typeface="Myanmar Text"/>
-        <a:font script="Nkoo" typeface="Ebrima"/>
-        <a:font script="Olck" typeface="Nirmala UI"/>
-        <a:font script="Osma" typeface="Ebrima"/>
-        <a:font script="Phag" typeface="Phagspa"/>
-        <a:font script="Syrn" typeface="Estrangelo Edessa"/>
-        <a:font script="Syrj" typeface="Estrangelo Edessa"/>
-        <a:font script="Syre" typeface="Estrangelo Edessa"/>
-        <a:font script="Sora" typeface="Nirmala UI"/>
-        <a:font script="Tale" typeface="Microsoft Tai Le"/>
-        <a:font script="Talu" typeface="Microsoft New Tai Lue"/>
-        <a:font script="Tfng" typeface="Ebrima"/>
-      </a:majorFont>
-      <a:minorFont>
-        <a:latin typeface="Aptos" panose="02110004020202020204"/>
-        <a:ea typeface=""/>
-        <a:cs typeface=""/>
-        <a:font script="Jpan" typeface="游ゴシック"/>
-        <a:font script="Hang" typeface="맑은 고딕"/>
-        <a:font script="Hans" typeface="等线"/>
-        <a:font script="Hant" typeface="新細明體"/>
-        <a:font script="Arab" typeface="Arial"/>
-        <a:font script="Hebr" typeface="Arial"/>
-        <a:font script="Thai" typeface="Cordia New"/>
-        <a:font script="Ethi" typeface="Nyala"/>
-        <a:font script="Beng" typeface="Vrinda"/>
-        <a:font script="Gujr" typeface="Shruti"/>
-        <a:font script="Khmr" typeface="DaunPenh"/>
-        <a:font script="Knda" typeface="Tunga"/>
-        <a:font script="Guru" typeface="Raavi"/>
-        <a:font script="Cans" typeface="Euphemia"/>
-        <a:font script="Cher" typeface="Plantagenet Cherokee"/>
-        <a:font script="Yiii" typeface="Microsoft Yi Baiti"/>
-        <a:font script="Tibt" typeface="Microsoft Himalaya"/>
-        <a:font script="Thaa" typeface="MV Boli"/>
-        <a:font script="Deva" typeface="Mangal"/>
-        <a:font script="Telu" typeface="Gautami"/>
-        <a:font script="Taml" typeface="Latha"/>
-        <a:font script="Syrc" typeface="Estrangelo Edessa"/>
-        <a:font script="Orya" typeface="Kalinga"/>
-        <a:font script="Mlym" typeface="Kartika"/>
-        <a:font script="Laoo" typeface="DokChampa"/>
-        <a:font script="Sinh" typeface="Iskoola Pota"/>
-        <a:font script="Mong" typeface="Mongolian Baiti"/>
-        <a:font script="Viet" typeface="Arial"/>
-        <a:font script="Uigh" typeface="Microsoft Uighur"/>
-        <a:font script="Geor" typeface="Sylfaen"/>
-        <a:font script="Armn" typeface="Arial"/>
-        <a:font script="Bugi" typeface="Leelawadee UI"/>
-        <a:font script="Bopo" typeface="Microsoft JhengHei"/>
-        <a:font script="Java" typeface="Javanese Text"/>
-        <a:font script="Lisu" typeface="Segoe UI"/>
-        <a:font script="Mymr" typeface="Myanmar Text"/>
-        <a:font script="Nkoo" typeface="Ebrima"/>
-        <a:font script="Olck" typeface="Nirmala UI"/>
-        <a:font script="Osma" typeface="Ebrima"/>
-        <a:font script="Phag" typeface="Phagspa"/>
-        <a:font script="Syrn" typeface="Estrangelo Edessa"/>
-        <a:font script="Syrj" typeface="Estrangelo Edessa"/>
-        <a:font script="Syre" typeface="Estrangelo Edessa"/>
-        <a:font script="Sora" typeface="Nirmala UI"/>
-        <a:font script="Tale" typeface="Microsoft Tai Le"/>
-        <a:font script="Talu" typeface="Microsoft New Tai Lue"/>
-        <a:font script="Tfng" typeface="Ebrima"/>
-      </a:minorFont>
-    </a:fontScheme>
-    <a:fmtScheme name="Office">
-      <a:fillStyleLst>
-        <a:solidFill>
-          <a:schemeClr val="phClr"/>
-        </a:solidFill>
-        <a:gradFill rotWithShape="1">
-          <a:gsLst>
-            <a:gs pos="0">
-              <a:schemeClr val="phClr">
-                <a:lumMod val="110000"/>
-                <a:satMod val="105000"/>
-                <a:tint val="67000"/>
-              </a:schemeClr>
-            </a:gs>
-            <a:gs pos="50000">
-              <a:schemeClr val="phClr">
-                <a:lumMod val="105000"/>
-                <a:satMod val="103000"/>
-                <a:tint val="73000"/>
-              </a:schemeClr>
-            </a:gs>
-            <a:gs pos="100000">
-              <a:schemeClr val="phClr">
-                <a:lumMod val="105000"/>
-                <a:satMod val="109000"/>
-                <a:tint val="81000"/>
-              </a:schemeClr>
-            </a:gs>
-          </a:gsLst>
-          <a:lin ang="5400000" scaled="0"/>
-        </a:gradFill>
-        <a:gradFill rotWithShape="1">
-          <a:gsLst>
-            <a:gs pos="0">
-              <a:schemeClr val="phClr">
-                <a:satMod val="103000"/>
-                <a:lumMod val="102000"/>
-                <a:tint val="94000"/>
-              </a:schemeClr>
-            </a:gs>
-            <a:gs pos="50000">
-              <a:schemeClr val="phClr">
-                <a:satMod val="110000"/>
-                <a:lumMod val="100000"/>
-                <a:shade val="100000"/>
-              </a:schemeClr>
-            </a:gs>
-            <a:gs pos="100000">
-              <a:schemeClr val="phClr">
-                <a:lumMod val="99000"/>
-                <a:satMod val="120000"/>
-                <a:shade val="78000"/>
-              </a:schemeClr>
-            </a:gs>
-          </a:gsLst>
-          <a:lin ang="5400000" scaled="0"/>
-        </a:gradFill>
-      </a:fillStyleLst>
-      <a:lnStyleLst>
-        <a:ln w="12700" cap="flat" cmpd="sng" algn="ctr">
-          <a:solidFill>
-            <a:schemeClr val="phClr"/>
-          </a:solidFill>
-          <a:prstDash val="solid"/>
-          <a:miter lim="800000"/>
-        </a:ln>
-        <a:ln w="19050" cap="flat" cmpd="sng" algn="ctr">
-          <a:solidFill>
-            <a:schemeClr val="phClr"/>
-          </a:solidFill>
-          <a:prstDash val="solid"/>
-          <a:miter lim="800000"/>
-        </a:ln>
-        <a:ln w="25400" cap="flat" cmpd="sng" algn="ctr">
-          <a:solidFill>
-            <a:schemeClr val="phClr"/>
-          </a:solidFill>
-          <a:prstDash val="solid"/>
-          <a:miter lim="800000"/>
-        </a:ln>
-      </a:lnStyleLst>
-      <a:effectStyleLst>
-        <a:effectStyle>
-          <a:effectLst/>
-        </a:effectStyle>
-        <a:effectStyle>
-          <a:effectLst/>
-        </a:effectStyle>
-        <a:effectStyle>
-          <a:effectLst>
-            <a:outerShdw blurRad="57150" dist="19050" dir="5400000" algn="ctr" rotWithShape="0">
-              <a:srgbClr val="000000">
-                <a:alpha val="63000"/>
-              </a:srgbClr>
-            </a:outerShdw>
-          </a:effectLst>
-        </a:effectStyle>
-      </a:effectStyleLst>
-      <a:bgFillStyleLst>
-        <a:solidFill>
-          <a:schemeClr val="phClr"/>
-        </a:solidFill>
-        <a:solidFill>
-          <a:schemeClr val="phClr">
-            <a:tint val="95000"/>
-            <a:satMod val="170000"/>
-          </a:schemeClr>
-        </a:solidFill>
-        <a:gradFill rotWithShape="1">
-          <a:gsLst>
-            <a:gs pos="0">
-              <a:schemeClr val="phClr">
-                <a:tint val="93000"/>
-                <a:satMod val="150000"/>
-                <a:shade val="98000"/>
-                <a:lumMod val="102000"/>
-              </a:schemeClr>
-            </a:gs>
-            <a:gs pos="50000">
-              <a:schemeClr val="phClr">
-                <a:tint val="98000"/>
-                <a:satMod val="130000"/>
-                <a:shade val="90000"/>
-                <a:lumMod val="103000"/>
-              </a:schemeClr>
-            </a:gs>
-            <a:gs pos="100000">
-              <a:schemeClr val="phClr">
-                <a:shade val="63000"/>
-                <a:satMod val="120000"/>
-              </a:schemeClr>
-            </a:gs>
-          </a:gsLst>
-          <a:lin ang="5400000" scaled="0"/>
-        </a:gradFill>
-      </a:bgFillStyleLst>
-    </a:fmtScheme>
-  </a:themeElements>
-  <a:objectDefaults>
-    <a:lnDef>
-      <a:spPr/>
-      <a:bodyPr/>
-      <a:lstStyle/>
-      <a:style>
-        <a:lnRef idx="2">
-          <a:schemeClr val="accent1"/>
-        </a:lnRef>
-        <a:fillRef idx="0">
-          <a:schemeClr val="accent1"/>
-        </a:fillRef>
-        <a:effectRef idx="1">
-          <a:schemeClr val="accent1"/>
-        </a:effectRef>
-        <a:fontRef idx="minor">
-          <a:schemeClr val="tx1"/>
-        </a:fontRef>
-      </a:style>
-    </a:lnDef>
-  </a:objectDefaults>
-  <a:extraClrSchemeLst/>
-  <a:extLst>
-    <a:ext uri="{05A4C25C-085E-4340-85A3-A5531E510DB2}">
-      <thm15:themeFamily xmlns:thm15="http://schemas.microsoft.com/office/thememl/2012/main" name="Office Theme" id="{2E142A2C-CD16-42D6-873A-C26D2A0506FA}" vid="{1BDDFF52-6CD6-40A5-AB3C-68EB2F1E4D0A}"/>
-    </a:ext>
-  </a:extLst>
-</a:theme>
 </file>
</xml_diff>

<commit_message>
Split bare-Pod explanation into its own slide, drop cross-slide references
The "why doesn't it come back" explanation was crammed into Slide 13
alongside the Pod manifest and delete experiment, making that slide's
narration too long. It's now its own slide (14, "Why Doesn't It Come
Back?") with a dedicated flow diagram, and the rest of the deck
renumbers accordingly (23 slides total, was 22).

Also removed explicit forward/backward references to other slides
("Slide 8", "next slide", "two slides ago", etc.) from speaker notes
and narration so each slide reads as self-contained.

Co-Authored-By: Claude Sonnet 5 <noreply@anthropic.com>
</commit_message>
<xml_diff>
--- a/docs/presentations/KubernetesFundamentals/KubernetesFundamentals.pptx
+++ b/docs/presentations/KubernetesFundamentals/KubernetesFundamentals.pptx
@@ -27,9 +27,10 @@
     <p:sldId id="275" r:id="rId21"/>
     <p:sldId id="276" r:id="rId22"/>
     <p:sldId id="277" r:id="rId23"/>
+    <p:sldId id="278" r:id="rId24"/>
   </p:sldIdLst>
   <p:notesMasterIdLst>
-    <p:notesMasterId r:id="rId24"/>
+    <p:notesMasterId r:id="rId25"/>
   </p:notesMasterIdLst>
   <p:sldSz cx="12192000" cy="6858000"/>
   <p:notesSz cx="6858000" cy="12192000"/>
@@ -699,7 +700,7 @@
           <a:p>
             <a:r>
               <a:rPr lang="en-US" dirty="0"/>
-              <a:t>Trace one concrete request end to end so the component table on the previous slide stops being abstract. Call out the pod-before-container ordering explicitly — it's a detail worth remembering.</a:t>
+              <a:t>Trace one concrete request end to end so the control-plane components stop being abstract. Call out the pod-before-container ordering explicitly — it's a detail worth remembering.</a:t>
             </a:r>
             <a:endParaRPr lang="en-US" dirty="0"/>
           </a:p>
@@ -875,7 +876,7 @@
           <a:p>
             <a:r>
               <a:rPr lang="en-US" dirty="0"/>
-              <a:t>This is the "aha" moment of the deck for a first-time reader: run the delete experiment and watch the Pod not come back. Frame it as a problem statement, not a dead end — Slide 14 is the fix.</a:t>
+              <a:t>This is the "aha" moment of the deck for a first-time reader: run the delete experiment and watch the Pod not come back. Frame it as a problem statement, not a dead end — the breakdown of why follows immediately.</a:t>
             </a:r>
             <a:endParaRPr lang="en-US" dirty="0"/>
           </a:p>
@@ -963,7 +964,7 @@
           <a:p>
             <a:r>
               <a:rPr lang="en-US" dirty="0"/>
-              <a:t>Repeat the exact delete experiment from Slide 13, but this time on a Deployment-managed Pod — the contrast is the whole point. Tie the self-healing behavior explicitly back to Slide 8's reconciliation loop.</a:t>
+              <a:t>This is the direct answer to "but I defined it in YAML" — the payoff for the whole deck's declarative-vs-controller distinction. Land it slowly; this is the moment that makes everything else click.</a:t>
             </a:r>
             <a:endParaRPr lang="en-US" dirty="0"/>
           </a:p>
@@ -1051,7 +1052,7 @@
           <a:p>
             <a:r>
               <a:rPr lang="en-US" dirty="0"/>
-              <a:t>Fourth and final focus area — the last two object types, then the capstone that wires everything together.</a:t>
+              <a:t>Repeat the exact delete experiment, but this time on a Deployment-managed Pod — the contrast with the bare-Pod case is the whole point. This is the concrete payoff: the ReplicaSet controller, not apply, is what runs the loop.</a:t>
             </a:r>
             <a:endParaRPr lang="en-US" dirty="0"/>
           </a:p>
@@ -1139,7 +1140,7 @@
           <a:p>
             <a:r>
               <a:rPr lang="en-US" dirty="0"/>
-              <a:t>Anchor this in the fact that the reader just watched a Pod's IP change in the previous section — a Service is the direct answer to that instability.</a:t>
+              <a:t>Fourth and final focus area — the last two object types, then the capstone that wires everything together.</a:t>
             </a:r>
             <a:endParaRPr lang="en-US" dirty="0"/>
           </a:p>
@@ -1227,7 +1228,7 @@
           <a:p>
             <a:r>
               <a:rPr lang="en-US" dirty="0"/>
-              <a:t>Keep this conceptual per the high-level depth — one short illustrative snippet, not a manifest walkthrough. The base64-is-not-encryption point is the one thing to land hard.</a:t>
+              <a:t>Anchor this in the fact that Pod IPs change on every delete/recreate — a Service is the direct answer to that instability.</a:t>
             </a:r>
             <a:endParaRPr lang="en-US" dirty="0"/>
           </a:p>
@@ -1315,7 +1316,7 @@
           <a:p>
             <a:r>
               <a:rPr lang="en-US" dirty="0"/>
-              <a:t>This is where all four focus areas visibly compose into TUTORIAL.md's Module 5. The DNS-name-per-Service detail and the deploy-order gotcha are the two things worth remembering here.</a:t>
+              <a:t>Keep this conceptual per the high-level depth — one short illustrative snippet, not a manifest walkthrough. The base64-is-not-encryption point is the one thing to land hard.</a:t>
             </a:r>
             <a:endParaRPr lang="en-US" dirty="0"/>
           </a:p>
@@ -1403,7 +1404,7 @@
           <a:p>
             <a:r>
               <a:rPr lang="en-US" dirty="0"/>
-              <a:t>Frame this as "things that were harder than expected" for an onboarding audience — real failure modes pulled straight from the tutorial's own troubleshooting notes, not hypotheticals.</a:t>
+              <a:t>This is where all four focus areas visibly compose into TUTORIAL.md's Module 5. The DNS-name-per-Service detail and the deploy-order gotcha are the two things worth remembering here.</a:t>
             </a:r>
             <a:endParaRPr lang="en-US" dirty="0"/>
           </a:p>
@@ -1579,7 +1580,7 @@
           <a:p>
             <a:r>
               <a:rPr lang="en-US" dirty="0"/>
-              <a:t>Land the single unifying idea before handing off to TUTORIAL.md — everything walked through today is one mechanism wearing different hats.</a:t>
+              <a:t>Frame this as "things that were harder than expected" for an onboarding audience — real failure modes pulled straight from the tutorial's own troubleshooting notes, not hypotheticals.</a:t>
             </a:r>
             <a:endParaRPr lang="en-US" dirty="0"/>
           </a:p>
@@ -1667,7 +1668,7 @@
           <a:p>
             <a:r>
               <a:rPr lang="en-US" dirty="0"/>
-              <a:t>Explicit handoff — this is the deck's actual job, to end with the reader opening a terminal and starting Module 0 with the mental model already in place.</a:t>
+              <a:t>Land the single unifying idea before handing off to TUTORIAL.md — everything walked through today is one mechanism wearing different hats.</a:t>
             </a:r>
             <a:endParaRPr lang="en-US" dirty="0"/>
           </a:p>
@@ -1755,7 +1756,7 @@
           <a:p>
             <a:r>
               <a:rPr lang="en-US" dirty="0"/>
-              <a:t>Three takeaways, no more — the last line is the one thing worth remembering walking into Module 1.</a:t>
+              <a:t>Explicit handoff — this is the deck's actual job, to end with the reader opening a terminal and starting Module 0 with the mental model already in place.</a:t>
             </a:r>
             <a:endParaRPr lang="en-US" dirty="0"/>
           </a:p>
@@ -1779,6 +1780,94 @@
             <a:fld id="{F7021451-1387-4CA6-816F-3879F97B5CBC}" type="slidenum">
               <a:rPr lang="en-US"/>
               <a:t>22</a:t>
+            </a:fld>
+            <a:endParaRPr lang="en-US"/>
+          </a:p>
+        </p:txBody>
+      </p:sp>
+    </p:spTree>
+    <p:extLst>
+      <p:ext uri="{BB962C8B-B14F-4D97-AF65-F5344CB8AC3E}">
+        <p14:creationId xmlns:p14="http://schemas.microsoft.com/office/powerpoint/2010/main" val="1024086991"/>
+      </p:ext>
+    </p:extLst>
+  </p:cSld>
+  <p:clrMapOvr>
+    <a:masterClrMapping/>
+  </p:clrMapOvr>
+</p:notes>
+</file>
+
+<file path=ppt/notesSlides/notesSlide23.xml><?xml version="1.0" encoding="utf-8"?>
+<p:notes xmlns:a="http://schemas.openxmlformats.org/drawingml/2006/main" xmlns:r="http://schemas.openxmlformats.org/officeDocument/2006/relationships" xmlns:p="http://schemas.openxmlformats.org/presentationml/2006/main">
+  <p:cSld>
+    <p:spTree>
+      <p:nvGrpSpPr>
+        <p:cNvPr id="1" name=""/>
+        <p:cNvGrpSpPr/>
+        <p:nvPr/>
+      </p:nvGrpSpPr>
+      <p:grpSpPr>
+        <a:xfrm>
+          <a:off x="0" y="0"/>
+          <a:ext cx="0" cy="0"/>
+          <a:chOff x="0" y="0"/>
+          <a:chExt cx="0" cy="0"/>
+        </a:xfrm>
+      </p:grpSpPr>
+      <p:sp>
+        <p:nvSpPr>
+          <p:cNvPr id="2" name="Slide Image Placeholder 1"/>
+          <p:cNvSpPr>
+            <a:spLocks noGrp="1" noRot="1" noChangeAspect="1"/>
+          </p:cNvSpPr>
+          <p:nvPr>
+            <p:ph type="sldImg"/>
+          </p:nvPr>
+        </p:nvSpPr>
+        <p:spPr/>
+      </p:sp>
+      <p:sp>
+        <p:nvSpPr>
+          <p:cNvPr id="3" name="Notes Placeholder 2"/>
+          <p:cNvSpPr>
+            <a:spLocks noGrp="1"/>
+          </p:cNvSpPr>
+          <p:nvPr>
+            <p:ph type="body" idx="1"/>
+          </p:nvPr>
+        </p:nvSpPr>
+        <p:spPr/>
+        <p:txBody>
+          <a:bodyPr/>
+          <a:lstStyle/>
+          <a:p>
+            <a:r>
+              <a:rPr lang="en-US" dirty="0"/>
+              <a:t>Three takeaways, no more — the last line is the one thing worth remembering walking into Module 1.</a:t>
+            </a:r>
+            <a:endParaRPr lang="en-US" dirty="0"/>
+          </a:p>
+        </p:txBody>
+      </p:sp>
+      <p:sp>
+        <p:nvSpPr>
+          <p:cNvPr id="4" name="Slide Number Placeholder 3"/>
+          <p:cNvSpPr>
+            <a:spLocks noGrp="1"/>
+          </p:cNvSpPr>
+          <p:nvPr>
+            <p:ph type="sldNum" sz="quarter" idx="10"/>
+          </p:nvPr>
+        </p:nvSpPr>
+        <p:spPr/>
+        <p:txBody>
+          <a:bodyPr/>
+          <a:lstStyle/>
+          <a:p>
+            <a:fld id="{F7021451-1387-4CA6-816F-3879F97B5CBC}" type="slidenum">
+              <a:rPr lang="en-US"/>
+              <a:t>23</a:t>
             </a:fld>
             <a:endParaRPr lang="en-US"/>
           </a:p>
@@ -2371,7 +2460,7 @@
           <a:p>
             <a:r>
               <a:rPr lang="en-US" dirty="0"/>
-              <a:t>Second focus area — now open the door from Slide 4 and name every piece behind it.</a:t>
+              <a:t>Second focus area — open the API server door and name every piece behind it.</a:t>
             </a:r>
             <a:endParaRPr lang="en-US" dirty="0"/>
           </a:p>
@@ -5048,7 +5137,7 @@
                 <a:ea typeface="Trebuchet MS" pitchFamily="34" charset="-122"/>
                 <a:cs typeface="Trebuchet MS" pitchFamily="34" charset="-120"/>
               </a:rPr>
-              <a:t>labels do nothing by themselves yet — but the next slide depends entirely on them</a:t>
+              <a:t>labels are just a tag on the object — inert until something else reads them</a:t>
             </a:r>
             <a:endParaRPr lang="en-US" sz="1600" dirty="0"/>
           </a:p>
@@ -5128,7 +5217,7 @@
                 <a:ea typeface="Trebuchet MS" pitchFamily="34" charset="-122"/>
                 <a:cs typeface="Trebuchet MS" pitchFamily="34" charset="-120"/>
               </a:rPr>
-              <a:t>It does not come back — apply already exited; the YAML file is now inert, no controller is watching this Pod</a:t>
+              <a:t>It does not come back, even though you defined it in pod.yaml</a:t>
             </a:r>
             <a:endParaRPr lang="en-US" sz="1600" dirty="0"/>
           </a:p>
@@ -5263,7 +5352,7 @@
                 <a:ea typeface="Arial Black" pitchFamily="34" charset="-122"/>
                 <a:cs typeface="Arial Black" pitchFamily="34" charset="-120"/>
               </a:rPr>
-              <a:t>Deployment → ReplicaSet → Pod</a:t>
+              <a:t>Why Doesn't It Come Back?</a:t>
             </a:r>
             <a:endParaRPr lang="en-US" sz="3000" dirty="0"/>
           </a:p>
@@ -5302,12 +5391,12 @@
         </p:nvSpPr>
         <p:spPr>
           <a:xfrm>
-            <a:off x="457200" y="1840230"/>
-            <a:ext cx="3526536" cy="653796"/>
+            <a:off x="457200" y="1901952"/>
+            <a:ext cx="3526536" cy="804672"/>
           </a:xfrm>
           <a:prstGeom prst="roundRect">
             <a:avLst>
-              <a:gd name="adj" fmla="val 13986"/>
+              <a:gd name="adj" fmla="val 11364"/>
             </a:avLst>
           </a:prstGeom>
           <a:solidFill>
@@ -5329,8 +5418,8 @@
         </p:nvSpPr>
         <p:spPr>
           <a:xfrm>
-            <a:off x="457200" y="1840230"/>
-            <a:ext cx="3526536" cy="653796"/>
+            <a:off x="457200" y="1901952"/>
+            <a:ext cx="3526536" cy="804672"/>
           </a:xfrm>
           <a:prstGeom prst="rect">
             <a:avLst/>
@@ -5354,7 +5443,7 @@
                 <a:ea typeface="Trebuchet MS" pitchFamily="34" charset="-122"/>
                 <a:cs typeface="Trebuchet MS" pitchFamily="34" charset="-120"/>
               </a:rPr>
-              <a:t>Deployment</a:t>
+              <a:t>kubectl apply</a:t>
             </a:r>
             <a:endParaRPr lang="en-US" sz="1200" dirty="0"/>
           </a:p>
@@ -5368,8 +5457,8 @@
         </p:nvSpPr>
         <p:spPr>
           <a:xfrm>
-            <a:off x="3983736" y="1840230"/>
-            <a:ext cx="347472" cy="653796"/>
+            <a:off x="3983736" y="1901952"/>
+            <a:ext cx="347472" cy="804672"/>
           </a:xfrm>
           <a:prstGeom prst="rect">
             <a:avLst/>
@@ -5407,12 +5496,12 @@
         </p:nvSpPr>
         <p:spPr>
           <a:xfrm>
-            <a:off x="4331208" y="1840230"/>
-            <a:ext cx="3526536" cy="653796"/>
+            <a:off x="4331208" y="1901952"/>
+            <a:ext cx="3526536" cy="804672"/>
           </a:xfrm>
           <a:prstGeom prst="roundRect">
             <a:avLst>
-              <a:gd name="adj" fmla="val 13986"/>
+              <a:gd name="adj" fmla="val 11364"/>
             </a:avLst>
           </a:prstGeom>
           <a:solidFill>
@@ -5434,8 +5523,8 @@
         </p:nvSpPr>
         <p:spPr>
           <a:xfrm>
-            <a:off x="4331208" y="1840230"/>
-            <a:ext cx="3526536" cy="653796"/>
+            <a:off x="4331208" y="1901952"/>
+            <a:ext cx="3526536" cy="804672"/>
           </a:xfrm>
           <a:prstGeom prst="rect">
             <a:avLst/>
@@ -5459,7 +5548,7 @@
                 <a:ea typeface="Trebuchet MS" pitchFamily="34" charset="-122"/>
                 <a:cs typeface="Trebuchet MS" pitchFamily="34" charset="-120"/>
               </a:rPr>
-              <a:t>ReplicaSet</a:t>
+              <a:t>Pod created</a:t>
             </a:r>
             <a:endParaRPr lang="en-US" sz="1200" dirty="0"/>
           </a:p>
@@ -5473,8 +5562,8 @@
         </p:nvSpPr>
         <p:spPr>
           <a:xfrm>
-            <a:off x="7857744" y="1840230"/>
-            <a:ext cx="347472" cy="653796"/>
+            <a:off x="7857744" y="1901952"/>
+            <a:ext cx="347472" cy="804672"/>
           </a:xfrm>
           <a:prstGeom prst="rect">
             <a:avLst/>
@@ -5512,18 +5601,18 @@
         </p:nvSpPr>
         <p:spPr>
           <a:xfrm>
-            <a:off x="8205216" y="1840230"/>
-            <a:ext cx="3526536" cy="653796"/>
+            <a:off x="8205216" y="1901952"/>
+            <a:ext cx="3526536" cy="804672"/>
           </a:xfrm>
           <a:prstGeom prst="roundRect">
             <a:avLst>
-              <a:gd name="adj" fmla="val 13986"/>
+              <a:gd name="adj" fmla="val 11364"/>
             </a:avLst>
           </a:prstGeom>
           <a:solidFill>
-            <a:srgbClr val="B8ECF5"/>
+            <a:srgbClr val="007A90"/>
           </a:solidFill>
-          <a:ln w="19050">
+          <a:ln w="31750">
             <a:solidFill>
               <a:srgbClr val="007A90"/>
             </a:solidFill>
@@ -5539,8 +5628,8 @@
         </p:nvSpPr>
         <p:spPr>
           <a:xfrm>
-            <a:off x="8205216" y="1840230"/>
-            <a:ext cx="3526536" cy="653796"/>
+            <a:off x="8205216" y="1901952"/>
+            <a:ext cx="3526536" cy="804672"/>
           </a:xfrm>
           <a:prstGeom prst="rect">
             <a:avLst/>
@@ -5558,228 +5647,45 @@
             <a:r>
               <a:rPr lang="en-US" sz="1200" b="1" dirty="0">
                 <a:solidFill>
-                  <a:srgbClr val="0A1A1C"/>
-                </a:solidFill>
-                <a:latin typeface="Trebuchet MS" pitchFamily="34" charset="0"/>
-                <a:ea typeface="Trebuchet MS" pitchFamily="34" charset="-122"/>
-                <a:cs typeface="Trebuchet MS" pitchFamily="34" charset="-120"/>
-              </a:rPr>
-              <a:t>Pod(s)</a:t>
+                  <a:srgbClr val="FFFFFF"/>
+                </a:solidFill>
+                <a:latin typeface="Trebuchet MS" pitchFamily="34" charset="0"/>
+                <a:ea typeface="Trebuchet MS" pitchFamily="34" charset="-122"/>
+                <a:cs typeface="Trebuchet MS" pitchFamily="34" charset="-120"/>
+              </a:rPr>
+              <a:t>apply exits</a:t>
             </a:r>
             <a:endParaRPr lang="en-US" sz="1200" dirty="0"/>
           </a:p>
-        </p:txBody>
-      </p:sp>
-      <p:sp>
-        <p:nvSpPr>
-          <p:cNvPr id="14" name="Shape 12"/>
-          <p:cNvSpPr/>
-          <p:nvPr/>
-        </p:nvSpPr>
-        <p:spPr>
-          <a:xfrm>
-            <a:off x="457200" y="2944368"/>
-            <a:ext cx="6040984" cy="3639312"/>
-          </a:xfrm>
-          <a:prstGeom prst="rect">
-            <a:avLst/>
-          </a:prstGeom>
-          <a:solidFill>
-            <a:srgbClr val="C0EDF5"/>
-          </a:solidFill>
-          <a:ln w="9525">
-            <a:solidFill>
-              <a:srgbClr val="007A90"/>
-            </a:solidFill>
-            <a:prstDash val="solid"/>
-          </a:ln>
-        </p:spPr>
-      </p:sp>
-      <p:sp>
-        <p:nvSpPr>
-          <p:cNvPr id="15" name="Text 13"/>
-          <p:cNvSpPr/>
-          <p:nvPr/>
-        </p:nvSpPr>
-        <p:spPr>
-          <a:xfrm>
-            <a:off x="640080" y="3081528"/>
-            <a:ext cx="5675224" cy="3364992"/>
-          </a:xfrm>
-          <a:prstGeom prst="rect">
-            <a:avLst/>
-          </a:prstGeom>
-          <a:noFill/>
-          <a:ln/>
-        </p:spPr>
-        <p:txBody>
-          <a:bodyPr wrap="none" rtlCol="0" anchor="t"/>
-          <a:lstStyle/>
-          <a:p>
-            <a:pPr indent="0" marL="0">
-              <a:buNone/>
-            </a:pPr>
-            <a:r>
-              <a:rPr lang="en-US" sz="1300" dirty="0">
-                <a:solidFill>
-                  <a:srgbClr val="003848"/>
-                </a:solidFill>
-                <a:latin typeface="Courier New" pitchFamily="34" charset="0"/>
-                <a:ea typeface="Courier New" pitchFamily="34" charset="-122"/>
-                <a:cs typeface="Courier New" pitchFamily="34" charset="-120"/>
-              </a:rPr>
-              <a:t>spec:</a:t>
-            </a:r>
-            <a:endParaRPr lang="en-US" sz="1300" dirty="0"/>
-          </a:p>
-          <a:p>
-            <a:pPr indent="0" marL="0">
-              <a:buNone/>
-            </a:pPr>
-            <a:r>
-              <a:rPr lang="en-US" sz="1300" dirty="0">
-                <a:solidFill>
-                  <a:srgbClr val="003848"/>
-                </a:solidFill>
-                <a:latin typeface="Courier New" pitchFamily="34" charset="0"/>
-                <a:ea typeface="Courier New" pitchFamily="34" charset="-122"/>
-                <a:cs typeface="Courier New" pitchFamily="34" charset="-120"/>
-              </a:rPr>
-              <a:t>  replicas: 3</a:t>
-            </a:r>
-            <a:endParaRPr lang="en-US" sz="1300" dirty="0"/>
-          </a:p>
-          <a:p>
-            <a:pPr indent="0" marL="0">
-              <a:buNone/>
-            </a:pPr>
-            <a:r>
-              <a:rPr lang="en-US" sz="1300" dirty="0">
-                <a:solidFill>
-                  <a:srgbClr val="003848"/>
-                </a:solidFill>
-                <a:latin typeface="Courier New" pitchFamily="34" charset="0"/>
-                <a:ea typeface="Courier New" pitchFamily="34" charset="-122"/>
-                <a:cs typeface="Courier New" pitchFamily="34" charset="-120"/>
-              </a:rPr>
-              <a:t>  selector:</a:t>
-            </a:r>
-            <a:endParaRPr lang="en-US" sz="1300" dirty="0"/>
-          </a:p>
-          <a:p>
-            <a:pPr indent="0" marL="0">
-              <a:buNone/>
-            </a:pPr>
-            <a:r>
-              <a:rPr lang="en-US" sz="1300" dirty="0">
-                <a:solidFill>
-                  <a:srgbClr val="003848"/>
-                </a:solidFill>
-                <a:latin typeface="Courier New" pitchFamily="34" charset="0"/>
-                <a:ea typeface="Courier New" pitchFamily="34" charset="-122"/>
-                <a:cs typeface="Courier New" pitchFamily="34" charset="-120"/>
-              </a:rPr>
-              <a:t>    matchLabels:</a:t>
-            </a:r>
-            <a:endParaRPr lang="en-US" sz="1300" dirty="0"/>
-          </a:p>
-          <a:p>
-            <a:pPr indent="0" marL="0">
-              <a:buNone/>
-            </a:pPr>
-            <a:r>
-              <a:rPr lang="en-US" sz="1300" dirty="0">
-                <a:solidFill>
-                  <a:srgbClr val="003848"/>
-                </a:solidFill>
-                <a:latin typeface="Courier New" pitchFamily="34" charset="0"/>
-                <a:ea typeface="Courier New" pitchFamily="34" charset="-122"/>
-                <a:cs typeface="Courier New" pitchFamily="34" charset="-120"/>
-              </a:rPr>
-              <a:t>      app: hello</a:t>
-            </a:r>
-            <a:endParaRPr lang="en-US" sz="1300" dirty="0"/>
-          </a:p>
-          <a:p>
-            <a:pPr indent="0" marL="0">
-              <a:buNone/>
-            </a:pPr>
-            <a:r>
-              <a:rPr lang="en-US" sz="1300" dirty="0">
-                <a:solidFill>
-                  <a:srgbClr val="003848"/>
-                </a:solidFill>
-                <a:latin typeface="Courier New" pitchFamily="34" charset="0"/>
-                <a:ea typeface="Courier New" pitchFamily="34" charset="-122"/>
-                <a:cs typeface="Courier New" pitchFamily="34" charset="-120"/>
-              </a:rPr>
-              <a:t>  template:      # a full Pod spec, nested one level deeper</a:t>
-            </a:r>
-            <a:endParaRPr lang="en-US" sz="1300" dirty="0"/>
-          </a:p>
-          <a:p>
-            <a:pPr indent="0" marL="0">
-              <a:buNone/>
-            </a:pPr>
-            <a:r>
-              <a:rPr lang="en-US" sz="1300" dirty="0">
-                <a:solidFill>
-                  <a:srgbClr val="003848"/>
-                </a:solidFill>
-                <a:latin typeface="Courier New" pitchFamily="34" charset="0"/>
-                <a:ea typeface="Courier New" pitchFamily="34" charset="-122"/>
-                <a:cs typeface="Courier New" pitchFamily="34" charset="-120"/>
-              </a:rPr>
-              <a:t>    metadata:</a:t>
-            </a:r>
-            <a:endParaRPr lang="en-US" sz="1300" dirty="0"/>
-          </a:p>
-          <a:p>
-            <a:pPr indent="0" marL="0">
-              <a:buNone/>
-            </a:pPr>
-            <a:r>
-              <a:rPr lang="en-US" sz="1300" dirty="0">
-                <a:solidFill>
-                  <a:srgbClr val="003848"/>
-                </a:solidFill>
-                <a:latin typeface="Courier New" pitchFamily="34" charset="0"/>
-                <a:ea typeface="Courier New" pitchFamily="34" charset="-122"/>
-                <a:cs typeface="Courier New" pitchFamily="34" charset="-120"/>
-              </a:rPr>
-              <a:t>      labels:</a:t>
-            </a:r>
-            <a:endParaRPr lang="en-US" sz="1300" dirty="0"/>
-          </a:p>
-          <a:p>
-            <a:pPr indent="0" marL="0">
-              <a:buNone/>
-            </a:pPr>
-            <a:r>
-              <a:rPr lang="en-US" sz="1300" dirty="0">
-                <a:solidFill>
-                  <a:srgbClr val="003848"/>
-                </a:solidFill>
-                <a:latin typeface="Courier New" pitchFamily="34" charset="0"/>
-                <a:ea typeface="Courier New" pitchFamily="34" charset="-122"/>
-                <a:cs typeface="Courier New" pitchFamily="34" charset="-120"/>
-              </a:rPr>
-              <a:t>        app: hello</a:t>
-            </a:r>
-            <a:endParaRPr lang="en-US" sz="1300" dirty="0"/>
-          </a:p>
-        </p:txBody>
-      </p:sp>
-      <p:sp>
-        <p:nvSpPr>
-          <p:cNvPr id="16" name="Text 14"/>
-          <p:cNvSpPr/>
-          <p:nvPr/>
-        </p:nvSpPr>
-        <p:spPr>
-          <a:xfrm>
-            <a:off x="6818224" y="2944368"/>
-            <a:ext cx="4913528" cy="909828"/>
+          <a:p>
+            <a:pPr algn="ctr" indent="0" marL="0">
+              <a:buNone/>
+            </a:pPr>
+            <a:r>
+              <a:rPr lang="en-US" sz="1200" b="1" dirty="0">
+                <a:solidFill>
+                  <a:srgbClr val="FFFFFF"/>
+                </a:solidFill>
+                <a:latin typeface="Trebuchet MS" pitchFamily="34" charset="0"/>
+                <a:ea typeface="Trebuchet MS" pitchFamily="34" charset="-122"/>
+                <a:cs typeface="Trebuchet MS" pitchFamily="34" charset="-120"/>
+              </a:rPr>
+              <a:t>(nothing left running)</a:t>
+            </a:r>
+            <a:endParaRPr lang="en-US" sz="1200" dirty="0"/>
+          </a:p>
+        </p:txBody>
+      </p:sp>
+      <p:sp>
+        <p:nvSpPr>
+          <p:cNvPr id="14" name="Text 12"/>
+          <p:cNvSpPr/>
+          <p:nvPr/>
+        </p:nvSpPr>
+        <p:spPr>
+          <a:xfrm>
+            <a:off x="457200" y="3218688"/>
+            <a:ext cx="11274552" cy="672998"/>
           </a:xfrm>
           <a:prstGeom prst="rect">
             <a:avLst/>
@@ -5796,7 +5702,7 @@
               <a:buChar char="•"/>
             </a:pPr>
             <a:r>
-              <a:rPr lang="en-US" sz="1500" dirty="0">
+              <a:rPr lang="en-US" sz="1700" dirty="0">
                 <a:solidFill>
                   <a:srgbClr val="0A1A1C"/>
                 </a:solidFill>
@@ -5804,22 +5710,22 @@
                 <a:ea typeface="Trebuchet MS" pitchFamily="34" charset="-122"/>
                 <a:cs typeface="Trebuchet MS" pitchFamily="34" charset="-120"/>
               </a:rPr>
-              <a:t>Deployment doesn't run containers directly — it manages a ReplicaSet, and the ReplicaSet IS a controller: a background process maintaining a fixed Pod count</a:t>
-            </a:r>
-            <a:endParaRPr lang="en-US" sz="1500" dirty="0"/>
-          </a:p>
-        </p:txBody>
-      </p:sp>
-      <p:sp>
-        <p:nvSpPr>
-          <p:cNvPr id="17" name="Text 15"/>
-          <p:cNvSpPr/>
-          <p:nvPr/>
-        </p:nvSpPr>
-        <p:spPr>
-          <a:xfrm>
-            <a:off x="6818224" y="3854196"/>
-            <a:ext cx="4913528" cy="909828"/>
+              <a:t>apply runs exactly once: read the file, create the Pod, exit — nothing stays behind to keep enforcing it</a:t>
+            </a:r>
+            <a:endParaRPr lang="en-US" sz="1700" dirty="0"/>
+          </a:p>
+        </p:txBody>
+      </p:sp>
+      <p:sp>
+        <p:nvSpPr>
+          <p:cNvPr id="15" name="Text 13"/>
+          <p:cNvSpPr/>
+          <p:nvPr/>
+        </p:nvSpPr>
+        <p:spPr>
+          <a:xfrm>
+            <a:off x="457200" y="3891686"/>
+            <a:ext cx="11274552" cy="672998"/>
           </a:xfrm>
           <a:prstGeom prst="rect">
             <a:avLst/>
@@ -5836,7 +5742,7 @@
               <a:buChar char="•"/>
             </a:pPr>
             <a:r>
-              <a:rPr lang="en-US" sz="1500" dirty="0">
+              <a:rPr lang="en-US" sz="1700" dirty="0">
                 <a:solidFill>
                   <a:srgbClr val="0A1A1C"/>
                 </a:solidFill>
@@ -5844,22 +5750,22 @@
                 <a:ea typeface="Trebuchet MS" pitchFamily="34" charset="-122"/>
                 <a:cs typeface="Trebuchet MS" pitchFamily="34" charset="-120"/>
               </a:rPr>
-              <a:t>Delete one managed Pod: it disappears, a brand-new one (new random suffix) appears almost immediately — with no re-apply</a:t>
-            </a:r>
-            <a:endParaRPr lang="en-US" sz="1500" dirty="0"/>
-          </a:p>
-        </p:txBody>
-      </p:sp>
-      <p:sp>
-        <p:nvSpPr>
-          <p:cNvPr id="18" name="Text 16"/>
-          <p:cNvSpPr/>
-          <p:nvPr/>
-        </p:nvSpPr>
-        <p:spPr>
-          <a:xfrm>
-            <a:off x="6818224" y="4764024"/>
-            <a:ext cx="4913528" cy="909828"/>
+              <a:t>The Pod becomes a plain record in etcd with no controller attached to it</a:t>
+            </a:r>
+            <a:endParaRPr lang="en-US" sz="1700" dirty="0"/>
+          </a:p>
+        </p:txBody>
+      </p:sp>
+      <p:sp>
+        <p:nvSpPr>
+          <p:cNvPr id="16" name="Text 14"/>
+          <p:cNvSpPr/>
+          <p:nvPr/>
+        </p:nvSpPr>
+        <p:spPr>
+          <a:xfrm>
+            <a:off x="457200" y="4564685"/>
+            <a:ext cx="11274552" cy="672998"/>
           </a:xfrm>
           <a:prstGeom prst="rect">
             <a:avLst/>
@@ -5876,7 +5782,7 @@
               <a:buChar char="•"/>
             </a:pPr>
             <a:r>
-              <a:rPr lang="en-US" sz="1500" dirty="0">
+              <a:rPr lang="en-US" sz="1700" dirty="0">
                 <a:solidFill>
                   <a:srgbClr val="0A1A1C"/>
                 </a:solidFill>
@@ -5884,22 +5790,22 @@
                 <a:ea typeface="Trebuchet MS" pitchFamily="34" charset="-122"/>
                 <a:cs typeface="Trebuchet MS" pitchFamily="34" charset="-120"/>
               </a:rPr>
-              <a:t>This is the controller piece from Slide 8 made concrete — a bare Pod (Slide 13) has no such process watching it</a:t>
-            </a:r>
-            <a:endParaRPr lang="en-US" sz="1500" dirty="0"/>
-          </a:p>
-        </p:txBody>
-      </p:sp>
-      <p:sp>
-        <p:nvSpPr>
-          <p:cNvPr id="19" name="Text 17"/>
-          <p:cNvSpPr/>
-          <p:nvPr/>
-        </p:nvSpPr>
-        <p:spPr>
-          <a:xfrm>
-            <a:off x="6818224" y="5673852"/>
-            <a:ext cx="4913528" cy="909828"/>
+              <a:t>Nothing is asking "does hello-pod still exist?" on a loop, so nothing notices when the answer becomes no</a:t>
+            </a:r>
+            <a:endParaRPr lang="en-US" sz="1700" dirty="0"/>
+          </a:p>
+        </p:txBody>
+      </p:sp>
+      <p:sp>
+        <p:nvSpPr>
+          <p:cNvPr id="17" name="Text 15"/>
+          <p:cNvSpPr/>
+          <p:nvPr/>
+        </p:nvSpPr>
+        <p:spPr>
+          <a:xfrm>
+            <a:off x="457200" y="5237683"/>
+            <a:ext cx="11274552" cy="672998"/>
           </a:xfrm>
           <a:prstGeom prst="rect">
             <a:avLst/>
@@ -5916,7 +5822,7 @@
               <a:buChar char="•"/>
             </a:pPr>
             <a:r>
-              <a:rPr lang="en-US" sz="1500" dirty="0">
+              <a:rPr lang="en-US" sz="1700" dirty="0">
                 <a:solidFill>
                   <a:srgbClr val="0A1A1C"/>
                 </a:solidFill>
@@ -5924,9 +5830,49 @@
                 <a:ea typeface="Trebuchet MS" pitchFamily="34" charset="-122"/>
                 <a:cs typeface="Trebuchet MS" pitchFamily="34" charset="-120"/>
               </a:rPr>
-              <a:t>kubectl scale --replicas=5 just changes what "desired" means; the same controller loop does the rest</a:t>
-            </a:r>
-            <a:endParaRPr lang="en-US" sz="1500" dirty="0"/>
+              <a:t>pod.yaml on your laptop only mattered at the moment you ran apply — after that it has no ongoing connection to the cluster</a:t>
+            </a:r>
+            <a:endParaRPr lang="en-US" sz="1700" dirty="0"/>
+          </a:p>
+        </p:txBody>
+      </p:sp>
+      <p:sp>
+        <p:nvSpPr>
+          <p:cNvPr id="18" name="Text 16"/>
+          <p:cNvSpPr/>
+          <p:nvPr/>
+        </p:nvSpPr>
+        <p:spPr>
+          <a:xfrm>
+            <a:off x="457200" y="5910682"/>
+            <a:ext cx="11274552" cy="672998"/>
+          </a:xfrm>
+          <a:prstGeom prst="rect">
+            <a:avLst/>
+          </a:prstGeom>
+          <a:noFill/>
+          <a:ln/>
+        </p:spPr>
+        <p:txBody>
+          <a:bodyPr wrap="square" rtlCol="0" anchor="ctr"/>
+          <a:lstStyle/>
+          <a:p>
+            <a:pPr marL="254000" indent="-254000">
+              <a:buSzPct val="100000"/>
+              <a:buChar char="•"/>
+            </a:pPr>
+            <a:r>
+              <a:rPr lang="en-US" sz="1700" dirty="0">
+                <a:solidFill>
+                  <a:srgbClr val="0A1A1C"/>
+                </a:solidFill>
+                <a:latin typeface="Trebuchet MS" pitchFamily="34" charset="0"/>
+                <a:ea typeface="Trebuchet MS" pitchFamily="34" charset="-122"/>
+                <a:cs typeface="Trebuchet MS" pitchFamily="34" charset="-120"/>
+              </a:rPr>
+              <a:t>Not a bug — it's the exact gap a controller is built to close, which is exactly what a Deployment adds</a:t>
+            </a:r>
+            <a:endParaRPr lang="en-US" sz="1700" dirty="0"/>
           </a:p>
         </p:txBody>
       </p:sp>
@@ -5941,6 +5887,802 @@
 <file path=ppt/slides/slide15.xml><?xml version="1.0" encoding="utf-8"?>
 <p:sld xmlns:a="http://schemas.openxmlformats.org/drawingml/2006/main" xmlns:r="http://schemas.openxmlformats.org/officeDocument/2006/relationships" xmlns:p="http://schemas.openxmlformats.org/presentationml/2006/main">
   <p:cSld name="Slide 15">
+    <p:bg>
+      <p:bgPr>
+        <a:solidFill>
+          <a:srgbClr val="EAFCFF"/>
+        </a:solidFill>
+      </p:bgPr>
+    </p:bg>
+    <p:spTree>
+      <p:nvGrpSpPr>
+        <p:cNvPr id="1" name=""/>
+        <p:cNvGrpSpPr/>
+        <p:nvPr/>
+      </p:nvGrpSpPr>
+      <p:grpSpPr>
+        <a:xfrm>
+          <a:off x="0" y="0"/>
+          <a:ext cx="0" cy="0"/>
+          <a:chOff x="0" y="0"/>
+          <a:chExt cx="0" cy="0"/>
+        </a:xfrm>
+      </p:grpSpPr>
+      <p:sp>
+        <p:nvSpPr>
+          <p:cNvPr id="2" name="Shape 0"/>
+          <p:cNvSpPr/>
+          <p:nvPr/>
+        </p:nvSpPr>
+        <p:spPr>
+          <a:xfrm>
+            <a:off x="457200" y="201168"/>
+            <a:ext cx="1828800" cy="347472"/>
+          </a:xfrm>
+          <a:prstGeom prst="rect">
+            <a:avLst/>
+          </a:prstGeom>
+          <a:solidFill>
+            <a:srgbClr val="007A90"/>
+          </a:solidFill>
+          <a:ln w="9525">
+            <a:solidFill>
+              <a:srgbClr val="007A90"/>
+            </a:solidFill>
+            <a:prstDash val="solid"/>
+          </a:ln>
+        </p:spPr>
+      </p:sp>
+      <p:sp>
+        <p:nvSpPr>
+          <p:cNvPr id="3" name="Text 1"/>
+          <p:cNvSpPr/>
+          <p:nvPr/>
+        </p:nvSpPr>
+        <p:spPr>
+          <a:xfrm>
+            <a:off x="457200" y="201168"/>
+            <a:ext cx="1828800" cy="347472"/>
+          </a:xfrm>
+          <a:prstGeom prst="rect">
+            <a:avLst/>
+          </a:prstGeom>
+          <a:noFill/>
+          <a:ln/>
+        </p:spPr>
+        <p:txBody>
+          <a:bodyPr wrap="square" rtlCol="0" anchor="ctr"/>
+          <a:lstStyle/>
+          <a:p>
+            <a:pPr algn="ctr" indent="0" marL="0">
+              <a:buNone/>
+            </a:pPr>
+            <a:r>
+              <a:rPr lang="en-US" sz="1200" b="1" spc="50" kern="0" dirty="0">
+                <a:solidFill>
+                  <a:srgbClr val="FFFFFF"/>
+                </a:solidFill>
+                <a:latin typeface="Trebuchet MS" pitchFamily="34" charset="0"/>
+                <a:ea typeface="Trebuchet MS" pitchFamily="34" charset="-122"/>
+                <a:cs typeface="Trebuchet MS" pitchFamily="34" charset="-120"/>
+              </a:rPr>
+              <a:t>KUBERNETES</a:t>
+            </a:r>
+            <a:endParaRPr lang="en-US" sz="1200" dirty="0"/>
+          </a:p>
+        </p:txBody>
+      </p:sp>
+      <p:sp>
+        <p:nvSpPr>
+          <p:cNvPr id="4" name="Text 2"/>
+          <p:cNvSpPr/>
+          <p:nvPr/>
+        </p:nvSpPr>
+        <p:spPr>
+          <a:xfrm>
+            <a:off x="457200" y="658368"/>
+            <a:ext cx="11274552" cy="685800"/>
+          </a:xfrm>
+          <a:prstGeom prst="rect">
+            <a:avLst/>
+          </a:prstGeom>
+          <a:noFill/>
+          <a:ln/>
+        </p:spPr>
+        <p:txBody>
+          <a:bodyPr wrap="square" rtlCol="0" anchor="ctr"/>
+          <a:lstStyle/>
+          <a:p>
+            <a:pPr indent="0" marL="0">
+              <a:buNone/>
+            </a:pPr>
+            <a:r>
+              <a:rPr lang="en-US" sz="3000" b="1" spc="50" kern="0" dirty="0">
+                <a:solidFill>
+                  <a:srgbClr val="0A1A1C"/>
+                </a:solidFill>
+                <a:latin typeface="Arial Black" pitchFamily="34" charset="0"/>
+                <a:ea typeface="Arial Black" pitchFamily="34" charset="-122"/>
+                <a:cs typeface="Arial Black" pitchFamily="34" charset="-120"/>
+              </a:rPr>
+              <a:t>Deployment → ReplicaSet → Pod</a:t>
+            </a:r>
+            <a:endParaRPr lang="en-US" sz="3000" dirty="0"/>
+          </a:p>
+        </p:txBody>
+      </p:sp>
+      <p:sp>
+        <p:nvSpPr>
+          <p:cNvPr id="5" name="Shape 3"/>
+          <p:cNvSpPr/>
+          <p:nvPr/>
+        </p:nvSpPr>
+        <p:spPr>
+          <a:xfrm>
+            <a:off x="457200" y="1417320"/>
+            <a:ext cx="11274552" cy="27432"/>
+          </a:xfrm>
+          <a:prstGeom prst="rect">
+            <a:avLst/>
+          </a:prstGeom>
+          <a:solidFill>
+            <a:srgbClr val="007A90"/>
+          </a:solidFill>
+          <a:ln w="12700">
+            <a:solidFill>
+              <a:srgbClr val="007A90"/>
+            </a:solidFill>
+            <a:prstDash val="solid"/>
+          </a:ln>
+        </p:spPr>
+      </p:sp>
+      <p:sp>
+        <p:nvSpPr>
+          <p:cNvPr id="6" name="Shape 4"/>
+          <p:cNvSpPr/>
+          <p:nvPr/>
+        </p:nvSpPr>
+        <p:spPr>
+          <a:xfrm>
+            <a:off x="457200" y="1840230"/>
+            <a:ext cx="3526536" cy="653796"/>
+          </a:xfrm>
+          <a:prstGeom prst="roundRect">
+            <a:avLst>
+              <a:gd name="adj" fmla="val 13986"/>
+            </a:avLst>
+          </a:prstGeom>
+          <a:solidFill>
+            <a:srgbClr val="B8ECF5"/>
+          </a:solidFill>
+          <a:ln w="19050">
+            <a:solidFill>
+              <a:srgbClr val="007A90"/>
+            </a:solidFill>
+            <a:prstDash val="solid"/>
+          </a:ln>
+        </p:spPr>
+      </p:sp>
+      <p:sp>
+        <p:nvSpPr>
+          <p:cNvPr id="7" name="Text 5"/>
+          <p:cNvSpPr/>
+          <p:nvPr/>
+        </p:nvSpPr>
+        <p:spPr>
+          <a:xfrm>
+            <a:off x="457200" y="1840230"/>
+            <a:ext cx="3526536" cy="653796"/>
+          </a:xfrm>
+          <a:prstGeom prst="rect">
+            <a:avLst/>
+          </a:prstGeom>
+          <a:noFill/>
+          <a:ln/>
+        </p:spPr>
+        <p:txBody>
+          <a:bodyPr wrap="square" rtlCol="0" anchor="ctr"/>
+          <a:lstStyle/>
+          <a:p>
+            <a:pPr algn="ctr" indent="0" marL="0">
+              <a:buNone/>
+            </a:pPr>
+            <a:r>
+              <a:rPr lang="en-US" sz="1200" b="1" dirty="0">
+                <a:solidFill>
+                  <a:srgbClr val="0A1A1C"/>
+                </a:solidFill>
+                <a:latin typeface="Trebuchet MS" pitchFamily="34" charset="0"/>
+                <a:ea typeface="Trebuchet MS" pitchFamily="34" charset="-122"/>
+                <a:cs typeface="Trebuchet MS" pitchFamily="34" charset="-120"/>
+              </a:rPr>
+              <a:t>Deployment</a:t>
+            </a:r>
+            <a:endParaRPr lang="en-US" sz="1200" dirty="0"/>
+          </a:p>
+        </p:txBody>
+      </p:sp>
+      <p:sp>
+        <p:nvSpPr>
+          <p:cNvPr id="8" name="Text 6"/>
+          <p:cNvSpPr/>
+          <p:nvPr/>
+        </p:nvSpPr>
+        <p:spPr>
+          <a:xfrm>
+            <a:off x="3983736" y="1840230"/>
+            <a:ext cx="347472" cy="653796"/>
+          </a:xfrm>
+          <a:prstGeom prst="rect">
+            <a:avLst/>
+          </a:prstGeom>
+          <a:noFill/>
+          <a:ln/>
+        </p:spPr>
+        <p:txBody>
+          <a:bodyPr wrap="square" rtlCol="0" anchor="ctr"/>
+          <a:lstStyle/>
+          <a:p>
+            <a:pPr algn="ctr" indent="0" marL="0">
+              <a:buNone/>
+            </a:pPr>
+            <a:r>
+              <a:rPr lang="en-US" sz="2200" dirty="0">
+                <a:solidFill>
+                  <a:srgbClr val="007A90"/>
+                </a:solidFill>
+                <a:latin typeface="Trebuchet MS" pitchFamily="34" charset="0"/>
+                <a:ea typeface="Trebuchet MS" pitchFamily="34" charset="-122"/>
+                <a:cs typeface="Trebuchet MS" pitchFamily="34" charset="-120"/>
+              </a:rPr>
+              <a:t>→</a:t>
+            </a:r>
+            <a:endParaRPr lang="en-US" sz="2200" dirty="0"/>
+          </a:p>
+        </p:txBody>
+      </p:sp>
+      <p:sp>
+        <p:nvSpPr>
+          <p:cNvPr id="9" name="Shape 7"/>
+          <p:cNvSpPr/>
+          <p:nvPr/>
+        </p:nvSpPr>
+        <p:spPr>
+          <a:xfrm>
+            <a:off x="4331208" y="1840230"/>
+            <a:ext cx="3526536" cy="653796"/>
+          </a:xfrm>
+          <a:prstGeom prst="roundRect">
+            <a:avLst>
+              <a:gd name="adj" fmla="val 13986"/>
+            </a:avLst>
+          </a:prstGeom>
+          <a:solidFill>
+            <a:srgbClr val="B8ECF5"/>
+          </a:solidFill>
+          <a:ln w="19050">
+            <a:solidFill>
+              <a:srgbClr val="007A90"/>
+            </a:solidFill>
+            <a:prstDash val="solid"/>
+          </a:ln>
+        </p:spPr>
+      </p:sp>
+      <p:sp>
+        <p:nvSpPr>
+          <p:cNvPr id="10" name="Text 8"/>
+          <p:cNvSpPr/>
+          <p:nvPr/>
+        </p:nvSpPr>
+        <p:spPr>
+          <a:xfrm>
+            <a:off x="4331208" y="1840230"/>
+            <a:ext cx="3526536" cy="653796"/>
+          </a:xfrm>
+          <a:prstGeom prst="rect">
+            <a:avLst/>
+          </a:prstGeom>
+          <a:noFill/>
+          <a:ln/>
+        </p:spPr>
+        <p:txBody>
+          <a:bodyPr wrap="square" rtlCol="0" anchor="ctr"/>
+          <a:lstStyle/>
+          <a:p>
+            <a:pPr algn="ctr" indent="0" marL="0">
+              <a:buNone/>
+            </a:pPr>
+            <a:r>
+              <a:rPr lang="en-US" sz="1200" dirty="0">
+                <a:solidFill>
+                  <a:srgbClr val="0A1A1C"/>
+                </a:solidFill>
+                <a:latin typeface="Trebuchet MS" pitchFamily="34" charset="0"/>
+                <a:ea typeface="Trebuchet MS" pitchFamily="34" charset="-122"/>
+                <a:cs typeface="Trebuchet MS" pitchFamily="34" charset="-120"/>
+              </a:rPr>
+              <a:t>ReplicaSet</a:t>
+            </a:r>
+            <a:endParaRPr lang="en-US" sz="1200" dirty="0"/>
+          </a:p>
+        </p:txBody>
+      </p:sp>
+      <p:sp>
+        <p:nvSpPr>
+          <p:cNvPr id="11" name="Text 9"/>
+          <p:cNvSpPr/>
+          <p:nvPr/>
+        </p:nvSpPr>
+        <p:spPr>
+          <a:xfrm>
+            <a:off x="7857744" y="1840230"/>
+            <a:ext cx="347472" cy="653796"/>
+          </a:xfrm>
+          <a:prstGeom prst="rect">
+            <a:avLst/>
+          </a:prstGeom>
+          <a:noFill/>
+          <a:ln/>
+        </p:spPr>
+        <p:txBody>
+          <a:bodyPr wrap="square" rtlCol="0" anchor="ctr"/>
+          <a:lstStyle/>
+          <a:p>
+            <a:pPr algn="ctr" indent="0" marL="0">
+              <a:buNone/>
+            </a:pPr>
+            <a:r>
+              <a:rPr lang="en-US" sz="2200" dirty="0">
+                <a:solidFill>
+                  <a:srgbClr val="007A90"/>
+                </a:solidFill>
+                <a:latin typeface="Trebuchet MS" pitchFamily="34" charset="0"/>
+                <a:ea typeface="Trebuchet MS" pitchFamily="34" charset="-122"/>
+                <a:cs typeface="Trebuchet MS" pitchFamily="34" charset="-120"/>
+              </a:rPr>
+              <a:t>→</a:t>
+            </a:r>
+            <a:endParaRPr lang="en-US" sz="2200" dirty="0"/>
+          </a:p>
+        </p:txBody>
+      </p:sp>
+      <p:sp>
+        <p:nvSpPr>
+          <p:cNvPr id="12" name="Shape 10"/>
+          <p:cNvSpPr/>
+          <p:nvPr/>
+        </p:nvSpPr>
+        <p:spPr>
+          <a:xfrm>
+            <a:off x="8205216" y="1840230"/>
+            <a:ext cx="3526536" cy="653796"/>
+          </a:xfrm>
+          <a:prstGeom prst="roundRect">
+            <a:avLst>
+              <a:gd name="adj" fmla="val 13986"/>
+            </a:avLst>
+          </a:prstGeom>
+          <a:solidFill>
+            <a:srgbClr val="B8ECF5"/>
+          </a:solidFill>
+          <a:ln w="19050">
+            <a:solidFill>
+              <a:srgbClr val="007A90"/>
+            </a:solidFill>
+            <a:prstDash val="solid"/>
+          </a:ln>
+        </p:spPr>
+      </p:sp>
+      <p:sp>
+        <p:nvSpPr>
+          <p:cNvPr id="13" name="Text 11"/>
+          <p:cNvSpPr/>
+          <p:nvPr/>
+        </p:nvSpPr>
+        <p:spPr>
+          <a:xfrm>
+            <a:off x="8205216" y="1840230"/>
+            <a:ext cx="3526536" cy="653796"/>
+          </a:xfrm>
+          <a:prstGeom prst="rect">
+            <a:avLst/>
+          </a:prstGeom>
+          <a:noFill/>
+          <a:ln/>
+        </p:spPr>
+        <p:txBody>
+          <a:bodyPr wrap="square" rtlCol="0" anchor="ctr"/>
+          <a:lstStyle/>
+          <a:p>
+            <a:pPr algn="ctr" indent="0" marL="0">
+              <a:buNone/>
+            </a:pPr>
+            <a:r>
+              <a:rPr lang="en-US" sz="1200" b="1" dirty="0">
+                <a:solidFill>
+                  <a:srgbClr val="0A1A1C"/>
+                </a:solidFill>
+                <a:latin typeface="Trebuchet MS" pitchFamily="34" charset="0"/>
+                <a:ea typeface="Trebuchet MS" pitchFamily="34" charset="-122"/>
+                <a:cs typeface="Trebuchet MS" pitchFamily="34" charset="-120"/>
+              </a:rPr>
+              <a:t>Pod(s)</a:t>
+            </a:r>
+            <a:endParaRPr lang="en-US" sz="1200" dirty="0"/>
+          </a:p>
+        </p:txBody>
+      </p:sp>
+      <p:sp>
+        <p:nvSpPr>
+          <p:cNvPr id="14" name="Shape 12"/>
+          <p:cNvSpPr/>
+          <p:nvPr/>
+        </p:nvSpPr>
+        <p:spPr>
+          <a:xfrm>
+            <a:off x="457200" y="2944368"/>
+            <a:ext cx="6040984" cy="3639312"/>
+          </a:xfrm>
+          <a:prstGeom prst="rect">
+            <a:avLst/>
+          </a:prstGeom>
+          <a:solidFill>
+            <a:srgbClr val="C0EDF5"/>
+          </a:solidFill>
+          <a:ln w="9525">
+            <a:solidFill>
+              <a:srgbClr val="007A90"/>
+            </a:solidFill>
+            <a:prstDash val="solid"/>
+          </a:ln>
+        </p:spPr>
+      </p:sp>
+      <p:sp>
+        <p:nvSpPr>
+          <p:cNvPr id="15" name="Text 13"/>
+          <p:cNvSpPr/>
+          <p:nvPr/>
+        </p:nvSpPr>
+        <p:spPr>
+          <a:xfrm>
+            <a:off x="640080" y="3081528"/>
+            <a:ext cx="5675224" cy="3364992"/>
+          </a:xfrm>
+          <a:prstGeom prst="rect">
+            <a:avLst/>
+          </a:prstGeom>
+          <a:noFill/>
+          <a:ln/>
+        </p:spPr>
+        <p:txBody>
+          <a:bodyPr wrap="none" rtlCol="0" anchor="t"/>
+          <a:lstStyle/>
+          <a:p>
+            <a:pPr indent="0" marL="0">
+              <a:buNone/>
+            </a:pPr>
+            <a:r>
+              <a:rPr lang="en-US" sz="1300" dirty="0">
+                <a:solidFill>
+                  <a:srgbClr val="003848"/>
+                </a:solidFill>
+                <a:latin typeface="Courier New" pitchFamily="34" charset="0"/>
+                <a:ea typeface="Courier New" pitchFamily="34" charset="-122"/>
+                <a:cs typeface="Courier New" pitchFamily="34" charset="-120"/>
+              </a:rPr>
+              <a:t>spec:</a:t>
+            </a:r>
+            <a:endParaRPr lang="en-US" sz="1300" dirty="0"/>
+          </a:p>
+          <a:p>
+            <a:pPr indent="0" marL="0">
+              <a:buNone/>
+            </a:pPr>
+            <a:r>
+              <a:rPr lang="en-US" sz="1300" dirty="0">
+                <a:solidFill>
+                  <a:srgbClr val="003848"/>
+                </a:solidFill>
+                <a:latin typeface="Courier New" pitchFamily="34" charset="0"/>
+                <a:ea typeface="Courier New" pitchFamily="34" charset="-122"/>
+                <a:cs typeface="Courier New" pitchFamily="34" charset="-120"/>
+              </a:rPr>
+              <a:t>  replicas: 3</a:t>
+            </a:r>
+            <a:endParaRPr lang="en-US" sz="1300" dirty="0"/>
+          </a:p>
+          <a:p>
+            <a:pPr indent="0" marL="0">
+              <a:buNone/>
+            </a:pPr>
+            <a:r>
+              <a:rPr lang="en-US" sz="1300" dirty="0">
+                <a:solidFill>
+                  <a:srgbClr val="003848"/>
+                </a:solidFill>
+                <a:latin typeface="Courier New" pitchFamily="34" charset="0"/>
+                <a:ea typeface="Courier New" pitchFamily="34" charset="-122"/>
+                <a:cs typeface="Courier New" pitchFamily="34" charset="-120"/>
+              </a:rPr>
+              <a:t>  selector:</a:t>
+            </a:r>
+            <a:endParaRPr lang="en-US" sz="1300" dirty="0"/>
+          </a:p>
+          <a:p>
+            <a:pPr indent="0" marL="0">
+              <a:buNone/>
+            </a:pPr>
+            <a:r>
+              <a:rPr lang="en-US" sz="1300" dirty="0">
+                <a:solidFill>
+                  <a:srgbClr val="003848"/>
+                </a:solidFill>
+                <a:latin typeface="Courier New" pitchFamily="34" charset="0"/>
+                <a:ea typeface="Courier New" pitchFamily="34" charset="-122"/>
+                <a:cs typeface="Courier New" pitchFamily="34" charset="-120"/>
+              </a:rPr>
+              <a:t>    matchLabels:</a:t>
+            </a:r>
+            <a:endParaRPr lang="en-US" sz="1300" dirty="0"/>
+          </a:p>
+          <a:p>
+            <a:pPr indent="0" marL="0">
+              <a:buNone/>
+            </a:pPr>
+            <a:r>
+              <a:rPr lang="en-US" sz="1300" dirty="0">
+                <a:solidFill>
+                  <a:srgbClr val="003848"/>
+                </a:solidFill>
+                <a:latin typeface="Courier New" pitchFamily="34" charset="0"/>
+                <a:ea typeface="Courier New" pitchFamily="34" charset="-122"/>
+                <a:cs typeface="Courier New" pitchFamily="34" charset="-120"/>
+              </a:rPr>
+              <a:t>      app: hello</a:t>
+            </a:r>
+            <a:endParaRPr lang="en-US" sz="1300" dirty="0"/>
+          </a:p>
+          <a:p>
+            <a:pPr indent="0" marL="0">
+              <a:buNone/>
+            </a:pPr>
+            <a:r>
+              <a:rPr lang="en-US" sz="1300" dirty="0">
+                <a:solidFill>
+                  <a:srgbClr val="003848"/>
+                </a:solidFill>
+                <a:latin typeface="Courier New" pitchFamily="34" charset="0"/>
+                <a:ea typeface="Courier New" pitchFamily="34" charset="-122"/>
+                <a:cs typeface="Courier New" pitchFamily="34" charset="-120"/>
+              </a:rPr>
+              <a:t>  template:      # a full Pod spec, nested one level deeper</a:t>
+            </a:r>
+            <a:endParaRPr lang="en-US" sz="1300" dirty="0"/>
+          </a:p>
+          <a:p>
+            <a:pPr indent="0" marL="0">
+              <a:buNone/>
+            </a:pPr>
+            <a:r>
+              <a:rPr lang="en-US" sz="1300" dirty="0">
+                <a:solidFill>
+                  <a:srgbClr val="003848"/>
+                </a:solidFill>
+                <a:latin typeface="Courier New" pitchFamily="34" charset="0"/>
+                <a:ea typeface="Courier New" pitchFamily="34" charset="-122"/>
+                <a:cs typeface="Courier New" pitchFamily="34" charset="-120"/>
+              </a:rPr>
+              <a:t>    metadata:</a:t>
+            </a:r>
+            <a:endParaRPr lang="en-US" sz="1300" dirty="0"/>
+          </a:p>
+          <a:p>
+            <a:pPr indent="0" marL="0">
+              <a:buNone/>
+            </a:pPr>
+            <a:r>
+              <a:rPr lang="en-US" sz="1300" dirty="0">
+                <a:solidFill>
+                  <a:srgbClr val="003848"/>
+                </a:solidFill>
+                <a:latin typeface="Courier New" pitchFamily="34" charset="0"/>
+                <a:ea typeface="Courier New" pitchFamily="34" charset="-122"/>
+                <a:cs typeface="Courier New" pitchFamily="34" charset="-120"/>
+              </a:rPr>
+              <a:t>      labels:</a:t>
+            </a:r>
+            <a:endParaRPr lang="en-US" sz="1300" dirty="0"/>
+          </a:p>
+          <a:p>
+            <a:pPr indent="0" marL="0">
+              <a:buNone/>
+            </a:pPr>
+            <a:r>
+              <a:rPr lang="en-US" sz="1300" dirty="0">
+                <a:solidFill>
+                  <a:srgbClr val="003848"/>
+                </a:solidFill>
+                <a:latin typeface="Courier New" pitchFamily="34" charset="0"/>
+                <a:ea typeface="Courier New" pitchFamily="34" charset="-122"/>
+                <a:cs typeface="Courier New" pitchFamily="34" charset="-120"/>
+              </a:rPr>
+              <a:t>        app: hello</a:t>
+            </a:r>
+            <a:endParaRPr lang="en-US" sz="1300" dirty="0"/>
+          </a:p>
+        </p:txBody>
+      </p:sp>
+      <p:sp>
+        <p:nvSpPr>
+          <p:cNvPr id="16" name="Text 14"/>
+          <p:cNvSpPr/>
+          <p:nvPr/>
+        </p:nvSpPr>
+        <p:spPr>
+          <a:xfrm>
+            <a:off x="6818224" y="2944368"/>
+            <a:ext cx="4913528" cy="909828"/>
+          </a:xfrm>
+          <a:prstGeom prst="rect">
+            <a:avLst/>
+          </a:prstGeom>
+          <a:noFill/>
+          <a:ln/>
+        </p:spPr>
+        <p:txBody>
+          <a:bodyPr wrap="square" rtlCol="0" anchor="ctr"/>
+          <a:lstStyle/>
+          <a:p>
+            <a:pPr marL="254000" indent="-254000">
+              <a:buSzPct val="100000"/>
+              <a:buChar char="•"/>
+            </a:pPr>
+            <a:r>
+              <a:rPr lang="en-US" sz="1500" dirty="0">
+                <a:solidFill>
+                  <a:srgbClr val="0A1A1C"/>
+                </a:solidFill>
+                <a:latin typeface="Trebuchet MS" pitchFamily="34" charset="0"/>
+                <a:ea typeface="Trebuchet MS" pitchFamily="34" charset="-122"/>
+                <a:cs typeface="Trebuchet MS" pitchFamily="34" charset="-120"/>
+              </a:rPr>
+              <a:t>Deployment doesn't run containers directly — it manages a ReplicaSet, and the ReplicaSet IS a controller: a background process maintaining a fixed Pod count</a:t>
+            </a:r>
+            <a:endParaRPr lang="en-US" sz="1500" dirty="0"/>
+          </a:p>
+        </p:txBody>
+      </p:sp>
+      <p:sp>
+        <p:nvSpPr>
+          <p:cNvPr id="17" name="Text 15"/>
+          <p:cNvSpPr/>
+          <p:nvPr/>
+        </p:nvSpPr>
+        <p:spPr>
+          <a:xfrm>
+            <a:off x="6818224" y="3854196"/>
+            <a:ext cx="4913528" cy="909828"/>
+          </a:xfrm>
+          <a:prstGeom prst="rect">
+            <a:avLst/>
+          </a:prstGeom>
+          <a:noFill/>
+          <a:ln/>
+        </p:spPr>
+        <p:txBody>
+          <a:bodyPr wrap="square" rtlCol="0" anchor="ctr"/>
+          <a:lstStyle/>
+          <a:p>
+            <a:pPr marL="254000" indent="-254000">
+              <a:buSzPct val="100000"/>
+              <a:buChar char="•"/>
+            </a:pPr>
+            <a:r>
+              <a:rPr lang="en-US" sz="1500" dirty="0">
+                <a:solidFill>
+                  <a:srgbClr val="0A1A1C"/>
+                </a:solidFill>
+                <a:latin typeface="Trebuchet MS" pitchFamily="34" charset="0"/>
+                <a:ea typeface="Trebuchet MS" pitchFamily="34" charset="-122"/>
+                <a:cs typeface="Trebuchet MS" pitchFamily="34" charset="-120"/>
+              </a:rPr>
+              <a:t>Delete one managed Pod: it disappears, a brand-new one (new random suffix) appears almost immediately — with no re-apply</a:t>
+            </a:r>
+            <a:endParaRPr lang="en-US" sz="1500" dirty="0"/>
+          </a:p>
+        </p:txBody>
+      </p:sp>
+      <p:sp>
+        <p:nvSpPr>
+          <p:cNvPr id="18" name="Text 16"/>
+          <p:cNvSpPr/>
+          <p:nvPr/>
+        </p:nvSpPr>
+        <p:spPr>
+          <a:xfrm>
+            <a:off x="6818224" y="4764024"/>
+            <a:ext cx="4913528" cy="909828"/>
+          </a:xfrm>
+          <a:prstGeom prst="rect">
+            <a:avLst/>
+          </a:prstGeom>
+          <a:noFill/>
+          <a:ln/>
+        </p:spPr>
+        <p:txBody>
+          <a:bodyPr wrap="square" rtlCol="0" anchor="ctr"/>
+          <a:lstStyle/>
+          <a:p>
+            <a:pPr marL="254000" indent="-254000">
+              <a:buSzPct val="100000"/>
+              <a:buChar char="•"/>
+            </a:pPr>
+            <a:r>
+              <a:rPr lang="en-US" sz="1500" dirty="0">
+                <a:solidFill>
+                  <a:srgbClr val="0A1A1C"/>
+                </a:solidFill>
+                <a:latin typeface="Trebuchet MS" pitchFamily="34" charset="0"/>
+                <a:ea typeface="Trebuchet MS" pitchFamily="34" charset="-122"/>
+                <a:cs typeface="Trebuchet MS" pitchFamily="34" charset="-120"/>
+              </a:rPr>
+              <a:t>A bare Pod has no such process watching it; a Deployment-managed Pod does — that's the entire difference</a:t>
+            </a:r>
+            <a:endParaRPr lang="en-US" sz="1500" dirty="0"/>
+          </a:p>
+        </p:txBody>
+      </p:sp>
+      <p:sp>
+        <p:nvSpPr>
+          <p:cNvPr id="19" name="Text 17"/>
+          <p:cNvSpPr/>
+          <p:nvPr/>
+        </p:nvSpPr>
+        <p:spPr>
+          <a:xfrm>
+            <a:off x="6818224" y="5673852"/>
+            <a:ext cx="4913528" cy="909828"/>
+          </a:xfrm>
+          <a:prstGeom prst="rect">
+            <a:avLst/>
+          </a:prstGeom>
+          <a:noFill/>
+          <a:ln/>
+        </p:spPr>
+        <p:txBody>
+          <a:bodyPr wrap="square" rtlCol="0" anchor="ctr"/>
+          <a:lstStyle/>
+          <a:p>
+            <a:pPr marL="254000" indent="-254000">
+              <a:buSzPct val="100000"/>
+              <a:buChar char="•"/>
+            </a:pPr>
+            <a:r>
+              <a:rPr lang="en-US" sz="1500" dirty="0">
+                <a:solidFill>
+                  <a:srgbClr val="0A1A1C"/>
+                </a:solidFill>
+                <a:latin typeface="Trebuchet MS" pitchFamily="34" charset="0"/>
+                <a:ea typeface="Trebuchet MS" pitchFamily="34" charset="-122"/>
+                <a:cs typeface="Trebuchet MS" pitchFamily="34" charset="-120"/>
+              </a:rPr>
+              <a:t>kubectl scale --replicas=5 just changes what "desired" means; the same controller loop does the rest</a:t>
+            </a:r>
+            <a:endParaRPr lang="en-US" sz="1500" dirty="0"/>
+          </a:p>
+        </p:txBody>
+      </p:sp>
+    </p:spTree>
+  </p:cSld>
+  <p:clrMapOvr>
+    <a:masterClrMapping/>
+  </p:clrMapOvr>
+</p:sld>
+</file>
+
+<file path=ppt/slides/slide16.xml><?xml version="1.0" encoding="utf-8"?>
+<p:sld xmlns:a="http://schemas.openxmlformats.org/drawingml/2006/main" xmlns:r="http://schemas.openxmlformats.org/officeDocument/2006/relationships" xmlns:p="http://schemas.openxmlformats.org/presentationml/2006/main">
+  <p:cSld name="Slide 16">
     <p:bg>
       <p:bgPr>
         <a:solidFill>
@@ -6064,424 +6806,6 @@
               <a:t>Stable networking, externalized config, and how it all composes.</a:t>
             </a:r>
             <a:endParaRPr lang="en-US" sz="2200" dirty="0"/>
-          </a:p>
-        </p:txBody>
-      </p:sp>
-    </p:spTree>
-  </p:cSld>
-  <p:clrMapOvr>
-    <a:masterClrMapping/>
-  </p:clrMapOvr>
-</p:sld>
-</file>
-
-<file path=ppt/slides/slide16.xml><?xml version="1.0" encoding="utf-8"?>
-<p:sld xmlns:a="http://schemas.openxmlformats.org/drawingml/2006/main" xmlns:r="http://schemas.openxmlformats.org/officeDocument/2006/relationships" xmlns:p="http://schemas.openxmlformats.org/presentationml/2006/main">
-  <p:cSld name="Slide 16">
-    <p:bg>
-      <p:bgPr>
-        <a:solidFill>
-          <a:srgbClr val="EAFCFF"/>
-        </a:solidFill>
-      </p:bgPr>
-    </p:bg>
-    <p:spTree>
-      <p:nvGrpSpPr>
-        <p:cNvPr id="1" name=""/>
-        <p:cNvGrpSpPr/>
-        <p:nvPr/>
-      </p:nvGrpSpPr>
-      <p:grpSpPr>
-        <a:xfrm>
-          <a:off x="0" y="0"/>
-          <a:ext cx="0" cy="0"/>
-          <a:chOff x="0" y="0"/>
-          <a:chExt cx="0" cy="0"/>
-        </a:xfrm>
-      </p:grpSpPr>
-      <p:sp>
-        <p:nvSpPr>
-          <p:cNvPr id="2" name="Shape 0"/>
-          <p:cNvSpPr/>
-          <p:nvPr/>
-        </p:nvSpPr>
-        <p:spPr>
-          <a:xfrm>
-            <a:off x="457200" y="201168"/>
-            <a:ext cx="1828800" cy="347472"/>
-          </a:xfrm>
-          <a:prstGeom prst="rect">
-            <a:avLst/>
-          </a:prstGeom>
-          <a:solidFill>
-            <a:srgbClr val="007A90"/>
-          </a:solidFill>
-          <a:ln w="9525">
-            <a:solidFill>
-              <a:srgbClr val="007A90"/>
-            </a:solidFill>
-            <a:prstDash val="solid"/>
-          </a:ln>
-        </p:spPr>
-      </p:sp>
-      <p:sp>
-        <p:nvSpPr>
-          <p:cNvPr id="3" name="Text 1"/>
-          <p:cNvSpPr/>
-          <p:nvPr/>
-        </p:nvSpPr>
-        <p:spPr>
-          <a:xfrm>
-            <a:off x="457200" y="201168"/>
-            <a:ext cx="1828800" cy="347472"/>
-          </a:xfrm>
-          <a:prstGeom prst="rect">
-            <a:avLst/>
-          </a:prstGeom>
-          <a:noFill/>
-          <a:ln/>
-        </p:spPr>
-        <p:txBody>
-          <a:bodyPr wrap="square" rtlCol="0" anchor="ctr"/>
-          <a:lstStyle/>
-          <a:p>
-            <a:pPr algn="ctr" indent="0" marL="0">
-              <a:buNone/>
-            </a:pPr>
-            <a:r>
-              <a:rPr lang="en-US" sz="1200" b="1" spc="50" kern="0" dirty="0">
-                <a:solidFill>
-                  <a:srgbClr val="FFFFFF"/>
-                </a:solidFill>
-                <a:latin typeface="Trebuchet MS" pitchFamily="34" charset="0"/>
-                <a:ea typeface="Trebuchet MS" pitchFamily="34" charset="-122"/>
-                <a:cs typeface="Trebuchet MS" pitchFamily="34" charset="-120"/>
-              </a:rPr>
-              <a:t>KUBERNETES</a:t>
-            </a:r>
-            <a:endParaRPr lang="en-US" sz="1200" dirty="0"/>
-          </a:p>
-        </p:txBody>
-      </p:sp>
-      <p:sp>
-        <p:nvSpPr>
-          <p:cNvPr id="4" name="Text 2"/>
-          <p:cNvSpPr/>
-          <p:nvPr/>
-        </p:nvSpPr>
-        <p:spPr>
-          <a:xfrm>
-            <a:off x="457200" y="658368"/>
-            <a:ext cx="11274552" cy="685800"/>
-          </a:xfrm>
-          <a:prstGeom prst="rect">
-            <a:avLst/>
-          </a:prstGeom>
-          <a:noFill/>
-          <a:ln/>
-        </p:spPr>
-        <p:txBody>
-          <a:bodyPr wrap="square" rtlCol="0" anchor="ctr"/>
-          <a:lstStyle/>
-          <a:p>
-            <a:pPr indent="0" marL="0">
-              <a:buNone/>
-            </a:pPr>
-            <a:r>
-              <a:rPr lang="en-US" sz="3000" b="1" spc="50" kern="0" dirty="0">
-                <a:solidFill>
-                  <a:srgbClr val="0A1A1C"/>
-                </a:solidFill>
-                <a:latin typeface="Arial Black" pitchFamily="34" charset="0"/>
-                <a:ea typeface="Arial Black" pitchFamily="34" charset="-122"/>
-                <a:cs typeface="Arial Black" pitchFamily="34" charset="-120"/>
-              </a:rPr>
-              <a:t>Services: Stable Addresses Over Disposable Pods</a:t>
-            </a:r>
-            <a:endParaRPr lang="en-US" sz="3000" dirty="0"/>
-          </a:p>
-        </p:txBody>
-      </p:sp>
-      <p:sp>
-        <p:nvSpPr>
-          <p:cNvPr id="5" name="Shape 3"/>
-          <p:cNvSpPr/>
-          <p:nvPr/>
-        </p:nvSpPr>
-        <p:spPr>
-          <a:xfrm>
-            <a:off x="457200" y="1417320"/>
-            <a:ext cx="11274552" cy="27432"/>
-          </a:xfrm>
-          <a:prstGeom prst="rect">
-            <a:avLst/>
-          </a:prstGeom>
-          <a:solidFill>
-            <a:srgbClr val="007A90"/>
-          </a:solidFill>
-          <a:ln w="12700">
-            <a:solidFill>
-              <a:srgbClr val="007A90"/>
-            </a:solidFill>
-            <a:prstDash val="solid"/>
-          </a:ln>
-        </p:spPr>
-      </p:sp>
-      <p:sp>
-        <p:nvSpPr>
-          <p:cNvPr id="6" name="Shape 4"/>
-          <p:cNvSpPr/>
-          <p:nvPr/>
-        </p:nvSpPr>
-        <p:spPr>
-          <a:xfrm>
-            <a:off x="457200" y="1572768"/>
-            <a:ext cx="5477256" cy="5010912"/>
-          </a:xfrm>
-          <a:prstGeom prst="rect">
-            <a:avLst/>
-          </a:prstGeom>
-          <a:solidFill>
-            <a:srgbClr val="C0EDF5"/>
-          </a:solidFill>
-          <a:ln w="9525">
-            <a:solidFill>
-              <a:srgbClr val="007A90"/>
-            </a:solidFill>
-            <a:prstDash val="solid"/>
-          </a:ln>
-        </p:spPr>
-      </p:sp>
-      <p:sp>
-        <p:nvSpPr>
-          <p:cNvPr id="7" name="Text 5"/>
-          <p:cNvSpPr/>
-          <p:nvPr/>
-        </p:nvSpPr>
-        <p:spPr>
-          <a:xfrm>
-            <a:off x="640080" y="1709928"/>
-            <a:ext cx="5111496" cy="4736592"/>
-          </a:xfrm>
-          <a:prstGeom prst="rect">
-            <a:avLst/>
-          </a:prstGeom>
-          <a:noFill/>
-          <a:ln/>
-        </p:spPr>
-        <p:txBody>
-          <a:bodyPr wrap="none" rtlCol="0" anchor="t"/>
-          <a:lstStyle/>
-          <a:p>
-            <a:pPr indent="0" marL="0">
-              <a:buNone/>
-            </a:pPr>
-            <a:r>
-              <a:rPr lang="en-US" sz="1300" dirty="0">
-                <a:solidFill>
-                  <a:srgbClr val="003848"/>
-                </a:solidFill>
-                <a:latin typeface="Courier New" pitchFamily="34" charset="0"/>
-                <a:ea typeface="Courier New" pitchFamily="34" charset="-122"/>
-                <a:cs typeface="Courier New" pitchFamily="34" charset="-120"/>
-              </a:rPr>
-              <a:t>kubectl expose deployment hello-deploy \</a:t>
-            </a:r>
-            <a:endParaRPr lang="en-US" sz="1300" dirty="0"/>
-          </a:p>
-          <a:p>
-            <a:pPr indent="0" marL="0">
-              <a:buNone/>
-            </a:pPr>
-            <a:r>
-              <a:rPr lang="en-US" sz="1300" dirty="0">
-                <a:solidFill>
-                  <a:srgbClr val="003848"/>
-                </a:solidFill>
-                <a:latin typeface="Courier New" pitchFamily="34" charset="0"/>
-                <a:ea typeface="Courier New" pitchFamily="34" charset="-122"/>
-                <a:cs typeface="Courier New" pitchFamily="34" charset="-120"/>
-              </a:rPr>
-              <a:t>  --port=80 --target-port=80 --name=hello-service</a:t>
-            </a:r>
-            <a:endParaRPr lang="en-US" sz="1300" dirty="0"/>
-          </a:p>
-          <a:p>
-            <a:pPr indent="0" marL="0">
-              <a:buNone/>
-            </a:pPr>
-            <a:r>
-              <a:rPr lang="en-US" sz="1300" dirty="0">
-                <a:solidFill>
-                  <a:srgbClr val="003848"/>
-                </a:solidFill>
-                <a:latin typeface="Courier New" pitchFamily="34" charset="0"/>
-                <a:ea typeface="Courier New" pitchFamily="34" charset="-122"/>
-                <a:cs typeface="Courier New" pitchFamily="34" charset="-120"/>
-              </a:rPr>
-              <a:t># → TYPE: ClusterIP   CLUSTER-IP: 10.x.x.x (stays fixed)</a:t>
-            </a:r>
-            <a:endParaRPr lang="en-US" sz="1300" dirty="0"/>
-          </a:p>
-        </p:txBody>
-      </p:sp>
-      <p:sp>
-        <p:nvSpPr>
-          <p:cNvPr id="8" name="Text 6"/>
-          <p:cNvSpPr/>
-          <p:nvPr/>
-        </p:nvSpPr>
-        <p:spPr>
-          <a:xfrm>
-            <a:off x="6254496" y="1572768"/>
-            <a:ext cx="5477256" cy="1252728"/>
-          </a:xfrm>
-          <a:prstGeom prst="rect">
-            <a:avLst/>
-          </a:prstGeom>
-          <a:noFill/>
-          <a:ln/>
-        </p:spPr>
-        <p:txBody>
-          <a:bodyPr wrap="square" rtlCol="0" anchor="ctr"/>
-          <a:lstStyle/>
-          <a:p>
-            <a:pPr marL="254000" indent="-254000">
-              <a:buSzPct val="100000"/>
-              <a:buChar char="•"/>
-            </a:pPr>
-            <a:r>
-              <a:rPr lang="en-US" sz="1700" dirty="0">
-                <a:solidFill>
-                  <a:srgbClr val="0A1A1C"/>
-                </a:solidFill>
-                <a:latin typeface="Trebuchet MS" pitchFamily="34" charset="0"/>
-                <a:ea typeface="Trebuchet MS" pitchFamily="34" charset="-122"/>
-                <a:cs typeface="Trebuchet MS" pitchFamily="34" charset="-120"/>
-              </a:rPr>
-              <a:t>Every Pod gets its own IP, but Pods are disposable — you just proved that</a:t>
-            </a:r>
-            <a:endParaRPr lang="en-US" sz="1700" dirty="0"/>
-          </a:p>
-        </p:txBody>
-      </p:sp>
-      <p:sp>
-        <p:nvSpPr>
-          <p:cNvPr id="9" name="Text 7"/>
-          <p:cNvSpPr/>
-          <p:nvPr/>
-        </p:nvSpPr>
-        <p:spPr>
-          <a:xfrm>
-            <a:off x="6254496" y="2825496"/>
-            <a:ext cx="5477256" cy="1252728"/>
-          </a:xfrm>
-          <a:prstGeom prst="rect">
-            <a:avLst/>
-          </a:prstGeom>
-          <a:noFill/>
-          <a:ln/>
-        </p:spPr>
-        <p:txBody>
-          <a:bodyPr wrap="square" rtlCol="0" anchor="ctr"/>
-          <a:lstStyle/>
-          <a:p>
-            <a:pPr marL="254000" indent="-254000">
-              <a:buSzPct val="100000"/>
-              <a:buChar char="•"/>
-            </a:pPr>
-            <a:r>
-              <a:rPr lang="en-US" sz="1700" dirty="0">
-                <a:solidFill>
-                  <a:srgbClr val="0A1A1C"/>
-                </a:solidFill>
-                <a:latin typeface="Trebuchet MS" pitchFamily="34" charset="0"/>
-                <a:ea typeface="Trebuchet MS" pitchFamily="34" charset="-122"/>
-                <a:cs typeface="Trebuchet MS" pitchFamily="34" charset="-120"/>
-              </a:rPr>
-              <a:t>A Service is a permanent address that tracks whichever Pods match its label selector</a:t>
-            </a:r>
-            <a:endParaRPr lang="en-US" sz="1700" dirty="0"/>
-          </a:p>
-        </p:txBody>
-      </p:sp>
-      <p:sp>
-        <p:nvSpPr>
-          <p:cNvPr id="10" name="Text 8"/>
-          <p:cNvSpPr/>
-          <p:nvPr/>
-        </p:nvSpPr>
-        <p:spPr>
-          <a:xfrm>
-            <a:off x="6254496" y="4078224"/>
-            <a:ext cx="5477256" cy="1252728"/>
-          </a:xfrm>
-          <a:prstGeom prst="rect">
-            <a:avLst/>
-          </a:prstGeom>
-          <a:noFill/>
-          <a:ln/>
-        </p:spPr>
-        <p:txBody>
-          <a:bodyPr wrap="square" rtlCol="0" anchor="ctr"/>
-          <a:lstStyle/>
-          <a:p>
-            <a:pPr marL="254000" indent="-254000">
-              <a:buSzPct val="100000"/>
-              <a:buChar char="•"/>
-            </a:pPr>
-            <a:r>
-              <a:rPr lang="en-US" sz="1700" dirty="0">
-                <a:solidFill>
-                  <a:srgbClr val="0A1A1C"/>
-                </a:solidFill>
-                <a:latin typeface="Trebuchet MS" pitchFamily="34" charset="0"/>
-                <a:ea typeface="Trebuchet MS" pitchFamily="34" charset="-122"/>
-                <a:cs typeface="Trebuchet MS" pitchFamily="34" charset="-120"/>
-              </a:rPr>
-              <a:t>ClusterIP (default) — internal-only; NodePort — opens a port in the 30000–32767 range for external access</a:t>
-            </a:r>
-            <a:endParaRPr lang="en-US" sz="1700" dirty="0"/>
-          </a:p>
-        </p:txBody>
-      </p:sp>
-      <p:sp>
-        <p:nvSpPr>
-          <p:cNvPr id="11" name="Text 9"/>
-          <p:cNvSpPr/>
-          <p:nvPr/>
-        </p:nvSpPr>
-        <p:spPr>
-          <a:xfrm>
-            <a:off x="6254496" y="5330952"/>
-            <a:ext cx="5477256" cy="1252728"/>
-          </a:xfrm>
-          <a:prstGeom prst="rect">
-            <a:avLst/>
-          </a:prstGeom>
-          <a:noFill/>
-          <a:ln/>
-        </p:spPr>
-        <p:txBody>
-          <a:bodyPr wrap="square" rtlCol="0" anchor="ctr"/>
-          <a:lstStyle/>
-          <a:p>
-            <a:pPr marL="254000" indent="-254000">
-              <a:buSzPct val="100000"/>
-              <a:buChar char="•"/>
-            </a:pPr>
-            <a:r>
-              <a:rPr lang="en-US" sz="1700" dirty="0">
-                <a:solidFill>
-                  <a:srgbClr val="0A1A1C"/>
-                </a:solidFill>
-                <a:latin typeface="Trebuchet MS" pitchFamily="34" charset="0"/>
-                <a:ea typeface="Trebuchet MS" pitchFamily="34" charset="-122"/>
-                <a:cs typeface="Trebuchet MS" pitchFamily="34" charset="-120"/>
-              </a:rPr>
-              <a:t>Proof: delete a Pod behind a Service — CLUSTER-IP stays exactly the same the whole time</a:t>
-            </a:r>
-            <a:endParaRPr lang="en-US" sz="1700" dirty="0"/>
           </a:p>
         </p:txBody>
       </p:sp>
@@ -6614,7 +6938,7 @@
                 <a:ea typeface="Arial Black" pitchFamily="34" charset="-122"/>
                 <a:cs typeface="Arial Black" pitchFamily="34" charset="-120"/>
               </a:rPr>
-              <a:t>ConfigMaps &amp; Secrets: Externalizing Config</a:t>
+              <a:t>Services: Stable Addresses Over Disposable Pods</a:t>
             </a:r>
             <a:endParaRPr lang="en-US" sz="3000" dirty="0"/>
           </a:p>
@@ -6647,14 +6971,112 @@
       </p:sp>
       <p:sp>
         <p:nvSpPr>
-          <p:cNvPr id="6" name="Text 4"/>
+          <p:cNvPr id="6" name="Shape 4"/>
           <p:cNvSpPr/>
           <p:nvPr/>
         </p:nvSpPr>
         <p:spPr>
           <a:xfrm>
             <a:off x="457200" y="1572768"/>
-            <a:ext cx="11274552" cy="1252728"/>
+            <a:ext cx="5477256" cy="5010912"/>
+          </a:xfrm>
+          <a:prstGeom prst="rect">
+            <a:avLst/>
+          </a:prstGeom>
+          <a:solidFill>
+            <a:srgbClr val="C0EDF5"/>
+          </a:solidFill>
+          <a:ln w="9525">
+            <a:solidFill>
+              <a:srgbClr val="007A90"/>
+            </a:solidFill>
+            <a:prstDash val="solid"/>
+          </a:ln>
+        </p:spPr>
+      </p:sp>
+      <p:sp>
+        <p:nvSpPr>
+          <p:cNvPr id="7" name="Text 5"/>
+          <p:cNvSpPr/>
+          <p:nvPr/>
+        </p:nvSpPr>
+        <p:spPr>
+          <a:xfrm>
+            <a:off x="640080" y="1709928"/>
+            <a:ext cx="5111496" cy="4736592"/>
+          </a:xfrm>
+          <a:prstGeom prst="rect">
+            <a:avLst/>
+          </a:prstGeom>
+          <a:noFill/>
+          <a:ln/>
+        </p:spPr>
+        <p:txBody>
+          <a:bodyPr wrap="none" rtlCol="0" anchor="t"/>
+          <a:lstStyle/>
+          <a:p>
+            <a:pPr indent="0" marL="0">
+              <a:buNone/>
+            </a:pPr>
+            <a:r>
+              <a:rPr lang="en-US" sz="1300" dirty="0">
+                <a:solidFill>
+                  <a:srgbClr val="003848"/>
+                </a:solidFill>
+                <a:latin typeface="Courier New" pitchFamily="34" charset="0"/>
+                <a:ea typeface="Courier New" pitchFamily="34" charset="-122"/>
+                <a:cs typeface="Courier New" pitchFamily="34" charset="-120"/>
+              </a:rPr>
+              <a:t>kubectl expose deployment hello-deploy \</a:t>
+            </a:r>
+            <a:endParaRPr lang="en-US" sz="1300" dirty="0"/>
+          </a:p>
+          <a:p>
+            <a:pPr indent="0" marL="0">
+              <a:buNone/>
+            </a:pPr>
+            <a:r>
+              <a:rPr lang="en-US" sz="1300" dirty="0">
+                <a:solidFill>
+                  <a:srgbClr val="003848"/>
+                </a:solidFill>
+                <a:latin typeface="Courier New" pitchFamily="34" charset="0"/>
+                <a:ea typeface="Courier New" pitchFamily="34" charset="-122"/>
+                <a:cs typeface="Courier New" pitchFamily="34" charset="-120"/>
+              </a:rPr>
+              <a:t>  --port=80 --target-port=80 --name=hello-service</a:t>
+            </a:r>
+            <a:endParaRPr lang="en-US" sz="1300" dirty="0"/>
+          </a:p>
+          <a:p>
+            <a:pPr indent="0" marL="0">
+              <a:buNone/>
+            </a:pPr>
+            <a:r>
+              <a:rPr lang="en-US" sz="1300" dirty="0">
+                <a:solidFill>
+                  <a:srgbClr val="003848"/>
+                </a:solidFill>
+                <a:latin typeface="Courier New" pitchFamily="34" charset="0"/>
+                <a:ea typeface="Courier New" pitchFamily="34" charset="-122"/>
+                <a:cs typeface="Courier New" pitchFamily="34" charset="-120"/>
+              </a:rPr>
+              <a:t># → TYPE: ClusterIP   CLUSTER-IP: 10.x.x.x (stays fixed)</a:t>
+            </a:r>
+            <a:endParaRPr lang="en-US" sz="1300" dirty="0"/>
+          </a:p>
+        </p:txBody>
+      </p:sp>
+      <p:sp>
+        <p:nvSpPr>
+          <p:cNvPr id="8" name="Text 6"/>
+          <p:cNvSpPr/>
+          <p:nvPr/>
+        </p:nvSpPr>
+        <p:spPr>
+          <a:xfrm>
+            <a:off x="6254496" y="1572768"/>
+            <a:ext cx="5477256" cy="1252728"/>
           </a:xfrm>
           <a:prstGeom prst="rect">
             <a:avLst/>
@@ -6671,7 +7093,7 @@
               <a:buChar char="•"/>
             </a:pPr>
             <a:r>
-              <a:rPr lang="en-US" sz="2200" dirty="0">
+              <a:rPr lang="en-US" sz="1700" dirty="0">
                 <a:solidFill>
                   <a:srgbClr val="0A1A1C"/>
                 </a:solidFill>
@@ -6679,22 +7101,22 @@
                 <a:ea typeface="Trebuchet MS" pitchFamily="34" charset="-122"/>
                 <a:cs typeface="Trebuchet MS" pitchFamily="34" charset="-120"/>
               </a:rPr>
-              <a:t>Same container image should run unmodified across dev, staging, prod — only config and credentials should differ</a:t>
-            </a:r>
-            <a:endParaRPr lang="en-US" sz="2200" dirty="0"/>
-          </a:p>
-        </p:txBody>
-      </p:sp>
-      <p:sp>
-        <p:nvSpPr>
-          <p:cNvPr id="7" name="Text 5"/>
-          <p:cNvSpPr/>
-          <p:nvPr/>
-        </p:nvSpPr>
-        <p:spPr>
-          <a:xfrm>
-            <a:off x="457200" y="2825496"/>
-            <a:ext cx="11274552" cy="1252728"/>
+              <a:t>Every Pod gets its own IP, but Pods are disposable — you just proved that</a:t>
+            </a:r>
+            <a:endParaRPr lang="en-US" sz="1700" dirty="0"/>
+          </a:p>
+        </p:txBody>
+      </p:sp>
+      <p:sp>
+        <p:nvSpPr>
+          <p:cNvPr id="9" name="Text 7"/>
+          <p:cNvSpPr/>
+          <p:nvPr/>
+        </p:nvSpPr>
+        <p:spPr>
+          <a:xfrm>
+            <a:off x="6254496" y="2825496"/>
+            <a:ext cx="5477256" cy="1252728"/>
           </a:xfrm>
           <a:prstGeom prst="rect">
             <a:avLst/>
@@ -6711,7 +7133,7 @@
               <a:buChar char="•"/>
             </a:pPr>
             <a:r>
-              <a:rPr lang="en-US" sz="2200" dirty="0">
+              <a:rPr lang="en-US" sz="1700" dirty="0">
                 <a:solidFill>
                   <a:srgbClr val="0A1A1C"/>
                 </a:solidFill>
@@ -6719,22 +7141,22 @@
                 <a:ea typeface="Trebuchet MS" pitchFamily="34" charset="-122"/>
                 <a:cs typeface="Trebuchet MS" pitchFamily="34" charset="-120"/>
               </a:rPr>
-              <a:t>ConfigMap = plain configuration; Secret = sensitive values — same injection mechanism for both</a:t>
-            </a:r>
-            <a:endParaRPr lang="en-US" sz="2200" dirty="0"/>
-          </a:p>
-        </p:txBody>
-      </p:sp>
-      <p:sp>
-        <p:nvSpPr>
-          <p:cNvPr id="8" name="Text 6"/>
-          <p:cNvSpPr/>
-          <p:nvPr/>
-        </p:nvSpPr>
-        <p:spPr>
-          <a:xfrm>
-            <a:off x="457200" y="4078224"/>
-            <a:ext cx="11274552" cy="1252728"/>
+              <a:t>A Service is a permanent address that tracks whichever Pods match its label selector</a:t>
+            </a:r>
+            <a:endParaRPr lang="en-US" sz="1700" dirty="0"/>
+          </a:p>
+        </p:txBody>
+      </p:sp>
+      <p:sp>
+        <p:nvSpPr>
+          <p:cNvPr id="10" name="Text 8"/>
+          <p:cNvSpPr/>
+          <p:nvPr/>
+        </p:nvSpPr>
+        <p:spPr>
+          <a:xfrm>
+            <a:off x="6254496" y="4078224"/>
+            <a:ext cx="5477256" cy="1252728"/>
           </a:xfrm>
           <a:prstGeom prst="rect">
             <a:avLst/>
@@ -6751,7 +7173,7 @@
               <a:buChar char="•"/>
             </a:pPr>
             <a:r>
-              <a:rPr lang="en-US" sz="2200" dirty="0">
+              <a:rPr lang="en-US" sz="1700" dirty="0">
                 <a:solidFill>
                   <a:srgbClr val="0A1A1C"/>
                 </a:solidFill>
@@ -6759,22 +7181,22 @@
                 <a:ea typeface="Trebuchet MS" pitchFamily="34" charset="-122"/>
                 <a:cs typeface="Trebuchet MS" pitchFamily="34" charset="-120"/>
               </a:rPr>
-              <a:t>Both referenced from a Pod via valueFrom.configMapKeyRef / valueFrom.secretKeyRef, injected as env vars at startup</a:t>
-            </a:r>
-            <a:endParaRPr lang="en-US" sz="2200" dirty="0"/>
-          </a:p>
-        </p:txBody>
-      </p:sp>
-      <p:sp>
-        <p:nvSpPr>
-          <p:cNvPr id="9" name="Text 7"/>
-          <p:cNvSpPr/>
-          <p:nvPr/>
-        </p:nvSpPr>
-        <p:spPr>
-          <a:xfrm>
-            <a:off x="457200" y="5330952"/>
-            <a:ext cx="11274552" cy="1252728"/>
+              <a:t>ClusterIP (default) — internal-only; NodePort — opens a port in the 30000–32767 range for external access</a:t>
+            </a:r>
+            <a:endParaRPr lang="en-US" sz="1700" dirty="0"/>
+          </a:p>
+        </p:txBody>
+      </p:sp>
+      <p:sp>
+        <p:nvSpPr>
+          <p:cNvPr id="11" name="Text 9"/>
+          <p:cNvSpPr/>
+          <p:nvPr/>
+        </p:nvSpPr>
+        <p:spPr>
+          <a:xfrm>
+            <a:off x="6254496" y="5330952"/>
+            <a:ext cx="5477256" cy="1252728"/>
           </a:xfrm>
           <a:prstGeom prst="rect">
             <a:avLst/>
@@ -6791,7 +7213,7 @@
               <a:buChar char="•"/>
             </a:pPr>
             <a:r>
-              <a:rPr lang="en-US" sz="2200" dirty="0">
+              <a:rPr lang="en-US" sz="1700" dirty="0">
                 <a:solidFill>
                   <a:srgbClr val="0A1A1C"/>
                 </a:solidFill>
@@ -6799,9 +7221,9 @@
                 <a:ea typeface="Trebuchet MS" pitchFamily="34" charset="-122"/>
                 <a:cs typeface="Trebuchet MS" pitchFamily="34" charset="-120"/>
               </a:rPr>
-              <a:t>Secrets are base64 encoded, not encrypted — anyone with API access can trivially decode them; fine for practice, not for production as-is</a:t>
-            </a:r>
-            <a:endParaRPr lang="en-US" sz="2200" dirty="0"/>
+              <a:t>Proof: delete a Pod behind a Service — CLUSTER-IP stays exactly the same the whole time</a:t>
+            </a:r>
+            <a:endParaRPr lang="en-US" sz="1700" dirty="0"/>
           </a:p>
         </p:txBody>
       </p:sp>
@@ -6934,7 +7356,7 @@
                 <a:ea typeface="Arial Black" pitchFamily="34" charset="-122"/>
                 <a:cs typeface="Arial Black" pitchFamily="34" charset="-120"/>
               </a:rPr>
-              <a:t>The Capstone: Wiring It All Together</a:t>
+              <a:t>ConfigMaps &amp; Secrets: Externalizing Config</a:t>
             </a:r>
             <a:endParaRPr lang="en-US" sz="3000" dirty="0"/>
           </a:p>
@@ -6967,568 +7389,14 @@
       </p:sp>
       <p:sp>
         <p:nvSpPr>
-          <p:cNvPr id="6" name="Shape 4"/>
-          <p:cNvSpPr/>
-          <p:nvPr/>
-        </p:nvSpPr>
-        <p:spPr>
-          <a:xfrm>
-            <a:off x="457200" y="1922526"/>
-            <a:ext cx="1976933" cy="854964"/>
-          </a:xfrm>
-          <a:prstGeom prst="roundRect">
-            <a:avLst>
-              <a:gd name="adj" fmla="val 10695"/>
-            </a:avLst>
-          </a:prstGeom>
-          <a:solidFill>
-            <a:srgbClr val="B8ECF5"/>
-          </a:solidFill>
-          <a:ln w="19050">
-            <a:solidFill>
-              <a:srgbClr val="007A90"/>
-            </a:solidFill>
-            <a:prstDash val="solid"/>
-          </a:ln>
-        </p:spPr>
-      </p:sp>
-      <p:sp>
-        <p:nvSpPr>
-          <p:cNvPr id="7" name="Text 5"/>
-          <p:cNvSpPr/>
-          <p:nvPr/>
-        </p:nvSpPr>
-        <p:spPr>
-          <a:xfrm>
-            <a:off x="457200" y="1922526"/>
-            <a:ext cx="1976933" cy="854964"/>
-          </a:xfrm>
-          <a:prstGeom prst="rect">
-            <a:avLst/>
-          </a:prstGeom>
-          <a:noFill/>
-          <a:ln/>
-        </p:spPr>
-        <p:txBody>
-          <a:bodyPr wrap="square" rtlCol="0" anchor="ctr"/>
-          <a:lstStyle/>
-          <a:p>
-            <a:pPr algn="ctr" indent="0" marL="0">
-              <a:buNone/>
-            </a:pPr>
-            <a:r>
-              <a:rPr lang="en-US" sz="1100" b="1" dirty="0">
-                <a:solidFill>
-                  <a:srgbClr val="0A1A1C"/>
-                </a:solidFill>
-                <a:latin typeface="Trebuchet MS" pitchFamily="34" charset="0"/>
-                <a:ea typeface="Trebuchet MS" pitchFamily="34" charset="-122"/>
-                <a:cs typeface="Trebuchet MS" pitchFamily="34" charset="-120"/>
-              </a:rPr>
-              <a:t>Secret</a:t>
-            </a:r>
-            <a:endParaRPr lang="en-US" sz="1100" dirty="0"/>
-          </a:p>
-          <a:p>
-            <a:pPr algn="ctr" indent="0" marL="0">
-              <a:buNone/>
-            </a:pPr>
-            <a:r>
-              <a:rPr lang="en-US" sz="1100" b="1" dirty="0">
-                <a:solidFill>
-                  <a:srgbClr val="0A1A1C"/>
-                </a:solidFill>
-                <a:latin typeface="Trebuchet MS" pitchFamily="34" charset="0"/>
-                <a:ea typeface="Trebuchet MS" pitchFamily="34" charset="-122"/>
-                <a:cs typeface="Trebuchet MS" pitchFamily="34" charset="-120"/>
-              </a:rPr>
-              <a:t>(mongo creds)</a:t>
-            </a:r>
-            <a:endParaRPr lang="en-US" sz="1100" dirty="0"/>
-          </a:p>
-        </p:txBody>
-      </p:sp>
-      <p:sp>
-        <p:nvSpPr>
-          <p:cNvPr id="8" name="Text 6"/>
-          <p:cNvSpPr/>
-          <p:nvPr/>
-        </p:nvSpPr>
-        <p:spPr>
-          <a:xfrm>
-            <a:off x="2434133" y="1922526"/>
-            <a:ext cx="347472" cy="854964"/>
-          </a:xfrm>
-          <a:prstGeom prst="rect">
-            <a:avLst/>
-          </a:prstGeom>
-          <a:noFill/>
-          <a:ln/>
-        </p:spPr>
-        <p:txBody>
-          <a:bodyPr wrap="square" rtlCol="0" anchor="ctr"/>
-          <a:lstStyle/>
-          <a:p>
-            <a:pPr algn="ctr" indent="0" marL="0">
-              <a:buNone/>
-            </a:pPr>
-            <a:r>
-              <a:rPr lang="en-US" sz="2200" dirty="0">
-                <a:solidFill>
-                  <a:srgbClr val="007A90"/>
-                </a:solidFill>
-                <a:latin typeface="Trebuchet MS" pitchFamily="34" charset="0"/>
-                <a:ea typeface="Trebuchet MS" pitchFamily="34" charset="-122"/>
-                <a:cs typeface="Trebuchet MS" pitchFamily="34" charset="-120"/>
-              </a:rPr>
-              <a:t>→</a:t>
-            </a:r>
-            <a:endParaRPr lang="en-US" sz="2200" dirty="0"/>
-          </a:p>
-        </p:txBody>
-      </p:sp>
-      <p:sp>
-        <p:nvSpPr>
-          <p:cNvPr id="9" name="Shape 7"/>
-          <p:cNvSpPr/>
-          <p:nvPr/>
-        </p:nvSpPr>
-        <p:spPr>
-          <a:xfrm>
-            <a:off x="2781605" y="1922526"/>
-            <a:ext cx="1976933" cy="854964"/>
-          </a:xfrm>
-          <a:prstGeom prst="roundRect">
-            <a:avLst>
-              <a:gd name="adj" fmla="val 10695"/>
-            </a:avLst>
-          </a:prstGeom>
-          <a:solidFill>
-            <a:srgbClr val="B8ECF5"/>
-          </a:solidFill>
-          <a:ln w="19050">
-            <a:solidFill>
-              <a:srgbClr val="007A90"/>
-            </a:solidFill>
-            <a:prstDash val="solid"/>
-          </a:ln>
-        </p:spPr>
-      </p:sp>
-      <p:sp>
-        <p:nvSpPr>
-          <p:cNvPr id="10" name="Text 8"/>
-          <p:cNvSpPr/>
-          <p:nvPr/>
-        </p:nvSpPr>
-        <p:spPr>
-          <a:xfrm>
-            <a:off x="2781605" y="1922526"/>
-            <a:ext cx="1976933" cy="854964"/>
-          </a:xfrm>
-          <a:prstGeom prst="rect">
-            <a:avLst/>
-          </a:prstGeom>
-          <a:noFill/>
-          <a:ln/>
-        </p:spPr>
-        <p:txBody>
-          <a:bodyPr wrap="square" rtlCol="0" anchor="ctr"/>
-          <a:lstStyle/>
-          <a:p>
-            <a:pPr algn="ctr" indent="0" marL="0">
-              <a:buNone/>
-            </a:pPr>
-            <a:r>
-              <a:rPr lang="en-US" sz="1100" dirty="0">
-                <a:solidFill>
-                  <a:srgbClr val="0A1A1C"/>
-                </a:solidFill>
-                <a:latin typeface="Trebuchet MS" pitchFamily="34" charset="0"/>
-                <a:ea typeface="Trebuchet MS" pitchFamily="34" charset="-122"/>
-                <a:cs typeface="Trebuchet MS" pitchFamily="34" charset="-120"/>
-              </a:rPr>
-              <a:t>MongoDB Deploy</a:t>
-            </a:r>
-            <a:endParaRPr lang="en-US" sz="1100" dirty="0"/>
-          </a:p>
-          <a:p>
-            <a:pPr algn="ctr" indent="0" marL="0">
-              <a:buNone/>
-            </a:pPr>
-            <a:r>
-              <a:rPr lang="en-US" sz="1100" dirty="0">
-                <a:solidFill>
-                  <a:srgbClr val="0A1A1C"/>
-                </a:solidFill>
-                <a:latin typeface="Trebuchet MS" pitchFamily="34" charset="0"/>
-                <a:ea typeface="Trebuchet MS" pitchFamily="34" charset="-122"/>
-                <a:cs typeface="Trebuchet MS" pitchFamily="34" charset="-120"/>
-              </a:rPr>
-              <a:t>+ ClusterIP Svc</a:t>
-            </a:r>
-            <a:endParaRPr lang="en-US" sz="1100" dirty="0"/>
-          </a:p>
-        </p:txBody>
-      </p:sp>
-      <p:sp>
-        <p:nvSpPr>
-          <p:cNvPr id="11" name="Text 9"/>
-          <p:cNvSpPr/>
-          <p:nvPr/>
-        </p:nvSpPr>
-        <p:spPr>
-          <a:xfrm>
-            <a:off x="4758538" y="1922526"/>
-            <a:ext cx="347472" cy="854964"/>
-          </a:xfrm>
-          <a:prstGeom prst="rect">
-            <a:avLst/>
-          </a:prstGeom>
-          <a:noFill/>
-          <a:ln/>
-        </p:spPr>
-        <p:txBody>
-          <a:bodyPr wrap="square" rtlCol="0" anchor="ctr"/>
-          <a:lstStyle/>
-          <a:p>
-            <a:pPr algn="ctr" indent="0" marL="0">
-              <a:buNone/>
-            </a:pPr>
-            <a:r>
-              <a:rPr lang="en-US" sz="2200" dirty="0">
-                <a:solidFill>
-                  <a:srgbClr val="007A90"/>
-                </a:solidFill>
-                <a:latin typeface="Trebuchet MS" pitchFamily="34" charset="0"/>
-                <a:ea typeface="Trebuchet MS" pitchFamily="34" charset="-122"/>
-                <a:cs typeface="Trebuchet MS" pitchFamily="34" charset="-120"/>
-              </a:rPr>
-              <a:t>→</a:t>
-            </a:r>
-            <a:endParaRPr lang="en-US" sz="2200" dirty="0"/>
-          </a:p>
-        </p:txBody>
-      </p:sp>
-      <p:sp>
-        <p:nvSpPr>
-          <p:cNvPr id="12" name="Shape 10"/>
-          <p:cNvSpPr/>
-          <p:nvPr/>
-        </p:nvSpPr>
-        <p:spPr>
-          <a:xfrm>
-            <a:off x="5106010" y="1922526"/>
-            <a:ext cx="1976933" cy="854964"/>
-          </a:xfrm>
-          <a:prstGeom prst="roundRect">
-            <a:avLst>
-              <a:gd name="adj" fmla="val 10695"/>
-            </a:avLst>
-          </a:prstGeom>
-          <a:solidFill>
-            <a:srgbClr val="B8ECF5"/>
-          </a:solidFill>
-          <a:ln w="19050">
-            <a:solidFill>
-              <a:srgbClr val="007A90"/>
-            </a:solidFill>
-            <a:prstDash val="solid"/>
-          </a:ln>
-        </p:spPr>
-      </p:sp>
-      <p:sp>
-        <p:nvSpPr>
-          <p:cNvPr id="13" name="Text 11"/>
-          <p:cNvSpPr/>
-          <p:nvPr/>
-        </p:nvSpPr>
-        <p:spPr>
-          <a:xfrm>
-            <a:off x="5106010" y="1922526"/>
-            <a:ext cx="1976933" cy="854964"/>
-          </a:xfrm>
-          <a:prstGeom prst="rect">
-            <a:avLst/>
-          </a:prstGeom>
-          <a:noFill/>
-          <a:ln/>
-        </p:spPr>
-        <p:txBody>
-          <a:bodyPr wrap="square" rtlCol="0" anchor="ctr"/>
-          <a:lstStyle/>
-          <a:p>
-            <a:pPr algn="ctr" indent="0" marL="0">
-              <a:buNone/>
-            </a:pPr>
-            <a:r>
-              <a:rPr lang="en-US" sz="1100" dirty="0">
-                <a:solidFill>
-                  <a:srgbClr val="0A1A1C"/>
-                </a:solidFill>
-                <a:latin typeface="Trebuchet MS" pitchFamily="34" charset="0"/>
-                <a:ea typeface="Trebuchet MS" pitchFamily="34" charset="-122"/>
-                <a:cs typeface="Trebuchet MS" pitchFamily="34" charset="-120"/>
-              </a:rPr>
-              <a:t>ConfigMap</a:t>
-            </a:r>
-            <a:endParaRPr lang="en-US" sz="1100" dirty="0"/>
-          </a:p>
-          <a:p>
-            <a:pPr algn="ctr" indent="0" marL="0">
-              <a:buNone/>
-            </a:pPr>
-            <a:r>
-              <a:rPr lang="en-US" sz="1100" dirty="0">
-                <a:solidFill>
-                  <a:srgbClr val="0A1A1C"/>
-                </a:solidFill>
-                <a:latin typeface="Trebuchet MS" pitchFamily="34" charset="0"/>
-                <a:ea typeface="Trebuchet MS" pitchFamily="34" charset="-122"/>
-                <a:cs typeface="Trebuchet MS" pitchFamily="34" charset="-120"/>
-              </a:rPr>
-              <a:t>(mongo URL)</a:t>
-            </a:r>
-            <a:endParaRPr lang="en-US" sz="1100" dirty="0"/>
-          </a:p>
-        </p:txBody>
-      </p:sp>
-      <p:sp>
-        <p:nvSpPr>
-          <p:cNvPr id="14" name="Text 12"/>
-          <p:cNvSpPr/>
-          <p:nvPr/>
-        </p:nvSpPr>
-        <p:spPr>
-          <a:xfrm>
-            <a:off x="7082942" y="1922526"/>
-            <a:ext cx="347472" cy="854964"/>
-          </a:xfrm>
-          <a:prstGeom prst="rect">
-            <a:avLst/>
-          </a:prstGeom>
-          <a:noFill/>
-          <a:ln/>
-        </p:spPr>
-        <p:txBody>
-          <a:bodyPr wrap="square" rtlCol="0" anchor="ctr"/>
-          <a:lstStyle/>
-          <a:p>
-            <a:pPr algn="ctr" indent="0" marL="0">
-              <a:buNone/>
-            </a:pPr>
-            <a:r>
-              <a:rPr lang="en-US" sz="2200" dirty="0">
-                <a:solidFill>
-                  <a:srgbClr val="007A90"/>
-                </a:solidFill>
-                <a:latin typeface="Trebuchet MS" pitchFamily="34" charset="0"/>
-                <a:ea typeface="Trebuchet MS" pitchFamily="34" charset="-122"/>
-                <a:cs typeface="Trebuchet MS" pitchFamily="34" charset="-120"/>
-              </a:rPr>
-              <a:t>→</a:t>
-            </a:r>
-            <a:endParaRPr lang="en-US" sz="2200" dirty="0"/>
-          </a:p>
-        </p:txBody>
-      </p:sp>
-      <p:sp>
-        <p:nvSpPr>
-          <p:cNvPr id="15" name="Shape 13"/>
-          <p:cNvSpPr/>
-          <p:nvPr/>
-        </p:nvSpPr>
-        <p:spPr>
-          <a:xfrm>
-            <a:off x="7430414" y="1922526"/>
-            <a:ext cx="1976933" cy="854964"/>
-          </a:xfrm>
-          <a:prstGeom prst="roundRect">
-            <a:avLst>
-              <a:gd name="adj" fmla="val 10695"/>
-            </a:avLst>
-          </a:prstGeom>
-          <a:solidFill>
-            <a:srgbClr val="B8ECF5"/>
-          </a:solidFill>
-          <a:ln w="19050">
-            <a:solidFill>
-              <a:srgbClr val="007A90"/>
-            </a:solidFill>
-            <a:prstDash val="solid"/>
-          </a:ln>
-        </p:spPr>
-      </p:sp>
-      <p:sp>
-        <p:nvSpPr>
-          <p:cNvPr id="16" name="Text 14"/>
-          <p:cNvSpPr/>
-          <p:nvPr/>
-        </p:nvSpPr>
-        <p:spPr>
-          <a:xfrm>
-            <a:off x="7430414" y="1922526"/>
-            <a:ext cx="1976933" cy="854964"/>
-          </a:xfrm>
-          <a:prstGeom prst="rect">
-            <a:avLst/>
-          </a:prstGeom>
-          <a:noFill/>
-          <a:ln/>
-        </p:spPr>
-        <p:txBody>
-          <a:bodyPr wrap="square" rtlCol="0" anchor="ctr"/>
-          <a:lstStyle/>
-          <a:p>
-            <a:pPr algn="ctr" indent="0" marL="0">
-              <a:buNone/>
-            </a:pPr>
-            <a:r>
-              <a:rPr lang="en-US" sz="1100" dirty="0">
-                <a:solidFill>
-                  <a:srgbClr val="0A1A1C"/>
-                </a:solidFill>
-                <a:latin typeface="Trebuchet MS" pitchFamily="34" charset="0"/>
-                <a:ea typeface="Trebuchet MS" pitchFamily="34" charset="-122"/>
-                <a:cs typeface="Trebuchet MS" pitchFamily="34" charset="-120"/>
-              </a:rPr>
-              <a:t>Web App Deploy</a:t>
-            </a:r>
-            <a:endParaRPr lang="en-US" sz="1100" dirty="0"/>
-          </a:p>
-          <a:p>
-            <a:pPr algn="ctr" indent="0" marL="0">
-              <a:buNone/>
-            </a:pPr>
-            <a:r>
-              <a:rPr lang="en-US" sz="1100" dirty="0">
-                <a:solidFill>
-                  <a:srgbClr val="0A1A1C"/>
-                </a:solidFill>
-                <a:latin typeface="Trebuchet MS" pitchFamily="34" charset="0"/>
-                <a:ea typeface="Trebuchet MS" pitchFamily="34" charset="-122"/>
-                <a:cs typeface="Trebuchet MS" pitchFamily="34" charset="-120"/>
-              </a:rPr>
-              <a:t>+ NodePort Svc</a:t>
-            </a:r>
-            <a:endParaRPr lang="en-US" sz="1100" dirty="0"/>
-          </a:p>
-        </p:txBody>
-      </p:sp>
-      <p:sp>
-        <p:nvSpPr>
-          <p:cNvPr id="17" name="Text 15"/>
-          <p:cNvSpPr/>
-          <p:nvPr/>
-        </p:nvSpPr>
-        <p:spPr>
-          <a:xfrm>
-            <a:off x="9407347" y="1922526"/>
-            <a:ext cx="347472" cy="854964"/>
-          </a:xfrm>
-          <a:prstGeom prst="rect">
-            <a:avLst/>
-          </a:prstGeom>
-          <a:noFill/>
-          <a:ln/>
-        </p:spPr>
-        <p:txBody>
-          <a:bodyPr wrap="square" rtlCol="0" anchor="ctr"/>
-          <a:lstStyle/>
-          <a:p>
-            <a:pPr algn="ctr" indent="0" marL="0">
-              <a:buNone/>
-            </a:pPr>
-            <a:r>
-              <a:rPr lang="en-US" sz="2200" dirty="0">
-                <a:solidFill>
-                  <a:srgbClr val="007A90"/>
-                </a:solidFill>
-                <a:latin typeface="Trebuchet MS" pitchFamily="34" charset="0"/>
-                <a:ea typeface="Trebuchet MS" pitchFamily="34" charset="-122"/>
-                <a:cs typeface="Trebuchet MS" pitchFamily="34" charset="-120"/>
-              </a:rPr>
-              <a:t>→</a:t>
-            </a:r>
-            <a:endParaRPr lang="en-US" sz="2200" dirty="0"/>
-          </a:p>
-        </p:txBody>
-      </p:sp>
-      <p:sp>
-        <p:nvSpPr>
-          <p:cNvPr id="18" name="Shape 16"/>
-          <p:cNvSpPr/>
-          <p:nvPr/>
-        </p:nvSpPr>
-        <p:spPr>
-          <a:xfrm>
-            <a:off x="9754819" y="1922526"/>
-            <a:ext cx="1976933" cy="854964"/>
-          </a:xfrm>
-          <a:prstGeom prst="roundRect">
-            <a:avLst>
-              <a:gd name="adj" fmla="val 10695"/>
-            </a:avLst>
-          </a:prstGeom>
-          <a:solidFill>
-            <a:srgbClr val="B8ECF5"/>
-          </a:solidFill>
-          <a:ln w="19050">
-            <a:solidFill>
-              <a:srgbClr val="007A90"/>
-            </a:solidFill>
-            <a:prstDash val="solid"/>
-          </a:ln>
-        </p:spPr>
-      </p:sp>
-      <p:sp>
-        <p:nvSpPr>
-          <p:cNvPr id="19" name="Text 17"/>
-          <p:cNvSpPr/>
-          <p:nvPr/>
-        </p:nvSpPr>
-        <p:spPr>
-          <a:xfrm>
-            <a:off x="9754819" y="1922526"/>
-            <a:ext cx="1976933" cy="854964"/>
-          </a:xfrm>
-          <a:prstGeom prst="rect">
-            <a:avLst/>
-          </a:prstGeom>
-          <a:noFill/>
-          <a:ln/>
-        </p:spPr>
-        <p:txBody>
-          <a:bodyPr wrap="square" rtlCol="0" anchor="ctr"/>
-          <a:lstStyle/>
-          <a:p>
-            <a:pPr algn="ctr" indent="0" marL="0">
-              <a:buNone/>
-            </a:pPr>
-            <a:r>
-              <a:rPr lang="en-US" sz="1100" b="1" dirty="0">
-                <a:solidFill>
-                  <a:srgbClr val="0A1A1C"/>
-                </a:solidFill>
-                <a:latin typeface="Trebuchet MS" pitchFamily="34" charset="0"/>
-                <a:ea typeface="Trebuchet MS" pitchFamily="34" charset="-122"/>
-                <a:cs typeface="Trebuchet MS" pitchFamily="34" charset="-120"/>
-              </a:rPr>
-              <a:t>Browser</a:t>
-            </a:r>
-            <a:endParaRPr lang="en-US" sz="1100" dirty="0"/>
-          </a:p>
-        </p:txBody>
-      </p:sp>
-      <p:sp>
-        <p:nvSpPr>
-          <p:cNvPr id="20" name="Text 18"/>
-          <p:cNvSpPr/>
-          <p:nvPr/>
-        </p:nvSpPr>
-        <p:spPr>
-          <a:xfrm>
-            <a:off x="457200" y="3310128"/>
-            <a:ext cx="11274552" cy="818388"/>
+          <p:cNvPr id="6" name="Text 4"/>
+          <p:cNvSpPr/>
+          <p:nvPr/>
+        </p:nvSpPr>
+        <p:spPr>
+          <a:xfrm>
+            <a:off x="457200" y="1572768"/>
+            <a:ext cx="11274552" cy="1252728"/>
           </a:xfrm>
           <a:prstGeom prst="rect">
             <a:avLst/>
@@ -7545,7 +7413,7 @@
               <a:buChar char="•"/>
             </a:pPr>
             <a:r>
-              <a:rPr lang="en-US" sz="1600" dirty="0">
+              <a:rPr lang="en-US" sz="2200" dirty="0">
                 <a:solidFill>
                   <a:srgbClr val="0A1A1C"/>
                 </a:solidFill>
@@ -7553,22 +7421,22 @@
                 <a:ea typeface="Trebuchet MS" pitchFamily="34" charset="-122"/>
                 <a:cs typeface="Trebuchet MS" pitchFamily="34" charset="-120"/>
               </a:rPr>
-              <a:t>Every concept from the last four sections combines into one two-tier system (web app + MongoDB)</a:t>
-            </a:r>
-            <a:endParaRPr lang="en-US" sz="1600" dirty="0"/>
-          </a:p>
-        </p:txBody>
-      </p:sp>
-      <p:sp>
-        <p:nvSpPr>
-          <p:cNvPr id="21" name="Text 19"/>
-          <p:cNvSpPr/>
-          <p:nvPr/>
-        </p:nvSpPr>
-        <p:spPr>
-          <a:xfrm>
-            <a:off x="457200" y="4128516"/>
-            <a:ext cx="11274552" cy="818388"/>
+              <a:t>Same container image should run unmodified across dev, staging, prod — only config and credentials should differ</a:t>
+            </a:r>
+            <a:endParaRPr lang="en-US" sz="2200" dirty="0"/>
+          </a:p>
+        </p:txBody>
+      </p:sp>
+      <p:sp>
+        <p:nvSpPr>
+          <p:cNvPr id="7" name="Text 5"/>
+          <p:cNvSpPr/>
+          <p:nvPr/>
+        </p:nvSpPr>
+        <p:spPr>
+          <a:xfrm>
+            <a:off x="457200" y="2825496"/>
+            <a:ext cx="11274552" cy="1252728"/>
           </a:xfrm>
           <a:prstGeom prst="rect">
             <a:avLst/>
@@ -7585,7 +7453,7 @@
               <a:buChar char="•"/>
             </a:pPr>
             <a:r>
-              <a:rPr lang="en-US" sz="1600" dirty="0">
+              <a:rPr lang="en-US" sz="2200" dirty="0">
                 <a:solidFill>
                   <a:srgbClr val="0A1A1C"/>
                 </a:solidFill>
@@ -7593,22 +7461,22 @@
                 <a:ea typeface="Trebuchet MS" pitchFamily="34" charset="-122"/>
                 <a:cs typeface="Trebuchet MS" pitchFamily="34" charset="-120"/>
               </a:rPr>
-              <a:t>Kubernetes gives every Service a DNS name matching its metadata.name — mongo-service resolves automatically, no IP involved</a:t>
-            </a:r>
-            <a:endParaRPr lang="en-US" sz="1600" dirty="0"/>
-          </a:p>
-        </p:txBody>
-      </p:sp>
-      <p:sp>
-        <p:nvSpPr>
-          <p:cNvPr id="22" name="Text 20"/>
-          <p:cNvSpPr/>
-          <p:nvPr/>
-        </p:nvSpPr>
-        <p:spPr>
-          <a:xfrm>
-            <a:off x="457200" y="4946904"/>
-            <a:ext cx="11274552" cy="818388"/>
+              <a:t>ConfigMap = plain configuration; Secret = sensitive values — same injection mechanism for both</a:t>
+            </a:r>
+            <a:endParaRPr lang="en-US" sz="2200" dirty="0"/>
+          </a:p>
+        </p:txBody>
+      </p:sp>
+      <p:sp>
+        <p:nvSpPr>
+          <p:cNvPr id="8" name="Text 6"/>
+          <p:cNvSpPr/>
+          <p:nvPr/>
+        </p:nvSpPr>
+        <p:spPr>
+          <a:xfrm>
+            <a:off x="457200" y="4078224"/>
+            <a:ext cx="11274552" cy="1252728"/>
           </a:xfrm>
           <a:prstGeom prst="rect">
             <a:avLst/>
@@ -7625,7 +7493,7 @@
               <a:buChar char="•"/>
             </a:pPr>
             <a:r>
-              <a:rPr lang="en-US" sz="1600" dirty="0">
+              <a:rPr lang="en-US" sz="2200" dirty="0">
                 <a:solidFill>
                   <a:srgbClr val="0A1A1C"/>
                 </a:solidFill>
@@ -7633,22 +7501,22 @@
                 <a:ea typeface="Trebuchet MS" pitchFamily="34" charset="-122"/>
                 <a:cs typeface="Trebuchet MS" pitchFamily="34" charset="-120"/>
               </a:rPr>
-              <a:t>Deploy order matters: the database's config must exist before the app that depends on it</a:t>
-            </a:r>
-            <a:endParaRPr lang="en-US" sz="1600" dirty="0"/>
-          </a:p>
-        </p:txBody>
-      </p:sp>
-      <p:sp>
-        <p:nvSpPr>
-          <p:cNvPr id="23" name="Text 21"/>
-          <p:cNvSpPr/>
-          <p:nvPr/>
-        </p:nvSpPr>
-        <p:spPr>
-          <a:xfrm>
-            <a:off x="457200" y="5765292"/>
-            <a:ext cx="11274552" cy="818388"/>
+              <a:t>Both referenced from a Pod via valueFrom.configMapKeyRef / valueFrom.secretKeyRef, injected as env vars at startup</a:t>
+            </a:r>
+            <a:endParaRPr lang="en-US" sz="2200" dirty="0"/>
+          </a:p>
+        </p:txBody>
+      </p:sp>
+      <p:sp>
+        <p:nvSpPr>
+          <p:cNvPr id="9" name="Text 7"/>
+          <p:cNvSpPr/>
+          <p:nvPr/>
+        </p:nvSpPr>
+        <p:spPr>
+          <a:xfrm>
+            <a:off x="457200" y="5330952"/>
+            <a:ext cx="11274552" cy="1252728"/>
           </a:xfrm>
           <a:prstGeom prst="rect">
             <a:avLst/>
@@ -7665,7 +7533,7 @@
               <a:buChar char="•"/>
             </a:pPr>
             <a:r>
-              <a:rPr lang="en-US" sz="1600" dirty="0">
+              <a:rPr lang="en-US" sz="2200" dirty="0">
                 <a:solidFill>
                   <a:srgbClr val="0A1A1C"/>
                 </a:solidFill>
@@ -7673,9 +7541,9 @@
                 <a:ea typeface="Trebuchet MS" pitchFamily="34" charset="-122"/>
                 <a:cs typeface="Trebuchet MS" pitchFamily="34" charset="-120"/>
               </a:rPr>
-              <a:t>Proof of wiring: kubectl exec deploy/webapp-deploy -- printenv MONGO_URL prints the full connection string, assembled purely from cluster objects</a:t>
-            </a:r>
-            <a:endParaRPr lang="en-US" sz="1600" dirty="0"/>
+              <a:t>Secrets are base64 encoded, not encrypted — anyone with API access can trivially decode them; fine for practice, not for production as-is</a:t>
+            </a:r>
+            <a:endParaRPr lang="en-US" sz="2200" dirty="0"/>
           </a:p>
         </p:txBody>
       </p:sp>
@@ -7808,7 +7676,7 @@
                 <a:ea typeface="Arial Black" pitchFamily="34" charset="-122"/>
                 <a:cs typeface="Arial Black" pitchFamily="34" charset="-120"/>
               </a:rPr>
-              <a:t>Gotchas &amp; Lessons</a:t>
+              <a:t>The Capstone: Wiring It All Together</a:t>
             </a:r>
             <a:endParaRPr lang="en-US" sz="3000" dirty="0"/>
           </a:p>
@@ -7841,14 +7709,568 @@
       </p:sp>
       <p:sp>
         <p:nvSpPr>
-          <p:cNvPr id="6" name="Text 4"/>
-          <p:cNvSpPr/>
-          <p:nvPr/>
-        </p:nvSpPr>
-        <p:spPr>
-          <a:xfrm>
-            <a:off x="457200" y="1572768"/>
-            <a:ext cx="11274552" cy="1252728"/>
+          <p:cNvPr id="6" name="Shape 4"/>
+          <p:cNvSpPr/>
+          <p:nvPr/>
+        </p:nvSpPr>
+        <p:spPr>
+          <a:xfrm>
+            <a:off x="457200" y="1922526"/>
+            <a:ext cx="1976933" cy="854964"/>
+          </a:xfrm>
+          <a:prstGeom prst="roundRect">
+            <a:avLst>
+              <a:gd name="adj" fmla="val 10695"/>
+            </a:avLst>
+          </a:prstGeom>
+          <a:solidFill>
+            <a:srgbClr val="B8ECF5"/>
+          </a:solidFill>
+          <a:ln w="19050">
+            <a:solidFill>
+              <a:srgbClr val="007A90"/>
+            </a:solidFill>
+            <a:prstDash val="solid"/>
+          </a:ln>
+        </p:spPr>
+      </p:sp>
+      <p:sp>
+        <p:nvSpPr>
+          <p:cNvPr id="7" name="Text 5"/>
+          <p:cNvSpPr/>
+          <p:nvPr/>
+        </p:nvSpPr>
+        <p:spPr>
+          <a:xfrm>
+            <a:off x="457200" y="1922526"/>
+            <a:ext cx="1976933" cy="854964"/>
+          </a:xfrm>
+          <a:prstGeom prst="rect">
+            <a:avLst/>
+          </a:prstGeom>
+          <a:noFill/>
+          <a:ln/>
+        </p:spPr>
+        <p:txBody>
+          <a:bodyPr wrap="square" rtlCol="0" anchor="ctr"/>
+          <a:lstStyle/>
+          <a:p>
+            <a:pPr algn="ctr" indent="0" marL="0">
+              <a:buNone/>
+            </a:pPr>
+            <a:r>
+              <a:rPr lang="en-US" sz="1100" b="1" dirty="0">
+                <a:solidFill>
+                  <a:srgbClr val="0A1A1C"/>
+                </a:solidFill>
+                <a:latin typeface="Trebuchet MS" pitchFamily="34" charset="0"/>
+                <a:ea typeface="Trebuchet MS" pitchFamily="34" charset="-122"/>
+                <a:cs typeface="Trebuchet MS" pitchFamily="34" charset="-120"/>
+              </a:rPr>
+              <a:t>Secret</a:t>
+            </a:r>
+            <a:endParaRPr lang="en-US" sz="1100" dirty="0"/>
+          </a:p>
+          <a:p>
+            <a:pPr algn="ctr" indent="0" marL="0">
+              <a:buNone/>
+            </a:pPr>
+            <a:r>
+              <a:rPr lang="en-US" sz="1100" b="1" dirty="0">
+                <a:solidFill>
+                  <a:srgbClr val="0A1A1C"/>
+                </a:solidFill>
+                <a:latin typeface="Trebuchet MS" pitchFamily="34" charset="0"/>
+                <a:ea typeface="Trebuchet MS" pitchFamily="34" charset="-122"/>
+                <a:cs typeface="Trebuchet MS" pitchFamily="34" charset="-120"/>
+              </a:rPr>
+              <a:t>(mongo creds)</a:t>
+            </a:r>
+            <a:endParaRPr lang="en-US" sz="1100" dirty="0"/>
+          </a:p>
+        </p:txBody>
+      </p:sp>
+      <p:sp>
+        <p:nvSpPr>
+          <p:cNvPr id="8" name="Text 6"/>
+          <p:cNvSpPr/>
+          <p:nvPr/>
+        </p:nvSpPr>
+        <p:spPr>
+          <a:xfrm>
+            <a:off x="2434133" y="1922526"/>
+            <a:ext cx="347472" cy="854964"/>
+          </a:xfrm>
+          <a:prstGeom prst="rect">
+            <a:avLst/>
+          </a:prstGeom>
+          <a:noFill/>
+          <a:ln/>
+        </p:spPr>
+        <p:txBody>
+          <a:bodyPr wrap="square" rtlCol="0" anchor="ctr"/>
+          <a:lstStyle/>
+          <a:p>
+            <a:pPr algn="ctr" indent="0" marL="0">
+              <a:buNone/>
+            </a:pPr>
+            <a:r>
+              <a:rPr lang="en-US" sz="2200" dirty="0">
+                <a:solidFill>
+                  <a:srgbClr val="007A90"/>
+                </a:solidFill>
+                <a:latin typeface="Trebuchet MS" pitchFamily="34" charset="0"/>
+                <a:ea typeface="Trebuchet MS" pitchFamily="34" charset="-122"/>
+                <a:cs typeface="Trebuchet MS" pitchFamily="34" charset="-120"/>
+              </a:rPr>
+              <a:t>→</a:t>
+            </a:r>
+            <a:endParaRPr lang="en-US" sz="2200" dirty="0"/>
+          </a:p>
+        </p:txBody>
+      </p:sp>
+      <p:sp>
+        <p:nvSpPr>
+          <p:cNvPr id="9" name="Shape 7"/>
+          <p:cNvSpPr/>
+          <p:nvPr/>
+        </p:nvSpPr>
+        <p:spPr>
+          <a:xfrm>
+            <a:off x="2781605" y="1922526"/>
+            <a:ext cx="1976933" cy="854964"/>
+          </a:xfrm>
+          <a:prstGeom prst="roundRect">
+            <a:avLst>
+              <a:gd name="adj" fmla="val 10695"/>
+            </a:avLst>
+          </a:prstGeom>
+          <a:solidFill>
+            <a:srgbClr val="B8ECF5"/>
+          </a:solidFill>
+          <a:ln w="19050">
+            <a:solidFill>
+              <a:srgbClr val="007A90"/>
+            </a:solidFill>
+            <a:prstDash val="solid"/>
+          </a:ln>
+        </p:spPr>
+      </p:sp>
+      <p:sp>
+        <p:nvSpPr>
+          <p:cNvPr id="10" name="Text 8"/>
+          <p:cNvSpPr/>
+          <p:nvPr/>
+        </p:nvSpPr>
+        <p:spPr>
+          <a:xfrm>
+            <a:off x="2781605" y="1922526"/>
+            <a:ext cx="1976933" cy="854964"/>
+          </a:xfrm>
+          <a:prstGeom prst="rect">
+            <a:avLst/>
+          </a:prstGeom>
+          <a:noFill/>
+          <a:ln/>
+        </p:spPr>
+        <p:txBody>
+          <a:bodyPr wrap="square" rtlCol="0" anchor="ctr"/>
+          <a:lstStyle/>
+          <a:p>
+            <a:pPr algn="ctr" indent="0" marL="0">
+              <a:buNone/>
+            </a:pPr>
+            <a:r>
+              <a:rPr lang="en-US" sz="1100" dirty="0">
+                <a:solidFill>
+                  <a:srgbClr val="0A1A1C"/>
+                </a:solidFill>
+                <a:latin typeface="Trebuchet MS" pitchFamily="34" charset="0"/>
+                <a:ea typeface="Trebuchet MS" pitchFamily="34" charset="-122"/>
+                <a:cs typeface="Trebuchet MS" pitchFamily="34" charset="-120"/>
+              </a:rPr>
+              <a:t>MongoDB Deploy</a:t>
+            </a:r>
+            <a:endParaRPr lang="en-US" sz="1100" dirty="0"/>
+          </a:p>
+          <a:p>
+            <a:pPr algn="ctr" indent="0" marL="0">
+              <a:buNone/>
+            </a:pPr>
+            <a:r>
+              <a:rPr lang="en-US" sz="1100" dirty="0">
+                <a:solidFill>
+                  <a:srgbClr val="0A1A1C"/>
+                </a:solidFill>
+                <a:latin typeface="Trebuchet MS" pitchFamily="34" charset="0"/>
+                <a:ea typeface="Trebuchet MS" pitchFamily="34" charset="-122"/>
+                <a:cs typeface="Trebuchet MS" pitchFamily="34" charset="-120"/>
+              </a:rPr>
+              <a:t>+ ClusterIP Svc</a:t>
+            </a:r>
+            <a:endParaRPr lang="en-US" sz="1100" dirty="0"/>
+          </a:p>
+        </p:txBody>
+      </p:sp>
+      <p:sp>
+        <p:nvSpPr>
+          <p:cNvPr id="11" name="Text 9"/>
+          <p:cNvSpPr/>
+          <p:nvPr/>
+        </p:nvSpPr>
+        <p:spPr>
+          <a:xfrm>
+            <a:off x="4758538" y="1922526"/>
+            <a:ext cx="347472" cy="854964"/>
+          </a:xfrm>
+          <a:prstGeom prst="rect">
+            <a:avLst/>
+          </a:prstGeom>
+          <a:noFill/>
+          <a:ln/>
+        </p:spPr>
+        <p:txBody>
+          <a:bodyPr wrap="square" rtlCol="0" anchor="ctr"/>
+          <a:lstStyle/>
+          <a:p>
+            <a:pPr algn="ctr" indent="0" marL="0">
+              <a:buNone/>
+            </a:pPr>
+            <a:r>
+              <a:rPr lang="en-US" sz="2200" dirty="0">
+                <a:solidFill>
+                  <a:srgbClr val="007A90"/>
+                </a:solidFill>
+                <a:latin typeface="Trebuchet MS" pitchFamily="34" charset="0"/>
+                <a:ea typeface="Trebuchet MS" pitchFamily="34" charset="-122"/>
+                <a:cs typeface="Trebuchet MS" pitchFamily="34" charset="-120"/>
+              </a:rPr>
+              <a:t>→</a:t>
+            </a:r>
+            <a:endParaRPr lang="en-US" sz="2200" dirty="0"/>
+          </a:p>
+        </p:txBody>
+      </p:sp>
+      <p:sp>
+        <p:nvSpPr>
+          <p:cNvPr id="12" name="Shape 10"/>
+          <p:cNvSpPr/>
+          <p:nvPr/>
+        </p:nvSpPr>
+        <p:spPr>
+          <a:xfrm>
+            <a:off x="5106010" y="1922526"/>
+            <a:ext cx="1976933" cy="854964"/>
+          </a:xfrm>
+          <a:prstGeom prst="roundRect">
+            <a:avLst>
+              <a:gd name="adj" fmla="val 10695"/>
+            </a:avLst>
+          </a:prstGeom>
+          <a:solidFill>
+            <a:srgbClr val="B8ECF5"/>
+          </a:solidFill>
+          <a:ln w="19050">
+            <a:solidFill>
+              <a:srgbClr val="007A90"/>
+            </a:solidFill>
+            <a:prstDash val="solid"/>
+          </a:ln>
+        </p:spPr>
+      </p:sp>
+      <p:sp>
+        <p:nvSpPr>
+          <p:cNvPr id="13" name="Text 11"/>
+          <p:cNvSpPr/>
+          <p:nvPr/>
+        </p:nvSpPr>
+        <p:spPr>
+          <a:xfrm>
+            <a:off x="5106010" y="1922526"/>
+            <a:ext cx="1976933" cy="854964"/>
+          </a:xfrm>
+          <a:prstGeom prst="rect">
+            <a:avLst/>
+          </a:prstGeom>
+          <a:noFill/>
+          <a:ln/>
+        </p:spPr>
+        <p:txBody>
+          <a:bodyPr wrap="square" rtlCol="0" anchor="ctr"/>
+          <a:lstStyle/>
+          <a:p>
+            <a:pPr algn="ctr" indent="0" marL="0">
+              <a:buNone/>
+            </a:pPr>
+            <a:r>
+              <a:rPr lang="en-US" sz="1100" dirty="0">
+                <a:solidFill>
+                  <a:srgbClr val="0A1A1C"/>
+                </a:solidFill>
+                <a:latin typeface="Trebuchet MS" pitchFamily="34" charset="0"/>
+                <a:ea typeface="Trebuchet MS" pitchFamily="34" charset="-122"/>
+                <a:cs typeface="Trebuchet MS" pitchFamily="34" charset="-120"/>
+              </a:rPr>
+              <a:t>ConfigMap</a:t>
+            </a:r>
+            <a:endParaRPr lang="en-US" sz="1100" dirty="0"/>
+          </a:p>
+          <a:p>
+            <a:pPr algn="ctr" indent="0" marL="0">
+              <a:buNone/>
+            </a:pPr>
+            <a:r>
+              <a:rPr lang="en-US" sz="1100" dirty="0">
+                <a:solidFill>
+                  <a:srgbClr val="0A1A1C"/>
+                </a:solidFill>
+                <a:latin typeface="Trebuchet MS" pitchFamily="34" charset="0"/>
+                <a:ea typeface="Trebuchet MS" pitchFamily="34" charset="-122"/>
+                <a:cs typeface="Trebuchet MS" pitchFamily="34" charset="-120"/>
+              </a:rPr>
+              <a:t>(mongo URL)</a:t>
+            </a:r>
+            <a:endParaRPr lang="en-US" sz="1100" dirty="0"/>
+          </a:p>
+        </p:txBody>
+      </p:sp>
+      <p:sp>
+        <p:nvSpPr>
+          <p:cNvPr id="14" name="Text 12"/>
+          <p:cNvSpPr/>
+          <p:nvPr/>
+        </p:nvSpPr>
+        <p:spPr>
+          <a:xfrm>
+            <a:off x="7082942" y="1922526"/>
+            <a:ext cx="347472" cy="854964"/>
+          </a:xfrm>
+          <a:prstGeom prst="rect">
+            <a:avLst/>
+          </a:prstGeom>
+          <a:noFill/>
+          <a:ln/>
+        </p:spPr>
+        <p:txBody>
+          <a:bodyPr wrap="square" rtlCol="0" anchor="ctr"/>
+          <a:lstStyle/>
+          <a:p>
+            <a:pPr algn="ctr" indent="0" marL="0">
+              <a:buNone/>
+            </a:pPr>
+            <a:r>
+              <a:rPr lang="en-US" sz="2200" dirty="0">
+                <a:solidFill>
+                  <a:srgbClr val="007A90"/>
+                </a:solidFill>
+                <a:latin typeface="Trebuchet MS" pitchFamily="34" charset="0"/>
+                <a:ea typeface="Trebuchet MS" pitchFamily="34" charset="-122"/>
+                <a:cs typeface="Trebuchet MS" pitchFamily="34" charset="-120"/>
+              </a:rPr>
+              <a:t>→</a:t>
+            </a:r>
+            <a:endParaRPr lang="en-US" sz="2200" dirty="0"/>
+          </a:p>
+        </p:txBody>
+      </p:sp>
+      <p:sp>
+        <p:nvSpPr>
+          <p:cNvPr id="15" name="Shape 13"/>
+          <p:cNvSpPr/>
+          <p:nvPr/>
+        </p:nvSpPr>
+        <p:spPr>
+          <a:xfrm>
+            <a:off x="7430414" y="1922526"/>
+            <a:ext cx="1976933" cy="854964"/>
+          </a:xfrm>
+          <a:prstGeom prst="roundRect">
+            <a:avLst>
+              <a:gd name="adj" fmla="val 10695"/>
+            </a:avLst>
+          </a:prstGeom>
+          <a:solidFill>
+            <a:srgbClr val="B8ECF5"/>
+          </a:solidFill>
+          <a:ln w="19050">
+            <a:solidFill>
+              <a:srgbClr val="007A90"/>
+            </a:solidFill>
+            <a:prstDash val="solid"/>
+          </a:ln>
+        </p:spPr>
+      </p:sp>
+      <p:sp>
+        <p:nvSpPr>
+          <p:cNvPr id="16" name="Text 14"/>
+          <p:cNvSpPr/>
+          <p:nvPr/>
+        </p:nvSpPr>
+        <p:spPr>
+          <a:xfrm>
+            <a:off x="7430414" y="1922526"/>
+            <a:ext cx="1976933" cy="854964"/>
+          </a:xfrm>
+          <a:prstGeom prst="rect">
+            <a:avLst/>
+          </a:prstGeom>
+          <a:noFill/>
+          <a:ln/>
+        </p:spPr>
+        <p:txBody>
+          <a:bodyPr wrap="square" rtlCol="0" anchor="ctr"/>
+          <a:lstStyle/>
+          <a:p>
+            <a:pPr algn="ctr" indent="0" marL="0">
+              <a:buNone/>
+            </a:pPr>
+            <a:r>
+              <a:rPr lang="en-US" sz="1100" dirty="0">
+                <a:solidFill>
+                  <a:srgbClr val="0A1A1C"/>
+                </a:solidFill>
+                <a:latin typeface="Trebuchet MS" pitchFamily="34" charset="0"/>
+                <a:ea typeface="Trebuchet MS" pitchFamily="34" charset="-122"/>
+                <a:cs typeface="Trebuchet MS" pitchFamily="34" charset="-120"/>
+              </a:rPr>
+              <a:t>Web App Deploy</a:t>
+            </a:r>
+            <a:endParaRPr lang="en-US" sz="1100" dirty="0"/>
+          </a:p>
+          <a:p>
+            <a:pPr algn="ctr" indent="0" marL="0">
+              <a:buNone/>
+            </a:pPr>
+            <a:r>
+              <a:rPr lang="en-US" sz="1100" dirty="0">
+                <a:solidFill>
+                  <a:srgbClr val="0A1A1C"/>
+                </a:solidFill>
+                <a:latin typeface="Trebuchet MS" pitchFamily="34" charset="0"/>
+                <a:ea typeface="Trebuchet MS" pitchFamily="34" charset="-122"/>
+                <a:cs typeface="Trebuchet MS" pitchFamily="34" charset="-120"/>
+              </a:rPr>
+              <a:t>+ NodePort Svc</a:t>
+            </a:r>
+            <a:endParaRPr lang="en-US" sz="1100" dirty="0"/>
+          </a:p>
+        </p:txBody>
+      </p:sp>
+      <p:sp>
+        <p:nvSpPr>
+          <p:cNvPr id="17" name="Text 15"/>
+          <p:cNvSpPr/>
+          <p:nvPr/>
+        </p:nvSpPr>
+        <p:spPr>
+          <a:xfrm>
+            <a:off x="9407347" y="1922526"/>
+            <a:ext cx="347472" cy="854964"/>
+          </a:xfrm>
+          <a:prstGeom prst="rect">
+            <a:avLst/>
+          </a:prstGeom>
+          <a:noFill/>
+          <a:ln/>
+        </p:spPr>
+        <p:txBody>
+          <a:bodyPr wrap="square" rtlCol="0" anchor="ctr"/>
+          <a:lstStyle/>
+          <a:p>
+            <a:pPr algn="ctr" indent="0" marL="0">
+              <a:buNone/>
+            </a:pPr>
+            <a:r>
+              <a:rPr lang="en-US" sz="2200" dirty="0">
+                <a:solidFill>
+                  <a:srgbClr val="007A90"/>
+                </a:solidFill>
+                <a:latin typeface="Trebuchet MS" pitchFamily="34" charset="0"/>
+                <a:ea typeface="Trebuchet MS" pitchFamily="34" charset="-122"/>
+                <a:cs typeface="Trebuchet MS" pitchFamily="34" charset="-120"/>
+              </a:rPr>
+              <a:t>→</a:t>
+            </a:r>
+            <a:endParaRPr lang="en-US" sz="2200" dirty="0"/>
+          </a:p>
+        </p:txBody>
+      </p:sp>
+      <p:sp>
+        <p:nvSpPr>
+          <p:cNvPr id="18" name="Shape 16"/>
+          <p:cNvSpPr/>
+          <p:nvPr/>
+        </p:nvSpPr>
+        <p:spPr>
+          <a:xfrm>
+            <a:off x="9754819" y="1922526"/>
+            <a:ext cx="1976933" cy="854964"/>
+          </a:xfrm>
+          <a:prstGeom prst="roundRect">
+            <a:avLst>
+              <a:gd name="adj" fmla="val 10695"/>
+            </a:avLst>
+          </a:prstGeom>
+          <a:solidFill>
+            <a:srgbClr val="B8ECF5"/>
+          </a:solidFill>
+          <a:ln w="19050">
+            <a:solidFill>
+              <a:srgbClr val="007A90"/>
+            </a:solidFill>
+            <a:prstDash val="solid"/>
+          </a:ln>
+        </p:spPr>
+      </p:sp>
+      <p:sp>
+        <p:nvSpPr>
+          <p:cNvPr id="19" name="Text 17"/>
+          <p:cNvSpPr/>
+          <p:nvPr/>
+        </p:nvSpPr>
+        <p:spPr>
+          <a:xfrm>
+            <a:off x="9754819" y="1922526"/>
+            <a:ext cx="1976933" cy="854964"/>
+          </a:xfrm>
+          <a:prstGeom prst="rect">
+            <a:avLst/>
+          </a:prstGeom>
+          <a:noFill/>
+          <a:ln/>
+        </p:spPr>
+        <p:txBody>
+          <a:bodyPr wrap="square" rtlCol="0" anchor="ctr"/>
+          <a:lstStyle/>
+          <a:p>
+            <a:pPr algn="ctr" indent="0" marL="0">
+              <a:buNone/>
+            </a:pPr>
+            <a:r>
+              <a:rPr lang="en-US" sz="1100" b="1" dirty="0">
+                <a:solidFill>
+                  <a:srgbClr val="0A1A1C"/>
+                </a:solidFill>
+                <a:latin typeface="Trebuchet MS" pitchFamily="34" charset="0"/>
+                <a:ea typeface="Trebuchet MS" pitchFamily="34" charset="-122"/>
+                <a:cs typeface="Trebuchet MS" pitchFamily="34" charset="-120"/>
+              </a:rPr>
+              <a:t>Browser</a:t>
+            </a:r>
+            <a:endParaRPr lang="en-US" sz="1100" dirty="0"/>
+          </a:p>
+        </p:txBody>
+      </p:sp>
+      <p:sp>
+        <p:nvSpPr>
+          <p:cNvPr id="20" name="Text 18"/>
+          <p:cNvSpPr/>
+          <p:nvPr/>
+        </p:nvSpPr>
+        <p:spPr>
+          <a:xfrm>
+            <a:off x="457200" y="3310128"/>
+            <a:ext cx="11274552" cy="818388"/>
           </a:xfrm>
           <a:prstGeom prst="rect">
             <a:avLst/>
@@ -7865,7 +8287,7 @@
               <a:buChar char="•"/>
             </a:pPr>
             <a:r>
-              <a:rPr lang="en-US" sz="2200" dirty="0">
+              <a:rPr lang="en-US" sz="1600" dirty="0">
                 <a:solidFill>
                   <a:srgbClr val="0A1A1C"/>
                 </a:solidFill>
@@ -7873,22 +8295,22 @@
                 <a:ea typeface="Trebuchet MS" pitchFamily="34" charset="-122"/>
                 <a:cs typeface="Trebuchet MS" pitchFamily="34" charset="-120"/>
               </a:rPr>
-              <a:t>Most common real failure across Modules 1–5: a typo in key: or name: inside a configMapKeyRef/secretKeyRef → shows up as CreateContainerConfigError</a:t>
-            </a:r>
-            <a:endParaRPr lang="en-US" sz="2200" dirty="0"/>
-          </a:p>
-        </p:txBody>
-      </p:sp>
-      <p:sp>
-        <p:nvSpPr>
-          <p:cNvPr id="7" name="Text 5"/>
-          <p:cNvSpPr/>
-          <p:nvPr/>
-        </p:nvSpPr>
-        <p:spPr>
-          <a:xfrm>
-            <a:off x="457200" y="2825496"/>
-            <a:ext cx="11274552" cy="1252728"/>
+              <a:t>Every object type covered so far combines into one two-tier system (web app + MongoDB)</a:t>
+            </a:r>
+            <a:endParaRPr lang="en-US" sz="1600" dirty="0"/>
+          </a:p>
+        </p:txBody>
+      </p:sp>
+      <p:sp>
+        <p:nvSpPr>
+          <p:cNvPr id="21" name="Text 19"/>
+          <p:cNvSpPr/>
+          <p:nvPr/>
+        </p:nvSpPr>
+        <p:spPr>
+          <a:xfrm>
+            <a:off x="457200" y="4128516"/>
+            <a:ext cx="11274552" cy="818388"/>
           </a:xfrm>
           <a:prstGeom prst="rect">
             <a:avLst/>
@@ -7905,7 +8327,7 @@
               <a:buChar char="•"/>
             </a:pPr>
             <a:r>
-              <a:rPr lang="en-US" sz="2200" dirty="0">
+              <a:rPr lang="en-US" sz="1600" dirty="0">
                 <a:solidFill>
                   <a:srgbClr val="0A1A1C"/>
                 </a:solidFill>
@@ -7913,22 +8335,22 @@
                 <a:ea typeface="Trebuchet MS" pitchFamily="34" charset="-122"/>
                 <a:cs typeface="Trebuchet MS" pitchFamily="34" charset="-120"/>
               </a:rPr>
-              <a:t>kubectl describe pod → the Events section is always the first move to diagnose a broken Pod</a:t>
-            </a:r>
-            <a:endParaRPr lang="en-US" sz="2200" dirty="0"/>
-          </a:p>
-        </p:txBody>
-      </p:sp>
-      <p:sp>
-        <p:nvSpPr>
-          <p:cNvPr id="8" name="Text 6"/>
-          <p:cNvSpPr/>
-          <p:nvPr/>
-        </p:nvSpPr>
-        <p:spPr>
-          <a:xfrm>
-            <a:off x="457200" y="4078224"/>
-            <a:ext cx="11274552" cy="1252728"/>
+              <a:t>Kubernetes gives every Service a DNS name matching its metadata.name — mongo-service resolves automatically, no IP involved</a:t>
+            </a:r>
+            <a:endParaRPr lang="en-US" sz="1600" dirty="0"/>
+          </a:p>
+        </p:txBody>
+      </p:sp>
+      <p:sp>
+        <p:nvSpPr>
+          <p:cNvPr id="22" name="Text 20"/>
+          <p:cNvSpPr/>
+          <p:nvPr/>
+        </p:nvSpPr>
+        <p:spPr>
+          <a:xfrm>
+            <a:off x="457200" y="4946904"/>
+            <a:ext cx="11274552" cy="818388"/>
           </a:xfrm>
           <a:prstGeom prst="rect">
             <a:avLst/>
@@ -7945,7 +8367,7 @@
               <a:buChar char="•"/>
             </a:pPr>
             <a:r>
-              <a:rPr lang="en-US" sz="2200" dirty="0">
+              <a:rPr lang="en-US" sz="1600" dirty="0">
                 <a:solidFill>
                   <a:srgbClr val="0A1A1C"/>
                 </a:solidFill>
@@ -7953,22 +8375,22 @@
                 <a:ea typeface="Trebuchet MS" pitchFamily="34" charset="-122"/>
                 <a:cs typeface="Trebuchet MS" pitchFamily="34" charset="-120"/>
               </a:rPr>
-              <a:t>Podman's Minikube driver is explicitly experimental — --driver=docker is the fallback if you hit an uncovered wall</a:t>
-            </a:r>
-            <a:endParaRPr lang="en-US" sz="2200" dirty="0"/>
-          </a:p>
-        </p:txBody>
-      </p:sp>
-      <p:sp>
-        <p:nvSpPr>
-          <p:cNvPr id="9" name="Text 7"/>
-          <p:cNvSpPr/>
-          <p:nvPr/>
-        </p:nvSpPr>
-        <p:spPr>
-          <a:xfrm>
-            <a:off x="457200" y="5330952"/>
-            <a:ext cx="11274552" cy="1252728"/>
+              <a:t>Deploy order matters: the database's config must exist before the app that depends on it</a:t>
+            </a:r>
+            <a:endParaRPr lang="en-US" sz="1600" dirty="0"/>
+          </a:p>
+        </p:txBody>
+      </p:sp>
+      <p:sp>
+        <p:nvSpPr>
+          <p:cNvPr id="23" name="Text 21"/>
+          <p:cNvSpPr/>
+          <p:nvPr/>
+        </p:nvSpPr>
+        <p:spPr>
+          <a:xfrm>
+            <a:off x="457200" y="5765292"/>
+            <a:ext cx="11274552" cy="818388"/>
           </a:xfrm>
           <a:prstGeom prst="rect">
             <a:avLst/>
@@ -7985,7 +8407,7 @@
               <a:buChar char="•"/>
             </a:pPr>
             <a:r>
-              <a:rPr lang="en-US" sz="2200" dirty="0">
+              <a:rPr lang="en-US" sz="1600" dirty="0">
                 <a:solidFill>
                   <a:srgbClr val="0A1A1C"/>
                 </a:solidFill>
@@ -7993,9 +8415,9 @@
                 <a:ea typeface="Trebuchet MS" pitchFamily="34" charset="-122"/>
                 <a:cs typeface="Trebuchet MS" pitchFamily="34" charset="-120"/>
               </a:rPr>
-              <a:t>Base64 is encoding, not encryption — don't mistake a Secret for something actually secured</a:t>
-            </a:r>
-            <a:endParaRPr lang="en-US" sz="2200" dirty="0"/>
+              <a:t>Proof of wiring: kubectl exec deploy/webapp-deploy -- printenv MONGO_URL prints the full connection string, assembled purely from cluster objects</a:t>
+            </a:r>
+            <a:endParaRPr lang="en-US" sz="1600" dirty="0"/>
           </a:p>
         </p:txBody>
       </p:sp>
@@ -8488,7 +8910,7 @@
                 <a:ea typeface="Arial Black" pitchFamily="34" charset="-122"/>
                 <a:cs typeface="Arial Black" pitchFamily="34" charset="-120"/>
               </a:rPr>
-              <a:t>Key Insight</a:t>
+              <a:t>Gotchas &amp; Lessons</a:t>
             </a:r>
             <a:endParaRPr lang="en-US" sz="3000" dirty="0"/>
           </a:p>
@@ -8521,53 +8943,83 @@
       </p:sp>
       <p:sp>
         <p:nvSpPr>
-          <p:cNvPr id="6" name="Shape 4"/>
-          <p:cNvSpPr/>
-          <p:nvPr/>
-        </p:nvSpPr>
-        <p:spPr>
-          <a:xfrm>
-            <a:off x="457200" y="2029968"/>
-            <a:ext cx="11274552" cy="4096512"/>
-          </a:xfrm>
-          <a:prstGeom prst="rect">
-            <a:avLst/>
-          </a:prstGeom>
-          <a:solidFill>
-            <a:srgbClr val="B8ECF5"/>
-          </a:solidFill>
-          <a:ln w="25400">
-            <a:solidFill>
-              <a:srgbClr val="007A90"/>
-            </a:solidFill>
-            <a:prstDash val="solid"/>
-          </a:ln>
-        </p:spPr>
-      </p:sp>
-      <p:sp>
-        <p:nvSpPr>
-          <p:cNvPr id="7" name="Shape 5"/>
-          <p:cNvSpPr/>
-          <p:nvPr/>
-        </p:nvSpPr>
-        <p:spPr>
-          <a:xfrm>
-            <a:off x="457200" y="2029968"/>
-            <a:ext cx="73152" cy="4096512"/>
-          </a:xfrm>
-          <a:prstGeom prst="rect">
-            <a:avLst/>
-          </a:prstGeom>
-          <a:solidFill>
-            <a:srgbClr val="007A90"/>
-          </a:solidFill>
-          <a:ln w="12700">
-            <a:solidFill>
-              <a:srgbClr val="007A90"/>
-            </a:solidFill>
-            <a:prstDash val="solid"/>
-          </a:ln>
-        </p:spPr>
+          <p:cNvPr id="6" name="Text 4"/>
+          <p:cNvSpPr/>
+          <p:nvPr/>
+        </p:nvSpPr>
+        <p:spPr>
+          <a:xfrm>
+            <a:off x="457200" y="1572768"/>
+            <a:ext cx="11274552" cy="1252728"/>
+          </a:xfrm>
+          <a:prstGeom prst="rect">
+            <a:avLst/>
+          </a:prstGeom>
+          <a:noFill/>
+          <a:ln/>
+        </p:spPr>
+        <p:txBody>
+          <a:bodyPr wrap="square" rtlCol="0" anchor="ctr"/>
+          <a:lstStyle/>
+          <a:p>
+            <a:pPr marL="254000" indent="-254000">
+              <a:buSzPct val="100000"/>
+              <a:buChar char="•"/>
+            </a:pPr>
+            <a:r>
+              <a:rPr lang="en-US" sz="2200" dirty="0">
+                <a:solidFill>
+                  <a:srgbClr val="0A1A1C"/>
+                </a:solidFill>
+                <a:latin typeface="Trebuchet MS" pitchFamily="34" charset="0"/>
+                <a:ea typeface="Trebuchet MS" pitchFamily="34" charset="-122"/>
+                <a:cs typeface="Trebuchet MS" pitchFamily="34" charset="-120"/>
+              </a:rPr>
+              <a:t>Most common real failure across Modules 1–5: a typo in key: or name: inside a configMapKeyRef/secretKeyRef → shows up as CreateContainerConfigError</a:t>
+            </a:r>
+            <a:endParaRPr lang="en-US" sz="2200" dirty="0"/>
+          </a:p>
+        </p:txBody>
+      </p:sp>
+      <p:sp>
+        <p:nvSpPr>
+          <p:cNvPr id="7" name="Text 5"/>
+          <p:cNvSpPr/>
+          <p:nvPr/>
+        </p:nvSpPr>
+        <p:spPr>
+          <a:xfrm>
+            <a:off x="457200" y="2825496"/>
+            <a:ext cx="11274552" cy="1252728"/>
+          </a:xfrm>
+          <a:prstGeom prst="rect">
+            <a:avLst/>
+          </a:prstGeom>
+          <a:noFill/>
+          <a:ln/>
+        </p:spPr>
+        <p:txBody>
+          <a:bodyPr wrap="square" rtlCol="0" anchor="ctr"/>
+          <a:lstStyle/>
+          <a:p>
+            <a:pPr marL="254000" indent="-254000">
+              <a:buSzPct val="100000"/>
+              <a:buChar char="•"/>
+            </a:pPr>
+            <a:r>
+              <a:rPr lang="en-US" sz="2200" dirty="0">
+                <a:solidFill>
+                  <a:srgbClr val="0A1A1C"/>
+                </a:solidFill>
+                <a:latin typeface="Trebuchet MS" pitchFamily="34" charset="0"/>
+                <a:ea typeface="Trebuchet MS" pitchFamily="34" charset="-122"/>
+                <a:cs typeface="Trebuchet MS" pitchFamily="34" charset="-120"/>
+              </a:rPr>
+              <a:t>kubectl describe pod → the Events section is always the first move to diagnose a broken Pod</a:t>
+            </a:r>
+            <a:endParaRPr lang="en-US" sz="2200" dirty="0"/>
+          </a:p>
+        </p:txBody>
       </p:sp>
       <p:sp>
         <p:nvSpPr>
@@ -8577,24 +9029,25 @@
         </p:nvSpPr>
         <p:spPr>
           <a:xfrm>
-            <a:off x="685800" y="2167128"/>
-            <a:ext cx="10954512" cy="3822192"/>
-          </a:xfrm>
-          <a:prstGeom prst="rect">
-            <a:avLst/>
-          </a:prstGeom>
-          <a:noFill/>
-          <a:ln/>
-        </p:spPr>
-        <p:txBody>
-          <a:bodyPr wrap="square" rtlCol="0" anchor="ctr"/>
-          <a:lstStyle/>
-          <a:p>
-            <a:pPr indent="0" marL="0">
-              <a:buNone/>
-            </a:pPr>
-            <a:r>
-              <a:rPr lang="en-US" sz="2600" b="1" dirty="0">
+            <a:off x="457200" y="4078224"/>
+            <a:ext cx="11274552" cy="1252728"/>
+          </a:xfrm>
+          <a:prstGeom prst="rect">
+            <a:avLst/>
+          </a:prstGeom>
+          <a:noFill/>
+          <a:ln/>
+        </p:spPr>
+        <p:txBody>
+          <a:bodyPr wrap="square" rtlCol="0" anchor="ctr"/>
+          <a:lstStyle/>
+          <a:p>
+            <a:pPr marL="254000" indent="-254000">
+              <a:buSzPct val="100000"/>
+              <a:buChar char="•"/>
+            </a:pPr>
+            <a:r>
+              <a:rPr lang="en-US" sz="2200" dirty="0">
                 <a:solidFill>
                   <a:srgbClr val="0A1A1C"/>
                 </a:solidFill>
@@ -8602,9 +9055,49 @@
                 <a:ea typeface="Trebuchet MS" pitchFamily="34" charset="-122"/>
                 <a:cs typeface="Trebuchet MS" pitchFamily="34" charset="-120"/>
               </a:rPr>
-              <a:t>Every guarantee Kubernetes makes — self-healing, scaling, zero-downtime rollout — reduces to one idea: you declare desired state, and a control loop never stops trying to make reality match it</a:t>
-            </a:r>
-            <a:endParaRPr lang="en-US" sz="2600" dirty="0"/>
+              <a:t>Podman's Minikube driver is explicitly experimental — --driver=docker is the fallback if you hit an uncovered wall</a:t>
+            </a:r>
+            <a:endParaRPr lang="en-US" sz="2200" dirty="0"/>
+          </a:p>
+        </p:txBody>
+      </p:sp>
+      <p:sp>
+        <p:nvSpPr>
+          <p:cNvPr id="9" name="Text 7"/>
+          <p:cNvSpPr/>
+          <p:nvPr/>
+        </p:nvSpPr>
+        <p:spPr>
+          <a:xfrm>
+            <a:off x="457200" y="5330952"/>
+            <a:ext cx="11274552" cy="1252728"/>
+          </a:xfrm>
+          <a:prstGeom prst="rect">
+            <a:avLst/>
+          </a:prstGeom>
+          <a:noFill/>
+          <a:ln/>
+        </p:spPr>
+        <p:txBody>
+          <a:bodyPr wrap="square" rtlCol="0" anchor="ctr"/>
+          <a:lstStyle/>
+          <a:p>
+            <a:pPr marL="254000" indent="-254000">
+              <a:buSzPct val="100000"/>
+              <a:buChar char="•"/>
+            </a:pPr>
+            <a:r>
+              <a:rPr lang="en-US" sz="2200" dirty="0">
+                <a:solidFill>
+                  <a:srgbClr val="0A1A1C"/>
+                </a:solidFill>
+                <a:latin typeface="Trebuchet MS" pitchFamily="34" charset="0"/>
+                <a:ea typeface="Trebuchet MS" pitchFamily="34" charset="-122"/>
+                <a:cs typeface="Trebuchet MS" pitchFamily="34" charset="-120"/>
+              </a:rPr>
+              <a:t>Base64 is encoding, not encryption — don't mistake a Secret for something actually secured</a:t>
+            </a:r>
+            <a:endParaRPr lang="en-US" sz="2200" dirty="0"/>
           </a:p>
         </p:txBody>
       </p:sp>
@@ -8737,7 +9230,7 @@
                 <a:ea typeface="Arial Black" pitchFamily="34" charset="-122"/>
                 <a:cs typeface="Arial Black" pitchFamily="34" charset="-120"/>
               </a:rPr>
-              <a:t>What's Next: Open TUTORIAL.md</a:t>
+              <a:t>Key Insight</a:t>
             </a:r>
             <a:endParaRPr lang="en-US" sz="3000" dirty="0"/>
           </a:p>
@@ -8770,31 +9263,80 @@
       </p:sp>
       <p:sp>
         <p:nvSpPr>
-          <p:cNvPr id="6" name="Text 4"/>
-          <p:cNvSpPr/>
-          <p:nvPr/>
-        </p:nvSpPr>
-        <p:spPr>
-          <a:xfrm>
-            <a:off x="457200" y="1572768"/>
-            <a:ext cx="11274552" cy="1252728"/>
-          </a:xfrm>
-          <a:prstGeom prst="rect">
-            <a:avLst/>
-          </a:prstGeom>
-          <a:noFill/>
-          <a:ln/>
-        </p:spPr>
-        <p:txBody>
-          <a:bodyPr wrap="square" rtlCol="0" anchor="ctr"/>
-          <a:lstStyle/>
-          <a:p>
-            <a:pPr marL="254000" indent="-254000">
-              <a:buSzPct val="100000"/>
-              <a:buChar char="•"/>
-            </a:pPr>
-            <a:r>
-              <a:rPr lang="en-US" sz="2200" dirty="0">
+          <p:cNvPr id="6" name="Shape 4"/>
+          <p:cNvSpPr/>
+          <p:nvPr/>
+        </p:nvSpPr>
+        <p:spPr>
+          <a:xfrm>
+            <a:off x="457200" y="2029968"/>
+            <a:ext cx="11274552" cy="4096512"/>
+          </a:xfrm>
+          <a:prstGeom prst="rect">
+            <a:avLst/>
+          </a:prstGeom>
+          <a:solidFill>
+            <a:srgbClr val="B8ECF5"/>
+          </a:solidFill>
+          <a:ln w="25400">
+            <a:solidFill>
+              <a:srgbClr val="007A90"/>
+            </a:solidFill>
+            <a:prstDash val="solid"/>
+          </a:ln>
+        </p:spPr>
+      </p:sp>
+      <p:sp>
+        <p:nvSpPr>
+          <p:cNvPr id="7" name="Shape 5"/>
+          <p:cNvSpPr/>
+          <p:nvPr/>
+        </p:nvSpPr>
+        <p:spPr>
+          <a:xfrm>
+            <a:off x="457200" y="2029968"/>
+            <a:ext cx="73152" cy="4096512"/>
+          </a:xfrm>
+          <a:prstGeom prst="rect">
+            <a:avLst/>
+          </a:prstGeom>
+          <a:solidFill>
+            <a:srgbClr val="007A90"/>
+          </a:solidFill>
+          <a:ln w="12700">
+            <a:solidFill>
+              <a:srgbClr val="007A90"/>
+            </a:solidFill>
+            <a:prstDash val="solid"/>
+          </a:ln>
+        </p:spPr>
+      </p:sp>
+      <p:sp>
+        <p:nvSpPr>
+          <p:cNvPr id="8" name="Text 6"/>
+          <p:cNvSpPr/>
+          <p:nvPr/>
+        </p:nvSpPr>
+        <p:spPr>
+          <a:xfrm>
+            <a:off x="685800" y="2167128"/>
+            <a:ext cx="10954512" cy="3822192"/>
+          </a:xfrm>
+          <a:prstGeom prst="rect">
+            <a:avLst/>
+          </a:prstGeom>
+          <a:noFill/>
+          <a:ln/>
+        </p:spPr>
+        <p:txBody>
+          <a:bodyPr wrap="square" rtlCol="0" anchor="ctr"/>
+          <a:lstStyle/>
+          <a:p>
+            <a:pPr indent="0" marL="0">
+              <a:buNone/>
+            </a:pPr>
+            <a:r>
+              <a:rPr lang="en-US" sz="2600" b="1" dirty="0">
                 <a:solidFill>
                   <a:srgbClr val="0A1A1C"/>
                 </a:solidFill>
@@ -8802,129 +9344,9 @@
                 <a:ea typeface="Trebuchet MS" pitchFamily="34" charset="-122"/>
                 <a:cs typeface="Trebuchet MS" pitchFamily="34" charset="-120"/>
               </a:rPr>
-              <a:t>This deck was the map — the territory starts now</a:t>
-            </a:r>
-            <a:endParaRPr lang="en-US" sz="2200" dirty="0"/>
-          </a:p>
-        </p:txBody>
-      </p:sp>
-      <p:sp>
-        <p:nvSpPr>
-          <p:cNvPr id="7" name="Text 5"/>
-          <p:cNvSpPr/>
-          <p:nvPr/>
-        </p:nvSpPr>
-        <p:spPr>
-          <a:xfrm>
-            <a:off x="457200" y="2825496"/>
-            <a:ext cx="11274552" cy="1252728"/>
-          </a:xfrm>
-          <a:prstGeom prst="rect">
-            <a:avLst/>
-          </a:prstGeom>
-          <a:noFill/>
-          <a:ln/>
-        </p:spPr>
-        <p:txBody>
-          <a:bodyPr wrap="square" rtlCol="0" anchor="ctr"/>
-          <a:lstStyle/>
-          <a:p>
-            <a:pPr marL="254000" indent="-254000">
-              <a:buSzPct val="100000"/>
-              <a:buChar char="•"/>
-            </a:pPr>
-            <a:r>
-              <a:rPr lang="en-US" sz="2200" dirty="0">
-                <a:solidFill>
-                  <a:srgbClr val="0A1A1C"/>
-                </a:solidFill>
-                <a:latin typeface="Trebuchet MS" pitchFamily="34" charset="0"/>
-                <a:ea typeface="Trebuchet MS" pitchFamily="34" charset="-122"/>
-                <a:cs typeface="Trebuchet MS" pitchFamily="34" charset="-120"/>
-              </a:rPr>
-              <a:t>Open TUTORIAL.md, start at Module 0 (Setup &amp; Orientation): install Podman, start Minikube, run your first real kubectl get nodes</a:t>
-            </a:r>
-            <a:endParaRPr lang="en-US" sz="2200" dirty="0"/>
-          </a:p>
-        </p:txBody>
-      </p:sp>
-      <p:sp>
-        <p:nvSpPr>
-          <p:cNvPr id="8" name="Text 6"/>
-          <p:cNvSpPr/>
-          <p:nvPr/>
-        </p:nvSpPr>
-        <p:spPr>
-          <a:xfrm>
-            <a:off x="457200" y="4078224"/>
-            <a:ext cx="11274552" cy="1252728"/>
-          </a:xfrm>
-          <a:prstGeom prst="rect">
-            <a:avLst/>
-          </a:prstGeom>
-          <a:noFill/>
-          <a:ln/>
-        </p:spPr>
-        <p:txBody>
-          <a:bodyPr wrap="square" rtlCol="0" anchor="ctr"/>
-          <a:lstStyle/>
-          <a:p>
-            <a:pPr marL="254000" indent="-254000">
-              <a:buSzPct val="100000"/>
-              <a:buChar char="•"/>
-            </a:pPr>
-            <a:r>
-              <a:rPr lang="en-US" sz="2200" dirty="0">
-                <a:solidFill>
-                  <a:srgbClr val="0A1A1C"/>
-                </a:solidFill>
-                <a:latin typeface="Trebuchet MS" pitchFamily="34" charset="0"/>
-                <a:ea typeface="Trebuchet MS" pitchFamily="34" charset="-122"/>
-                <a:cs typeface="Trebuchet MS" pitchFamily="34" charset="-120"/>
-              </a:rPr>
-              <a:t>Modules 1–6 build in exactly today's order: Pods → Deployments → Services → Config/Secrets → Capstone → Cleanup</a:t>
-            </a:r>
-            <a:endParaRPr lang="en-US" sz="2200" dirty="0"/>
-          </a:p>
-        </p:txBody>
-      </p:sp>
-      <p:sp>
-        <p:nvSpPr>
-          <p:cNvPr id="9" name="Text 7"/>
-          <p:cNvSpPr/>
-          <p:nvPr/>
-        </p:nvSpPr>
-        <p:spPr>
-          <a:xfrm>
-            <a:off x="457200" y="5330952"/>
-            <a:ext cx="11274552" cy="1252728"/>
-          </a:xfrm>
-          <a:prstGeom prst="rect">
-            <a:avLst/>
-          </a:prstGeom>
-          <a:noFill/>
-          <a:ln/>
-        </p:spPr>
-        <p:txBody>
-          <a:bodyPr wrap="square" rtlCol="0" anchor="ctr"/>
-          <a:lstStyle/>
-          <a:p>
-            <a:pPr marL="254000" indent="-254000">
-              <a:buSzPct val="100000"/>
-              <a:buChar char="•"/>
-            </a:pPr>
-            <a:r>
-              <a:rPr lang="en-US" sz="2200" dirty="0">
-                <a:solidFill>
-                  <a:srgbClr val="0A1A1C"/>
-                </a:solidFill>
-                <a:latin typeface="Trebuchet MS" pitchFamily="34" charset="0"/>
-                <a:ea typeface="Trebuchet MS" pitchFamily="34" charset="-122"/>
-                <a:cs typeface="Trebuchet MS" pitchFamily="34" charset="-120"/>
-              </a:rPr>
-              <a:t>docs/kubernetes-fundamentals-notes.md has the CKA/CKAD-style deeper reference once a concept clicks</a:t>
-            </a:r>
-            <a:endParaRPr lang="en-US" sz="2200" dirty="0"/>
+              <a:t>Every guarantee Kubernetes makes — self-healing, scaling, zero-downtime rollout — reduces to one idea: you declare desired state, and a control loop never stops trying to make reality match it</a:t>
+            </a:r>
+            <a:endParaRPr lang="en-US" sz="2600" dirty="0"/>
           </a:p>
         </p:txBody>
       </p:sp>
@@ -8939,6 +9361,326 @@
 <file path=ppt/slides/slide22.xml><?xml version="1.0" encoding="utf-8"?>
 <p:sld xmlns:a="http://schemas.openxmlformats.org/drawingml/2006/main" xmlns:r="http://schemas.openxmlformats.org/officeDocument/2006/relationships" xmlns:p="http://schemas.openxmlformats.org/presentationml/2006/main">
   <p:cSld name="Slide 22">
+    <p:bg>
+      <p:bgPr>
+        <a:solidFill>
+          <a:srgbClr val="EAFCFF"/>
+        </a:solidFill>
+      </p:bgPr>
+    </p:bg>
+    <p:spTree>
+      <p:nvGrpSpPr>
+        <p:cNvPr id="1" name=""/>
+        <p:cNvGrpSpPr/>
+        <p:nvPr/>
+      </p:nvGrpSpPr>
+      <p:grpSpPr>
+        <a:xfrm>
+          <a:off x="0" y="0"/>
+          <a:ext cx="0" cy="0"/>
+          <a:chOff x="0" y="0"/>
+          <a:chExt cx="0" cy="0"/>
+        </a:xfrm>
+      </p:grpSpPr>
+      <p:sp>
+        <p:nvSpPr>
+          <p:cNvPr id="2" name="Shape 0"/>
+          <p:cNvSpPr/>
+          <p:nvPr/>
+        </p:nvSpPr>
+        <p:spPr>
+          <a:xfrm>
+            <a:off x="457200" y="201168"/>
+            <a:ext cx="1828800" cy="347472"/>
+          </a:xfrm>
+          <a:prstGeom prst="rect">
+            <a:avLst/>
+          </a:prstGeom>
+          <a:solidFill>
+            <a:srgbClr val="007A90"/>
+          </a:solidFill>
+          <a:ln w="9525">
+            <a:solidFill>
+              <a:srgbClr val="007A90"/>
+            </a:solidFill>
+            <a:prstDash val="solid"/>
+          </a:ln>
+        </p:spPr>
+      </p:sp>
+      <p:sp>
+        <p:nvSpPr>
+          <p:cNvPr id="3" name="Text 1"/>
+          <p:cNvSpPr/>
+          <p:nvPr/>
+        </p:nvSpPr>
+        <p:spPr>
+          <a:xfrm>
+            <a:off x="457200" y="201168"/>
+            <a:ext cx="1828800" cy="347472"/>
+          </a:xfrm>
+          <a:prstGeom prst="rect">
+            <a:avLst/>
+          </a:prstGeom>
+          <a:noFill/>
+          <a:ln/>
+        </p:spPr>
+        <p:txBody>
+          <a:bodyPr wrap="square" rtlCol="0" anchor="ctr"/>
+          <a:lstStyle/>
+          <a:p>
+            <a:pPr algn="ctr" indent="0" marL="0">
+              <a:buNone/>
+            </a:pPr>
+            <a:r>
+              <a:rPr lang="en-US" sz="1200" b="1" spc="50" kern="0" dirty="0">
+                <a:solidFill>
+                  <a:srgbClr val="FFFFFF"/>
+                </a:solidFill>
+                <a:latin typeface="Trebuchet MS" pitchFamily="34" charset="0"/>
+                <a:ea typeface="Trebuchet MS" pitchFamily="34" charset="-122"/>
+                <a:cs typeface="Trebuchet MS" pitchFamily="34" charset="-120"/>
+              </a:rPr>
+              <a:t>KUBERNETES</a:t>
+            </a:r>
+            <a:endParaRPr lang="en-US" sz="1200" dirty="0"/>
+          </a:p>
+        </p:txBody>
+      </p:sp>
+      <p:sp>
+        <p:nvSpPr>
+          <p:cNvPr id="4" name="Text 2"/>
+          <p:cNvSpPr/>
+          <p:nvPr/>
+        </p:nvSpPr>
+        <p:spPr>
+          <a:xfrm>
+            <a:off x="457200" y="658368"/>
+            <a:ext cx="11274552" cy="685800"/>
+          </a:xfrm>
+          <a:prstGeom prst="rect">
+            <a:avLst/>
+          </a:prstGeom>
+          <a:noFill/>
+          <a:ln/>
+        </p:spPr>
+        <p:txBody>
+          <a:bodyPr wrap="square" rtlCol="0" anchor="ctr"/>
+          <a:lstStyle/>
+          <a:p>
+            <a:pPr indent="0" marL="0">
+              <a:buNone/>
+            </a:pPr>
+            <a:r>
+              <a:rPr lang="en-US" sz="3000" b="1" spc="50" kern="0" dirty="0">
+                <a:solidFill>
+                  <a:srgbClr val="0A1A1C"/>
+                </a:solidFill>
+                <a:latin typeface="Arial Black" pitchFamily="34" charset="0"/>
+                <a:ea typeface="Arial Black" pitchFamily="34" charset="-122"/>
+                <a:cs typeface="Arial Black" pitchFamily="34" charset="-120"/>
+              </a:rPr>
+              <a:t>What's Next: Open TUTORIAL.md</a:t>
+            </a:r>
+            <a:endParaRPr lang="en-US" sz="3000" dirty="0"/>
+          </a:p>
+        </p:txBody>
+      </p:sp>
+      <p:sp>
+        <p:nvSpPr>
+          <p:cNvPr id="5" name="Shape 3"/>
+          <p:cNvSpPr/>
+          <p:nvPr/>
+        </p:nvSpPr>
+        <p:spPr>
+          <a:xfrm>
+            <a:off x="457200" y="1417320"/>
+            <a:ext cx="11274552" cy="27432"/>
+          </a:xfrm>
+          <a:prstGeom prst="rect">
+            <a:avLst/>
+          </a:prstGeom>
+          <a:solidFill>
+            <a:srgbClr val="007A90"/>
+          </a:solidFill>
+          <a:ln w="12700">
+            <a:solidFill>
+              <a:srgbClr val="007A90"/>
+            </a:solidFill>
+            <a:prstDash val="solid"/>
+          </a:ln>
+        </p:spPr>
+      </p:sp>
+      <p:sp>
+        <p:nvSpPr>
+          <p:cNvPr id="6" name="Text 4"/>
+          <p:cNvSpPr/>
+          <p:nvPr/>
+        </p:nvSpPr>
+        <p:spPr>
+          <a:xfrm>
+            <a:off x="457200" y="1572768"/>
+            <a:ext cx="11274552" cy="1252728"/>
+          </a:xfrm>
+          <a:prstGeom prst="rect">
+            <a:avLst/>
+          </a:prstGeom>
+          <a:noFill/>
+          <a:ln/>
+        </p:spPr>
+        <p:txBody>
+          <a:bodyPr wrap="square" rtlCol="0" anchor="ctr"/>
+          <a:lstStyle/>
+          <a:p>
+            <a:pPr marL="254000" indent="-254000">
+              <a:buSzPct val="100000"/>
+              <a:buChar char="•"/>
+            </a:pPr>
+            <a:r>
+              <a:rPr lang="en-US" sz="2200" dirty="0">
+                <a:solidFill>
+                  <a:srgbClr val="0A1A1C"/>
+                </a:solidFill>
+                <a:latin typeface="Trebuchet MS" pitchFamily="34" charset="0"/>
+                <a:ea typeface="Trebuchet MS" pitchFamily="34" charset="-122"/>
+                <a:cs typeface="Trebuchet MS" pitchFamily="34" charset="-120"/>
+              </a:rPr>
+              <a:t>This deck was the map — the territory starts now</a:t>
+            </a:r>
+            <a:endParaRPr lang="en-US" sz="2200" dirty="0"/>
+          </a:p>
+        </p:txBody>
+      </p:sp>
+      <p:sp>
+        <p:nvSpPr>
+          <p:cNvPr id="7" name="Text 5"/>
+          <p:cNvSpPr/>
+          <p:nvPr/>
+        </p:nvSpPr>
+        <p:spPr>
+          <a:xfrm>
+            <a:off x="457200" y="2825496"/>
+            <a:ext cx="11274552" cy="1252728"/>
+          </a:xfrm>
+          <a:prstGeom prst="rect">
+            <a:avLst/>
+          </a:prstGeom>
+          <a:noFill/>
+          <a:ln/>
+        </p:spPr>
+        <p:txBody>
+          <a:bodyPr wrap="square" rtlCol="0" anchor="ctr"/>
+          <a:lstStyle/>
+          <a:p>
+            <a:pPr marL="254000" indent="-254000">
+              <a:buSzPct val="100000"/>
+              <a:buChar char="•"/>
+            </a:pPr>
+            <a:r>
+              <a:rPr lang="en-US" sz="2200" dirty="0">
+                <a:solidFill>
+                  <a:srgbClr val="0A1A1C"/>
+                </a:solidFill>
+                <a:latin typeface="Trebuchet MS" pitchFamily="34" charset="0"/>
+                <a:ea typeface="Trebuchet MS" pitchFamily="34" charset="-122"/>
+                <a:cs typeface="Trebuchet MS" pitchFamily="34" charset="-120"/>
+              </a:rPr>
+              <a:t>Open TUTORIAL.md, start at Module 0 (Setup &amp; Orientation): install Podman, start Minikube, run your first real kubectl get nodes</a:t>
+            </a:r>
+            <a:endParaRPr lang="en-US" sz="2200" dirty="0"/>
+          </a:p>
+        </p:txBody>
+      </p:sp>
+      <p:sp>
+        <p:nvSpPr>
+          <p:cNvPr id="8" name="Text 6"/>
+          <p:cNvSpPr/>
+          <p:nvPr/>
+        </p:nvSpPr>
+        <p:spPr>
+          <a:xfrm>
+            <a:off x="457200" y="4078224"/>
+            <a:ext cx="11274552" cy="1252728"/>
+          </a:xfrm>
+          <a:prstGeom prst="rect">
+            <a:avLst/>
+          </a:prstGeom>
+          <a:noFill/>
+          <a:ln/>
+        </p:spPr>
+        <p:txBody>
+          <a:bodyPr wrap="square" rtlCol="0" anchor="ctr"/>
+          <a:lstStyle/>
+          <a:p>
+            <a:pPr marL="254000" indent="-254000">
+              <a:buSzPct val="100000"/>
+              <a:buChar char="•"/>
+            </a:pPr>
+            <a:r>
+              <a:rPr lang="en-US" sz="2200" dirty="0">
+                <a:solidFill>
+                  <a:srgbClr val="0A1A1C"/>
+                </a:solidFill>
+                <a:latin typeface="Trebuchet MS" pitchFamily="34" charset="0"/>
+                <a:ea typeface="Trebuchet MS" pitchFamily="34" charset="-122"/>
+                <a:cs typeface="Trebuchet MS" pitchFamily="34" charset="-120"/>
+              </a:rPr>
+              <a:t>Modules 1–6 build in exactly today's order: Pods → Deployments → Services → Config/Secrets → Capstone → Cleanup</a:t>
+            </a:r>
+            <a:endParaRPr lang="en-US" sz="2200" dirty="0"/>
+          </a:p>
+        </p:txBody>
+      </p:sp>
+      <p:sp>
+        <p:nvSpPr>
+          <p:cNvPr id="9" name="Text 7"/>
+          <p:cNvSpPr/>
+          <p:nvPr/>
+        </p:nvSpPr>
+        <p:spPr>
+          <a:xfrm>
+            <a:off x="457200" y="5330952"/>
+            <a:ext cx="11274552" cy="1252728"/>
+          </a:xfrm>
+          <a:prstGeom prst="rect">
+            <a:avLst/>
+          </a:prstGeom>
+          <a:noFill/>
+          <a:ln/>
+        </p:spPr>
+        <p:txBody>
+          <a:bodyPr wrap="square" rtlCol="0" anchor="ctr"/>
+          <a:lstStyle/>
+          <a:p>
+            <a:pPr marL="254000" indent="-254000">
+              <a:buSzPct val="100000"/>
+              <a:buChar char="•"/>
+            </a:pPr>
+            <a:r>
+              <a:rPr lang="en-US" sz="2200" dirty="0">
+                <a:solidFill>
+                  <a:srgbClr val="0A1A1C"/>
+                </a:solidFill>
+                <a:latin typeface="Trebuchet MS" pitchFamily="34" charset="0"/>
+                <a:ea typeface="Trebuchet MS" pitchFamily="34" charset="-122"/>
+                <a:cs typeface="Trebuchet MS" pitchFamily="34" charset="-120"/>
+              </a:rPr>
+              <a:t>docs/kubernetes-fundamentals-notes.md has the CKA/CKAD-style deeper reference once a concept clicks</a:t>
+            </a:r>
+            <a:endParaRPr lang="en-US" sz="2200" dirty="0"/>
+          </a:p>
+        </p:txBody>
+      </p:sp>
+    </p:spTree>
+  </p:cSld>
+  <p:clrMapOvr>
+    <a:masterClrMapping/>
+  </p:clrMapOvr>
+</p:sld>
+</file>
+
+<file path=ppt/slides/slide23.xml><?xml version="1.0" encoding="utf-8"?>
+<p:sld xmlns:a="http://schemas.openxmlformats.org/drawingml/2006/main" xmlns:r="http://schemas.openxmlformats.org/officeDocument/2006/relationships" xmlns:p="http://schemas.openxmlformats.org/presentationml/2006/main">
+  <p:cSld name="Slide 23">
     <p:bg>
       <p:bgPr>
         <a:solidFill>

</xml_diff>

<commit_message>
Clarify why deleting the Pod matters relative to pod.yaml
The delete/get experiment showed the commands and result but never
explained what relationship it was actually testing. Make explicit
that kubectl delete only removes the live object in the cluster — it
never touches, reads, or invalidates pod.yaml on disk. A file and a
cluster object are two separate things, linked only for the instant
apply runs. That's the actual thing the experiment proves.

Co-Authored-By: Claude Sonnet 5 <noreply@anthropic.com>
</commit_message>
<xml_diff>
--- a/docs/presentations/KubernetesFundamentals/KubernetesFundamentals.pptx
+++ b/docs/presentations/KubernetesFundamentals/KubernetesFundamentals.pptx
@@ -876,7 +876,7 @@
           <a:p>
             <a:r>
               <a:rPr lang="en-US" dirty="0"/>
-              <a:t>This is the "aha" moment of the deck for a first-time reader: run the delete experiment and watch the Pod not come back. Frame it as a problem statement, not a dead end — the breakdown of why follows immediately.</a:t>
+              <a:t>This is the "aha" moment of the deck for a first-time reader: run the delete experiment and watch the Pod not come back. Before running delete, be explicit about what it does and doesn't touch — that's the detail that makes the result land instead of feeling like a magic trick. Frame it as a problem statement, not a dead end — the breakdown of why follows immediately.</a:t>
             </a:r>
             <a:endParaRPr lang="en-US" dirty="0"/>
           </a:p>
@@ -5049,7 +5049,7 @@
               <a:buChar char="•"/>
             </a:pPr>
             <a:r>
-              <a:rPr lang="en-US" sz="1600" dirty="0">
+              <a:rPr lang="en-US" sz="1400" dirty="0">
                 <a:solidFill>
                   <a:srgbClr val="0A1A1C"/>
                 </a:solidFill>
@@ -5059,7 +5059,7 @@
               </a:rPr>
               <a:t>Smallest deployable unit — a thin wrapper around one or more containers</a:t>
             </a:r>
-            <a:endParaRPr lang="en-US" sz="1600" dirty="0"/>
+            <a:endParaRPr lang="en-US" sz="1400" dirty="0"/>
           </a:p>
         </p:txBody>
       </p:sp>
@@ -5089,7 +5089,7 @@
               <a:buChar char="•"/>
             </a:pPr>
             <a:r>
-              <a:rPr lang="en-US" sz="1600" dirty="0">
+              <a:rPr lang="en-US" sz="1400" dirty="0">
                 <a:solidFill>
                   <a:srgbClr val="0A1A1C"/>
                 </a:solidFill>
@@ -5099,7 +5099,7 @@
               </a:rPr>
               <a:t>kind: Pod is case-sensitive; lowercase pod fails outright</a:t>
             </a:r>
-            <a:endParaRPr lang="en-US" sz="1600" dirty="0"/>
+            <a:endParaRPr lang="en-US" sz="1400" dirty="0"/>
           </a:p>
         </p:txBody>
       </p:sp>
@@ -5129,7 +5129,7 @@
               <a:buChar char="•"/>
             </a:pPr>
             <a:r>
-              <a:rPr lang="en-US" sz="1600" dirty="0">
+              <a:rPr lang="en-US" sz="1400" dirty="0">
                 <a:solidFill>
                   <a:srgbClr val="0A1A1C"/>
                 </a:solidFill>
@@ -5137,9 +5137,9 @@
                 <a:ea typeface="Trebuchet MS" pitchFamily="34" charset="-122"/>
                 <a:cs typeface="Trebuchet MS" pitchFamily="34" charset="-120"/>
               </a:rPr>
-              <a:t>labels are just a tag on the object — inert until something else reads them</a:t>
-            </a:r>
-            <a:endParaRPr lang="en-US" sz="1600" dirty="0"/>
+              <a:t>The full experiment, in order: apply -f pod.yaml (creates it) → get pods (confirms Running) → delete pod hello-pod (removes the live object — not the file) → get pods again</a:t>
+            </a:r>
+            <a:endParaRPr lang="en-US" sz="1400" dirty="0"/>
           </a:p>
         </p:txBody>
       </p:sp>
@@ -5169,7 +5169,7 @@
               <a:buChar char="•"/>
             </a:pPr>
             <a:r>
-              <a:rPr lang="en-US" sz="1600" dirty="0">
+              <a:rPr lang="en-US" sz="1400" dirty="0">
                 <a:solidFill>
                   <a:srgbClr val="0A1A1C"/>
                 </a:solidFill>
@@ -5177,9 +5177,9 @@
                 <a:ea typeface="Trebuchet MS" pitchFamily="34" charset="-122"/>
                 <a:cs typeface="Trebuchet MS" pitchFamily="34" charset="-120"/>
               </a:rPr>
-              <a:t>The experiment: kubectl delete pod hello-pod → kubectl get pods → No resources found in default namespace.</a:t>
-            </a:r>
-            <a:endParaRPr lang="en-US" sz="1600" dirty="0"/>
+              <a:t>pod.yaml sits on your laptop the whole time, completely untouched by that delete — a file and a cluster object are two separate things</a:t>
+            </a:r>
+            <a:endParaRPr lang="en-US" sz="1400" dirty="0"/>
           </a:p>
         </p:txBody>
       </p:sp>
@@ -5209,7 +5209,7 @@
               <a:buChar char="•"/>
             </a:pPr>
             <a:r>
-              <a:rPr lang="en-US" sz="1600" dirty="0">
+              <a:rPr lang="en-US" sz="1400" dirty="0">
                 <a:solidFill>
                   <a:srgbClr val="0A1A1C"/>
                 </a:solidFill>
@@ -5217,9 +5217,9 @@
                 <a:ea typeface="Trebuchet MS" pitchFamily="34" charset="-122"/>
                 <a:cs typeface="Trebuchet MS" pitchFamily="34" charset="-120"/>
               </a:rPr>
-              <a:t>It does not come back, even though you defined it in pod.yaml</a:t>
-            </a:r>
-            <a:endParaRPr lang="en-US" sz="1600" dirty="0"/>
+              <a:t>Result: No resources found in default namespace. — it does not come back</a:t>
+            </a:r>
+            <a:endParaRPr lang="en-US" sz="1400" dirty="0"/>
           </a:p>
         </p:txBody>
       </p:sp>
@@ -5685,7 +5685,7 @@
         <p:spPr>
           <a:xfrm>
             <a:off x="457200" y="3218688"/>
-            <a:ext cx="11274552" cy="672998"/>
+            <a:ext cx="11274552" cy="560832"/>
           </a:xfrm>
           <a:prstGeom prst="rect">
             <a:avLst/>
@@ -5702,7 +5702,7 @@
               <a:buChar char="•"/>
             </a:pPr>
             <a:r>
-              <a:rPr lang="en-US" sz="1700" dirty="0">
+              <a:rPr lang="en-US" sz="1500" dirty="0">
                 <a:solidFill>
                   <a:srgbClr val="0A1A1C"/>
                 </a:solidFill>
@@ -5712,7 +5712,7 @@
               </a:rPr>
               <a:t>apply runs exactly once: read the file, create the Pod, exit — nothing stays behind to keep enforcing it</a:t>
             </a:r>
-            <a:endParaRPr lang="en-US" sz="1700" dirty="0"/>
+            <a:endParaRPr lang="en-US" sz="1500" dirty="0"/>
           </a:p>
         </p:txBody>
       </p:sp>
@@ -5724,8 +5724,8 @@
         </p:nvSpPr>
         <p:spPr>
           <a:xfrm>
-            <a:off x="457200" y="3891686"/>
-            <a:ext cx="11274552" cy="672998"/>
+            <a:off x="457200" y="3779520"/>
+            <a:ext cx="11274552" cy="560832"/>
           </a:xfrm>
           <a:prstGeom prst="rect">
             <a:avLst/>
@@ -5742,7 +5742,7 @@
               <a:buChar char="•"/>
             </a:pPr>
             <a:r>
-              <a:rPr lang="en-US" sz="1700" dirty="0">
+              <a:rPr lang="en-US" sz="1500" dirty="0">
                 <a:solidFill>
                   <a:srgbClr val="0A1A1C"/>
                 </a:solidFill>
@@ -5750,9 +5750,9 @@
                 <a:ea typeface="Trebuchet MS" pitchFamily="34" charset="-122"/>
                 <a:cs typeface="Trebuchet MS" pitchFamily="34" charset="-120"/>
               </a:rPr>
-              <a:t>The Pod becomes a plain record in etcd with no controller attached to it</a:t>
-            </a:r>
-            <a:endParaRPr lang="en-US" sz="1700" dirty="0"/>
+              <a:t>delete only ever removes the live object in the cluster — pod.yaml on disk is never read, touched, or invalidated by it</a:t>
+            </a:r>
+            <a:endParaRPr lang="en-US" sz="1500" dirty="0"/>
           </a:p>
         </p:txBody>
       </p:sp>
@@ -5764,8 +5764,8 @@
         </p:nvSpPr>
         <p:spPr>
           <a:xfrm>
-            <a:off x="457200" y="4564685"/>
-            <a:ext cx="11274552" cy="672998"/>
+            <a:off x="457200" y="4340352"/>
+            <a:ext cx="11274552" cy="560832"/>
           </a:xfrm>
           <a:prstGeom prst="rect">
             <a:avLst/>
@@ -5782,7 +5782,7 @@
               <a:buChar char="•"/>
             </a:pPr>
             <a:r>
-              <a:rPr lang="en-US" sz="1700" dirty="0">
+              <a:rPr lang="en-US" sz="1500" dirty="0">
                 <a:solidFill>
                   <a:srgbClr val="0A1A1C"/>
                 </a:solidFill>
@@ -5790,9 +5790,9 @@
                 <a:ea typeface="Trebuchet MS" pitchFamily="34" charset="-122"/>
                 <a:cs typeface="Trebuchet MS" pitchFamily="34" charset="-120"/>
               </a:rPr>
-              <a:t>Nothing is asking "does hello-pod still exist?" on a loop, so nothing notices when the answer becomes no</a:t>
-            </a:r>
-            <a:endParaRPr lang="en-US" sz="1700" dirty="0"/>
+              <a:t>The Pod becomes a plain record in etcd with no controller attached to it</a:t>
+            </a:r>
+            <a:endParaRPr lang="en-US" sz="1500" dirty="0"/>
           </a:p>
         </p:txBody>
       </p:sp>
@@ -5804,8 +5804,8 @@
         </p:nvSpPr>
         <p:spPr>
           <a:xfrm>
-            <a:off x="457200" y="5237683"/>
-            <a:ext cx="11274552" cy="672998"/>
+            <a:off x="457200" y="4901184"/>
+            <a:ext cx="11274552" cy="560832"/>
           </a:xfrm>
           <a:prstGeom prst="rect">
             <a:avLst/>
@@ -5822,7 +5822,7 @@
               <a:buChar char="•"/>
             </a:pPr>
             <a:r>
-              <a:rPr lang="en-US" sz="1700" dirty="0">
+              <a:rPr lang="en-US" sz="1500" dirty="0">
                 <a:solidFill>
                   <a:srgbClr val="0A1A1C"/>
                 </a:solidFill>
@@ -5830,9 +5830,9 @@
                 <a:ea typeface="Trebuchet MS" pitchFamily="34" charset="-122"/>
                 <a:cs typeface="Trebuchet MS" pitchFamily="34" charset="-120"/>
               </a:rPr>
-              <a:t>pod.yaml on your laptop only mattered at the moment you ran apply — after that it has no ongoing connection to the cluster</a:t>
-            </a:r>
-            <a:endParaRPr lang="en-US" sz="1700" dirty="0"/>
+              <a:t>Nothing is asking "does hello-pod still exist?" on a loop, so nothing notices when the answer becomes no</a:t>
+            </a:r>
+            <a:endParaRPr lang="en-US" sz="1500" dirty="0"/>
           </a:p>
         </p:txBody>
       </p:sp>
@@ -5844,8 +5844,8 @@
         </p:nvSpPr>
         <p:spPr>
           <a:xfrm>
-            <a:off x="457200" y="5910682"/>
-            <a:ext cx="11274552" cy="672998"/>
+            <a:off x="457200" y="5462016"/>
+            <a:ext cx="11274552" cy="560832"/>
           </a:xfrm>
           <a:prstGeom prst="rect">
             <a:avLst/>
@@ -5862,7 +5862,7 @@
               <a:buChar char="•"/>
             </a:pPr>
             <a:r>
-              <a:rPr lang="en-US" sz="1700" dirty="0">
+              <a:rPr lang="en-US" sz="1500" dirty="0">
                 <a:solidFill>
                   <a:srgbClr val="0A1A1C"/>
                 </a:solidFill>
@@ -5870,9 +5870,49 @@
                 <a:ea typeface="Trebuchet MS" pitchFamily="34" charset="-122"/>
                 <a:cs typeface="Trebuchet MS" pitchFamily="34" charset="-120"/>
               </a:rPr>
+              <a:t>A file and a cluster object are linked only for the instant apply runs — after that, editing or deleting one has zero effect on the other</a:t>
+            </a:r>
+            <a:endParaRPr lang="en-US" sz="1500" dirty="0"/>
+          </a:p>
+        </p:txBody>
+      </p:sp>
+      <p:sp>
+        <p:nvSpPr>
+          <p:cNvPr id="19" name="Text 17"/>
+          <p:cNvSpPr/>
+          <p:nvPr/>
+        </p:nvSpPr>
+        <p:spPr>
+          <a:xfrm>
+            <a:off x="457200" y="6022848"/>
+            <a:ext cx="11274552" cy="560832"/>
+          </a:xfrm>
+          <a:prstGeom prst="rect">
+            <a:avLst/>
+          </a:prstGeom>
+          <a:noFill/>
+          <a:ln/>
+        </p:spPr>
+        <p:txBody>
+          <a:bodyPr wrap="square" rtlCol="0" anchor="ctr"/>
+          <a:lstStyle/>
+          <a:p>
+            <a:pPr marL="254000" indent="-254000">
+              <a:buSzPct val="100000"/>
+              <a:buChar char="•"/>
+            </a:pPr>
+            <a:r>
+              <a:rPr lang="en-US" sz="1500" dirty="0">
+                <a:solidFill>
+                  <a:srgbClr val="0A1A1C"/>
+                </a:solidFill>
+                <a:latin typeface="Trebuchet MS" pitchFamily="34" charset="0"/>
+                <a:ea typeface="Trebuchet MS" pitchFamily="34" charset="-122"/>
+                <a:cs typeface="Trebuchet MS" pitchFamily="34" charset="-120"/>
+              </a:rPr>
               <a:t>Not a bug — it's the exact gap a controller is built to close, which is exactly what a Deployment adds</a:t>
             </a:r>
-            <a:endParaRPr lang="en-US" sz="1700" dirty="0"/>
+            <a:endParaRPr lang="en-US" sz="1500" dirty="0"/>
           </a:p>
         </p:txBody>
       </p:sp>

</xml_diff>